<commit_message>
Small improvements to the slides
</commit_message>
<xml_diff>
--- a/2026-09-23 LabVIEW Multithreading and VI Execution Settings (GDevCon7).pptx
+++ b/2026-09-23 LabVIEW Multithreading and VI Execution Settings (GDevCon7).pptx
@@ -5,7 +5,7 @@
     <p:sldMasterId id="2147483648" r:id="rId1"/>
   </p:sldMasterIdLst>
   <p:notesMasterIdLst>
-    <p:notesMasterId r:id="rId71"/>
+    <p:notesMasterId r:id="rId66"/>
   </p:notesMasterIdLst>
   <p:sldIdLst>
     <p:sldId id="272" r:id="rId2"/>
@@ -57,26 +57,21 @@
     <p:sldId id="316" r:id="rId48"/>
     <p:sldId id="317" r:id="rId49"/>
     <p:sldId id="320" r:id="rId50"/>
-    <p:sldId id="324" r:id="rId51"/>
-    <p:sldId id="325" r:id="rId52"/>
-    <p:sldId id="326" r:id="rId53"/>
-    <p:sldId id="327" r:id="rId54"/>
-    <p:sldId id="328" r:id="rId55"/>
-    <p:sldId id="322" r:id="rId56"/>
-    <p:sldId id="330" r:id="rId57"/>
-    <p:sldId id="331" r:id="rId58"/>
-    <p:sldId id="323" r:id="rId59"/>
-    <p:sldId id="332" r:id="rId60"/>
-    <p:sldId id="333" r:id="rId61"/>
-    <p:sldId id="334" r:id="rId62"/>
-    <p:sldId id="335" r:id="rId63"/>
-    <p:sldId id="336" r:id="rId64"/>
-    <p:sldId id="338" r:id="rId65"/>
-    <p:sldId id="337" r:id="rId66"/>
-    <p:sldId id="339" r:id="rId67"/>
-    <p:sldId id="276" r:id="rId68"/>
-    <p:sldId id="329" r:id="rId69"/>
-    <p:sldId id="271" r:id="rId70"/>
+    <p:sldId id="322" r:id="rId51"/>
+    <p:sldId id="330" r:id="rId52"/>
+    <p:sldId id="331" r:id="rId53"/>
+    <p:sldId id="323" r:id="rId54"/>
+    <p:sldId id="332" r:id="rId55"/>
+    <p:sldId id="333" r:id="rId56"/>
+    <p:sldId id="334" r:id="rId57"/>
+    <p:sldId id="335" r:id="rId58"/>
+    <p:sldId id="336" r:id="rId59"/>
+    <p:sldId id="338" r:id="rId60"/>
+    <p:sldId id="337" r:id="rId61"/>
+    <p:sldId id="339" r:id="rId62"/>
+    <p:sldId id="276" r:id="rId63"/>
+    <p:sldId id="329" r:id="rId64"/>
+    <p:sldId id="271" r:id="rId65"/>
   </p:sldIdLst>
   <p:sldSz cx="12192000" cy="6858000"/>
   <p:notesSz cx="6858000" cy="9144000"/>
@@ -7579,726 +7574,6 @@
         <p:cNvPr id="1" name="">
           <a:extLst>
             <a:ext uri="{FF2B5EF4-FFF2-40B4-BE49-F238E27FC236}">
-              <a16:creationId xmlns:a16="http://schemas.microsoft.com/office/drawing/2014/main" id="{0A561407-8420-ADEE-C999-9687BC0910BC}"/>
-            </a:ext>
-          </a:extLst>
-        </p:cNvPr>
-        <p:cNvGrpSpPr/>
-        <p:nvPr/>
-      </p:nvGrpSpPr>
-      <p:grpSpPr>
-        <a:xfrm>
-          <a:off x="0" y="0"/>
-          <a:ext cx="0" cy="0"/>
-          <a:chOff x="0" y="0"/>
-          <a:chExt cx="0" cy="0"/>
-        </a:xfrm>
-      </p:grpSpPr>
-      <p:sp>
-        <p:nvSpPr>
-          <p:cNvPr id="2" name="Slide Image Placeholder 1">
-            <a:extLst>
-              <a:ext uri="{FF2B5EF4-FFF2-40B4-BE49-F238E27FC236}">
-                <a16:creationId xmlns:a16="http://schemas.microsoft.com/office/drawing/2014/main" id="{BCFE8B57-A6E5-D2A0-C374-E38B1B762D75}"/>
-              </a:ext>
-            </a:extLst>
-          </p:cNvPr>
-          <p:cNvSpPr>
-            <a:spLocks noGrp="1" noRot="1" noChangeAspect="1"/>
-          </p:cNvSpPr>
-          <p:nvPr>
-            <p:ph type="sldImg"/>
-          </p:nvPr>
-        </p:nvSpPr>
-        <p:spPr/>
-        <p:txBody>
-          <a:bodyPr/>
-          <a:lstStyle/>
-          <a:p>
-            <a:endParaRPr lang="en-GB"/>
-          </a:p>
-        </p:txBody>
-      </p:sp>
-      <p:sp>
-        <p:nvSpPr>
-          <p:cNvPr id="3" name="Notes Placeholder 2">
-            <a:extLst>
-              <a:ext uri="{FF2B5EF4-FFF2-40B4-BE49-F238E27FC236}">
-                <a16:creationId xmlns:a16="http://schemas.microsoft.com/office/drawing/2014/main" id="{D7932321-270E-4E9A-DB47-17538D06BCA1}"/>
-              </a:ext>
-            </a:extLst>
-          </p:cNvPr>
-          <p:cNvSpPr>
-            <a:spLocks noGrp="1"/>
-          </p:cNvSpPr>
-          <p:nvPr>
-            <p:ph type="body" idx="1"/>
-          </p:nvPr>
-        </p:nvSpPr>
-        <p:spPr/>
-        <p:txBody>
-          <a:bodyPr/>
-          <a:lstStyle/>
-          <a:p>
-            <a:r>
-              <a:rPr lang="en-GB" dirty="0">
-                <a:latin typeface="Aptos" panose="020B0004020202020204" pitchFamily="34" charset="0"/>
-              </a:rPr>
-              <a:t>Let’s look at these </a:t>
-            </a:r>
-            <a:r>
-              <a:rPr lang="en-GB" dirty="0" err="1">
-                <a:latin typeface="Aptos" panose="020B0004020202020204" pitchFamily="34" charset="0"/>
-              </a:rPr>
-              <a:t>AppBuilder</a:t>
-            </a:r>
-            <a:r>
-              <a:rPr lang="en-GB" dirty="0">
-                <a:latin typeface="Aptos" panose="020B0004020202020204" pitchFamily="34" charset="0"/>
-              </a:rPr>
-              <a:t> VIs, to get a sense of how small they are and how being set to Non-</a:t>
-            </a:r>
-            <a:r>
-              <a:rPr lang="en-GB" dirty="0" err="1">
-                <a:latin typeface="Aptos" panose="020B0004020202020204" pitchFamily="34" charset="0"/>
-              </a:rPr>
-              <a:t>Reentrant</a:t>
-            </a:r>
-            <a:r>
-              <a:rPr lang="en-GB" dirty="0">
-                <a:latin typeface="Aptos" panose="020B0004020202020204" pitchFamily="34" charset="0"/>
-              </a:rPr>
-              <a:t> is simply the incorrect choice.</a:t>
-            </a:r>
-          </a:p>
-        </p:txBody>
-      </p:sp>
-      <p:sp>
-        <p:nvSpPr>
-          <p:cNvPr id="4" name="Slide Number Placeholder 3">
-            <a:extLst>
-              <a:ext uri="{FF2B5EF4-FFF2-40B4-BE49-F238E27FC236}">
-                <a16:creationId xmlns:a16="http://schemas.microsoft.com/office/drawing/2014/main" id="{4B295BEE-25DF-25D1-72FF-EDEABF2E53DD}"/>
-              </a:ext>
-            </a:extLst>
-          </p:cNvPr>
-          <p:cNvSpPr>
-            <a:spLocks noGrp="1"/>
-          </p:cNvSpPr>
-          <p:nvPr>
-            <p:ph type="sldNum" sz="quarter" idx="5"/>
-          </p:nvPr>
-        </p:nvSpPr>
-        <p:spPr/>
-        <p:txBody>
-          <a:bodyPr/>
-          <a:lstStyle/>
-          <a:p>
-            <a:fld id="{009A7612-DBC4-42FD-AF5C-03C5F90E2665}" type="slidenum">
-              <a:rPr lang="en-GB" smtClean="0"/>
-              <a:t>50</a:t>
-            </a:fld>
-            <a:endParaRPr lang="en-GB"/>
-          </a:p>
-        </p:txBody>
-      </p:sp>
-    </p:spTree>
-    <p:extLst>
-      <p:ext uri="{BB962C8B-B14F-4D97-AF65-F5344CB8AC3E}">
-        <p14:creationId xmlns:p14="http://schemas.microsoft.com/office/powerpoint/2010/main" val="3382839082"/>
-      </p:ext>
-    </p:extLst>
-  </p:cSld>
-  <p:clrMapOvr>
-    <a:masterClrMapping/>
-  </p:clrMapOvr>
-</p:notes>
-</file>
-
-<file path=ppt/notesSlides/notesSlide51.xml><?xml version="1.0" encoding="utf-8"?>
-<p:notes xmlns:a="http://schemas.openxmlformats.org/drawingml/2006/main" xmlns:r="http://schemas.openxmlformats.org/officeDocument/2006/relationships" xmlns:p="http://schemas.openxmlformats.org/presentationml/2006/main">
-  <p:cSld>
-    <p:spTree>
-      <p:nvGrpSpPr>
-        <p:cNvPr id="1" name="">
-          <a:extLst>
-            <a:ext uri="{FF2B5EF4-FFF2-40B4-BE49-F238E27FC236}">
-              <a16:creationId xmlns:a16="http://schemas.microsoft.com/office/drawing/2014/main" id="{B8EFA77B-8AB2-2AB4-1D79-BBA91B36C2B1}"/>
-            </a:ext>
-          </a:extLst>
-        </p:cNvPr>
-        <p:cNvGrpSpPr/>
-        <p:nvPr/>
-      </p:nvGrpSpPr>
-      <p:grpSpPr>
-        <a:xfrm>
-          <a:off x="0" y="0"/>
-          <a:ext cx="0" cy="0"/>
-          <a:chOff x="0" y="0"/>
-          <a:chExt cx="0" cy="0"/>
-        </a:xfrm>
-      </p:grpSpPr>
-      <p:sp>
-        <p:nvSpPr>
-          <p:cNvPr id="2" name="Slide Image Placeholder 1">
-            <a:extLst>
-              <a:ext uri="{FF2B5EF4-FFF2-40B4-BE49-F238E27FC236}">
-                <a16:creationId xmlns:a16="http://schemas.microsoft.com/office/drawing/2014/main" id="{F9D3DBB1-6392-6F7B-0A97-3120FFA2902A}"/>
-              </a:ext>
-            </a:extLst>
-          </p:cNvPr>
-          <p:cNvSpPr>
-            <a:spLocks noGrp="1" noRot="1" noChangeAspect="1"/>
-          </p:cNvSpPr>
-          <p:nvPr>
-            <p:ph type="sldImg"/>
-          </p:nvPr>
-        </p:nvSpPr>
-        <p:spPr/>
-        <p:txBody>
-          <a:bodyPr/>
-          <a:lstStyle/>
-          <a:p>
-            <a:endParaRPr lang="en-GB"/>
-          </a:p>
-        </p:txBody>
-      </p:sp>
-      <p:sp>
-        <p:nvSpPr>
-          <p:cNvPr id="3" name="Notes Placeholder 2">
-            <a:extLst>
-              <a:ext uri="{FF2B5EF4-FFF2-40B4-BE49-F238E27FC236}">
-                <a16:creationId xmlns:a16="http://schemas.microsoft.com/office/drawing/2014/main" id="{170B6C03-F645-306B-8CC4-4B2298B4814D}"/>
-              </a:ext>
-            </a:extLst>
-          </p:cNvPr>
-          <p:cNvSpPr>
-            <a:spLocks noGrp="1"/>
-          </p:cNvSpPr>
-          <p:nvPr>
-            <p:ph type="body" idx="1"/>
-          </p:nvPr>
-        </p:nvSpPr>
-        <p:spPr/>
-        <p:txBody>
-          <a:bodyPr/>
-          <a:lstStyle/>
-          <a:p>
-            <a:r>
-              <a:rPr lang="en-GB" dirty="0">
-                <a:latin typeface="Aptos" panose="020B0004020202020204" pitchFamily="34" charset="0"/>
-              </a:rPr>
-              <a:t>Let’s look at these </a:t>
-            </a:r>
-            <a:r>
-              <a:rPr lang="en-GB" dirty="0" err="1">
-                <a:latin typeface="Aptos" panose="020B0004020202020204" pitchFamily="34" charset="0"/>
-              </a:rPr>
-              <a:t>AppBuilder</a:t>
-            </a:r>
-            <a:r>
-              <a:rPr lang="en-GB" dirty="0">
-                <a:latin typeface="Aptos" panose="020B0004020202020204" pitchFamily="34" charset="0"/>
-              </a:rPr>
-              <a:t> VIs, to get a sense of how small they are and how being set to Non-</a:t>
-            </a:r>
-            <a:r>
-              <a:rPr lang="en-GB" dirty="0" err="1">
-                <a:latin typeface="Aptos" panose="020B0004020202020204" pitchFamily="34" charset="0"/>
-              </a:rPr>
-              <a:t>Reentrant</a:t>
-            </a:r>
-            <a:r>
-              <a:rPr lang="en-GB" dirty="0">
-                <a:latin typeface="Aptos" panose="020B0004020202020204" pitchFamily="34" charset="0"/>
-              </a:rPr>
-              <a:t> is simply the incorrect choice.</a:t>
-            </a:r>
-          </a:p>
-        </p:txBody>
-      </p:sp>
-      <p:sp>
-        <p:nvSpPr>
-          <p:cNvPr id="4" name="Slide Number Placeholder 3">
-            <a:extLst>
-              <a:ext uri="{FF2B5EF4-FFF2-40B4-BE49-F238E27FC236}">
-                <a16:creationId xmlns:a16="http://schemas.microsoft.com/office/drawing/2014/main" id="{020C2AC4-E0BB-6ED4-A7C4-5908775F1736}"/>
-              </a:ext>
-            </a:extLst>
-          </p:cNvPr>
-          <p:cNvSpPr>
-            <a:spLocks noGrp="1"/>
-          </p:cNvSpPr>
-          <p:nvPr>
-            <p:ph type="sldNum" sz="quarter" idx="5"/>
-          </p:nvPr>
-        </p:nvSpPr>
-        <p:spPr/>
-        <p:txBody>
-          <a:bodyPr/>
-          <a:lstStyle/>
-          <a:p>
-            <a:fld id="{009A7612-DBC4-42FD-AF5C-03C5F90E2665}" type="slidenum">
-              <a:rPr lang="en-GB" smtClean="0"/>
-              <a:t>51</a:t>
-            </a:fld>
-            <a:endParaRPr lang="en-GB"/>
-          </a:p>
-        </p:txBody>
-      </p:sp>
-    </p:spTree>
-    <p:extLst>
-      <p:ext uri="{BB962C8B-B14F-4D97-AF65-F5344CB8AC3E}">
-        <p14:creationId xmlns:p14="http://schemas.microsoft.com/office/powerpoint/2010/main" val="2512449619"/>
-      </p:ext>
-    </p:extLst>
-  </p:cSld>
-  <p:clrMapOvr>
-    <a:masterClrMapping/>
-  </p:clrMapOvr>
-</p:notes>
-</file>
-
-<file path=ppt/notesSlides/notesSlide52.xml><?xml version="1.0" encoding="utf-8"?>
-<p:notes xmlns:a="http://schemas.openxmlformats.org/drawingml/2006/main" xmlns:r="http://schemas.openxmlformats.org/officeDocument/2006/relationships" xmlns:p="http://schemas.openxmlformats.org/presentationml/2006/main">
-  <p:cSld>
-    <p:spTree>
-      <p:nvGrpSpPr>
-        <p:cNvPr id="1" name="">
-          <a:extLst>
-            <a:ext uri="{FF2B5EF4-FFF2-40B4-BE49-F238E27FC236}">
-              <a16:creationId xmlns:a16="http://schemas.microsoft.com/office/drawing/2014/main" id="{AF27EE99-0F78-19C9-6BBB-ABBA12B989A4}"/>
-            </a:ext>
-          </a:extLst>
-        </p:cNvPr>
-        <p:cNvGrpSpPr/>
-        <p:nvPr/>
-      </p:nvGrpSpPr>
-      <p:grpSpPr>
-        <a:xfrm>
-          <a:off x="0" y="0"/>
-          <a:ext cx="0" cy="0"/>
-          <a:chOff x="0" y="0"/>
-          <a:chExt cx="0" cy="0"/>
-        </a:xfrm>
-      </p:grpSpPr>
-      <p:sp>
-        <p:nvSpPr>
-          <p:cNvPr id="2" name="Slide Image Placeholder 1">
-            <a:extLst>
-              <a:ext uri="{FF2B5EF4-FFF2-40B4-BE49-F238E27FC236}">
-                <a16:creationId xmlns:a16="http://schemas.microsoft.com/office/drawing/2014/main" id="{375CFB69-F6DC-29BD-CC00-25E6362B01FD}"/>
-              </a:ext>
-            </a:extLst>
-          </p:cNvPr>
-          <p:cNvSpPr>
-            <a:spLocks noGrp="1" noRot="1" noChangeAspect="1"/>
-          </p:cNvSpPr>
-          <p:nvPr>
-            <p:ph type="sldImg"/>
-          </p:nvPr>
-        </p:nvSpPr>
-        <p:spPr/>
-        <p:txBody>
-          <a:bodyPr/>
-          <a:lstStyle/>
-          <a:p>
-            <a:endParaRPr lang="en-GB"/>
-          </a:p>
-        </p:txBody>
-      </p:sp>
-      <p:sp>
-        <p:nvSpPr>
-          <p:cNvPr id="3" name="Notes Placeholder 2">
-            <a:extLst>
-              <a:ext uri="{FF2B5EF4-FFF2-40B4-BE49-F238E27FC236}">
-                <a16:creationId xmlns:a16="http://schemas.microsoft.com/office/drawing/2014/main" id="{BD8ABE26-A139-06D0-623E-732C8B051133}"/>
-              </a:ext>
-            </a:extLst>
-          </p:cNvPr>
-          <p:cNvSpPr>
-            <a:spLocks noGrp="1"/>
-          </p:cNvSpPr>
-          <p:nvPr>
-            <p:ph type="body" idx="1"/>
-          </p:nvPr>
-        </p:nvSpPr>
-        <p:spPr/>
-        <p:txBody>
-          <a:bodyPr/>
-          <a:lstStyle/>
-          <a:p>
-            <a:r>
-              <a:rPr lang="en-GB" dirty="0">
-                <a:latin typeface="Aptos" panose="020B0004020202020204" pitchFamily="34" charset="0"/>
-              </a:rPr>
-              <a:t>Let’s look at these </a:t>
-            </a:r>
-            <a:r>
-              <a:rPr lang="en-GB" dirty="0" err="1">
-                <a:latin typeface="Aptos" panose="020B0004020202020204" pitchFamily="34" charset="0"/>
-              </a:rPr>
-              <a:t>AppBuilder</a:t>
-            </a:r>
-            <a:r>
-              <a:rPr lang="en-GB" dirty="0">
-                <a:latin typeface="Aptos" panose="020B0004020202020204" pitchFamily="34" charset="0"/>
-              </a:rPr>
-              <a:t> VIs, to get a sense of how small they are and how being set to Non-</a:t>
-            </a:r>
-            <a:r>
-              <a:rPr lang="en-GB" dirty="0" err="1">
-                <a:latin typeface="Aptos" panose="020B0004020202020204" pitchFamily="34" charset="0"/>
-              </a:rPr>
-              <a:t>Reentrant</a:t>
-            </a:r>
-            <a:r>
-              <a:rPr lang="en-GB" dirty="0">
-                <a:latin typeface="Aptos" panose="020B0004020202020204" pitchFamily="34" charset="0"/>
-              </a:rPr>
-              <a:t> is simply the incorrect choice.</a:t>
-            </a:r>
-          </a:p>
-        </p:txBody>
-      </p:sp>
-      <p:sp>
-        <p:nvSpPr>
-          <p:cNvPr id="4" name="Slide Number Placeholder 3">
-            <a:extLst>
-              <a:ext uri="{FF2B5EF4-FFF2-40B4-BE49-F238E27FC236}">
-                <a16:creationId xmlns:a16="http://schemas.microsoft.com/office/drawing/2014/main" id="{571327EB-8F2F-B30A-5127-42E0D4B8CF1B}"/>
-              </a:ext>
-            </a:extLst>
-          </p:cNvPr>
-          <p:cNvSpPr>
-            <a:spLocks noGrp="1"/>
-          </p:cNvSpPr>
-          <p:nvPr>
-            <p:ph type="sldNum" sz="quarter" idx="5"/>
-          </p:nvPr>
-        </p:nvSpPr>
-        <p:spPr/>
-        <p:txBody>
-          <a:bodyPr/>
-          <a:lstStyle/>
-          <a:p>
-            <a:fld id="{009A7612-DBC4-42FD-AF5C-03C5F90E2665}" type="slidenum">
-              <a:rPr lang="en-GB" smtClean="0"/>
-              <a:t>52</a:t>
-            </a:fld>
-            <a:endParaRPr lang="en-GB"/>
-          </a:p>
-        </p:txBody>
-      </p:sp>
-    </p:spTree>
-    <p:extLst>
-      <p:ext uri="{BB962C8B-B14F-4D97-AF65-F5344CB8AC3E}">
-        <p14:creationId xmlns:p14="http://schemas.microsoft.com/office/powerpoint/2010/main" val="2403541052"/>
-      </p:ext>
-    </p:extLst>
-  </p:cSld>
-  <p:clrMapOvr>
-    <a:masterClrMapping/>
-  </p:clrMapOvr>
-</p:notes>
-</file>
-
-<file path=ppt/notesSlides/notesSlide53.xml><?xml version="1.0" encoding="utf-8"?>
-<p:notes xmlns:a="http://schemas.openxmlformats.org/drawingml/2006/main" xmlns:r="http://schemas.openxmlformats.org/officeDocument/2006/relationships" xmlns:p="http://schemas.openxmlformats.org/presentationml/2006/main">
-  <p:cSld>
-    <p:spTree>
-      <p:nvGrpSpPr>
-        <p:cNvPr id="1" name="">
-          <a:extLst>
-            <a:ext uri="{FF2B5EF4-FFF2-40B4-BE49-F238E27FC236}">
-              <a16:creationId xmlns:a16="http://schemas.microsoft.com/office/drawing/2014/main" id="{693ED8C2-E7D1-80BC-0CB9-E5F20DAB8474}"/>
-            </a:ext>
-          </a:extLst>
-        </p:cNvPr>
-        <p:cNvGrpSpPr/>
-        <p:nvPr/>
-      </p:nvGrpSpPr>
-      <p:grpSpPr>
-        <a:xfrm>
-          <a:off x="0" y="0"/>
-          <a:ext cx="0" cy="0"/>
-          <a:chOff x="0" y="0"/>
-          <a:chExt cx="0" cy="0"/>
-        </a:xfrm>
-      </p:grpSpPr>
-      <p:sp>
-        <p:nvSpPr>
-          <p:cNvPr id="2" name="Slide Image Placeholder 1">
-            <a:extLst>
-              <a:ext uri="{FF2B5EF4-FFF2-40B4-BE49-F238E27FC236}">
-                <a16:creationId xmlns:a16="http://schemas.microsoft.com/office/drawing/2014/main" id="{26BBD02E-DF40-3E11-BF8B-CCAD15F79051}"/>
-              </a:ext>
-            </a:extLst>
-          </p:cNvPr>
-          <p:cNvSpPr>
-            <a:spLocks noGrp="1" noRot="1" noChangeAspect="1"/>
-          </p:cNvSpPr>
-          <p:nvPr>
-            <p:ph type="sldImg"/>
-          </p:nvPr>
-        </p:nvSpPr>
-        <p:spPr/>
-        <p:txBody>
-          <a:bodyPr/>
-          <a:lstStyle/>
-          <a:p>
-            <a:endParaRPr lang="en-GB"/>
-          </a:p>
-        </p:txBody>
-      </p:sp>
-      <p:sp>
-        <p:nvSpPr>
-          <p:cNvPr id="3" name="Notes Placeholder 2">
-            <a:extLst>
-              <a:ext uri="{FF2B5EF4-FFF2-40B4-BE49-F238E27FC236}">
-                <a16:creationId xmlns:a16="http://schemas.microsoft.com/office/drawing/2014/main" id="{75A5E610-6837-4232-98E3-AEC19659B0F7}"/>
-              </a:ext>
-            </a:extLst>
-          </p:cNvPr>
-          <p:cNvSpPr>
-            <a:spLocks noGrp="1"/>
-          </p:cNvSpPr>
-          <p:nvPr>
-            <p:ph type="body" idx="1"/>
-          </p:nvPr>
-        </p:nvSpPr>
-        <p:spPr/>
-        <p:txBody>
-          <a:bodyPr/>
-          <a:lstStyle/>
-          <a:p>
-            <a:r>
-              <a:rPr lang="en-GB" dirty="0">
-                <a:latin typeface="Aptos" panose="020B0004020202020204" pitchFamily="34" charset="0"/>
-              </a:rPr>
-              <a:t>Let’s look at these </a:t>
-            </a:r>
-            <a:r>
-              <a:rPr lang="en-GB" dirty="0" err="1">
-                <a:latin typeface="Aptos" panose="020B0004020202020204" pitchFamily="34" charset="0"/>
-              </a:rPr>
-              <a:t>AppBuilder</a:t>
-            </a:r>
-            <a:r>
-              <a:rPr lang="en-GB" dirty="0">
-                <a:latin typeface="Aptos" panose="020B0004020202020204" pitchFamily="34" charset="0"/>
-              </a:rPr>
-              <a:t> VIs, to get a sense of how small they are and how being set to Non-</a:t>
-            </a:r>
-            <a:r>
-              <a:rPr lang="en-GB" dirty="0" err="1">
-                <a:latin typeface="Aptos" panose="020B0004020202020204" pitchFamily="34" charset="0"/>
-              </a:rPr>
-              <a:t>Reentrant</a:t>
-            </a:r>
-            <a:r>
-              <a:rPr lang="en-GB" dirty="0">
-                <a:latin typeface="Aptos" panose="020B0004020202020204" pitchFamily="34" charset="0"/>
-              </a:rPr>
-              <a:t> is simply the incorrect choice.</a:t>
-            </a:r>
-          </a:p>
-        </p:txBody>
-      </p:sp>
-      <p:sp>
-        <p:nvSpPr>
-          <p:cNvPr id="4" name="Slide Number Placeholder 3">
-            <a:extLst>
-              <a:ext uri="{FF2B5EF4-FFF2-40B4-BE49-F238E27FC236}">
-                <a16:creationId xmlns:a16="http://schemas.microsoft.com/office/drawing/2014/main" id="{BF42BB24-D3D8-1881-69FB-DABCE2097C2C}"/>
-              </a:ext>
-            </a:extLst>
-          </p:cNvPr>
-          <p:cNvSpPr>
-            <a:spLocks noGrp="1"/>
-          </p:cNvSpPr>
-          <p:nvPr>
-            <p:ph type="sldNum" sz="quarter" idx="5"/>
-          </p:nvPr>
-        </p:nvSpPr>
-        <p:spPr/>
-        <p:txBody>
-          <a:bodyPr/>
-          <a:lstStyle/>
-          <a:p>
-            <a:fld id="{009A7612-DBC4-42FD-AF5C-03C5F90E2665}" type="slidenum">
-              <a:rPr lang="en-GB" smtClean="0"/>
-              <a:t>53</a:t>
-            </a:fld>
-            <a:endParaRPr lang="en-GB"/>
-          </a:p>
-        </p:txBody>
-      </p:sp>
-    </p:spTree>
-    <p:extLst>
-      <p:ext uri="{BB962C8B-B14F-4D97-AF65-F5344CB8AC3E}">
-        <p14:creationId xmlns:p14="http://schemas.microsoft.com/office/powerpoint/2010/main" val="1846778418"/>
-      </p:ext>
-    </p:extLst>
-  </p:cSld>
-  <p:clrMapOvr>
-    <a:masterClrMapping/>
-  </p:clrMapOvr>
-</p:notes>
-</file>
-
-<file path=ppt/notesSlides/notesSlide54.xml><?xml version="1.0" encoding="utf-8"?>
-<p:notes xmlns:a="http://schemas.openxmlformats.org/drawingml/2006/main" xmlns:r="http://schemas.openxmlformats.org/officeDocument/2006/relationships" xmlns:p="http://schemas.openxmlformats.org/presentationml/2006/main">
-  <p:cSld>
-    <p:spTree>
-      <p:nvGrpSpPr>
-        <p:cNvPr id="1" name="">
-          <a:extLst>
-            <a:ext uri="{FF2B5EF4-FFF2-40B4-BE49-F238E27FC236}">
-              <a16:creationId xmlns:a16="http://schemas.microsoft.com/office/drawing/2014/main" id="{736956FE-525F-63D3-06D7-4EE72CB7B78D}"/>
-            </a:ext>
-          </a:extLst>
-        </p:cNvPr>
-        <p:cNvGrpSpPr/>
-        <p:nvPr/>
-      </p:nvGrpSpPr>
-      <p:grpSpPr>
-        <a:xfrm>
-          <a:off x="0" y="0"/>
-          <a:ext cx="0" cy="0"/>
-          <a:chOff x="0" y="0"/>
-          <a:chExt cx="0" cy="0"/>
-        </a:xfrm>
-      </p:grpSpPr>
-      <p:sp>
-        <p:nvSpPr>
-          <p:cNvPr id="2" name="Slide Image Placeholder 1">
-            <a:extLst>
-              <a:ext uri="{FF2B5EF4-FFF2-40B4-BE49-F238E27FC236}">
-                <a16:creationId xmlns:a16="http://schemas.microsoft.com/office/drawing/2014/main" id="{971AF6E2-5296-5AF3-5E6D-DDDE9E5E311A}"/>
-              </a:ext>
-            </a:extLst>
-          </p:cNvPr>
-          <p:cNvSpPr>
-            <a:spLocks noGrp="1" noRot="1" noChangeAspect="1"/>
-          </p:cNvSpPr>
-          <p:nvPr>
-            <p:ph type="sldImg"/>
-          </p:nvPr>
-        </p:nvSpPr>
-        <p:spPr/>
-        <p:txBody>
-          <a:bodyPr/>
-          <a:lstStyle/>
-          <a:p>
-            <a:endParaRPr lang="en-GB"/>
-          </a:p>
-        </p:txBody>
-      </p:sp>
-      <p:sp>
-        <p:nvSpPr>
-          <p:cNvPr id="3" name="Notes Placeholder 2">
-            <a:extLst>
-              <a:ext uri="{FF2B5EF4-FFF2-40B4-BE49-F238E27FC236}">
-                <a16:creationId xmlns:a16="http://schemas.microsoft.com/office/drawing/2014/main" id="{4712A9D1-7069-3D9E-2C24-89251AC0B5F1}"/>
-              </a:ext>
-            </a:extLst>
-          </p:cNvPr>
-          <p:cNvSpPr>
-            <a:spLocks noGrp="1"/>
-          </p:cNvSpPr>
-          <p:nvPr>
-            <p:ph type="body" idx="1"/>
-          </p:nvPr>
-        </p:nvSpPr>
-        <p:spPr/>
-        <p:txBody>
-          <a:bodyPr/>
-          <a:lstStyle/>
-          <a:p>
-            <a:r>
-              <a:rPr lang="en-GB" dirty="0">
-                <a:latin typeface="Aptos" panose="020B0004020202020204" pitchFamily="34" charset="0"/>
-              </a:rPr>
-              <a:t>Let’s look at these </a:t>
-            </a:r>
-            <a:r>
-              <a:rPr lang="en-GB" dirty="0" err="1">
-                <a:latin typeface="Aptos" panose="020B0004020202020204" pitchFamily="34" charset="0"/>
-              </a:rPr>
-              <a:t>AppBuilder</a:t>
-            </a:r>
-            <a:r>
-              <a:rPr lang="en-GB" dirty="0">
-                <a:latin typeface="Aptos" panose="020B0004020202020204" pitchFamily="34" charset="0"/>
-              </a:rPr>
-              <a:t> VIs, to get a sense of how small they are and how being set to Non-</a:t>
-            </a:r>
-            <a:r>
-              <a:rPr lang="en-GB" dirty="0" err="1">
-                <a:latin typeface="Aptos" panose="020B0004020202020204" pitchFamily="34" charset="0"/>
-              </a:rPr>
-              <a:t>Reentrant</a:t>
-            </a:r>
-            <a:r>
-              <a:rPr lang="en-GB" dirty="0">
-                <a:latin typeface="Aptos" panose="020B0004020202020204" pitchFamily="34" charset="0"/>
-              </a:rPr>
-              <a:t> is simply the incorrect choice.</a:t>
-            </a:r>
-          </a:p>
-        </p:txBody>
-      </p:sp>
-      <p:sp>
-        <p:nvSpPr>
-          <p:cNvPr id="4" name="Slide Number Placeholder 3">
-            <a:extLst>
-              <a:ext uri="{FF2B5EF4-FFF2-40B4-BE49-F238E27FC236}">
-                <a16:creationId xmlns:a16="http://schemas.microsoft.com/office/drawing/2014/main" id="{91B07886-9DCF-F35C-AD9F-AC81E8953C24}"/>
-              </a:ext>
-            </a:extLst>
-          </p:cNvPr>
-          <p:cNvSpPr>
-            <a:spLocks noGrp="1"/>
-          </p:cNvSpPr>
-          <p:nvPr>
-            <p:ph type="sldNum" sz="quarter" idx="5"/>
-          </p:nvPr>
-        </p:nvSpPr>
-        <p:spPr/>
-        <p:txBody>
-          <a:bodyPr/>
-          <a:lstStyle/>
-          <a:p>
-            <a:fld id="{009A7612-DBC4-42FD-AF5C-03C5F90E2665}" type="slidenum">
-              <a:rPr lang="en-GB" smtClean="0"/>
-              <a:t>54</a:t>
-            </a:fld>
-            <a:endParaRPr lang="en-GB"/>
-          </a:p>
-        </p:txBody>
-      </p:sp>
-    </p:spTree>
-    <p:extLst>
-      <p:ext uri="{BB962C8B-B14F-4D97-AF65-F5344CB8AC3E}">
-        <p14:creationId xmlns:p14="http://schemas.microsoft.com/office/powerpoint/2010/main" val="4282064650"/>
-      </p:ext>
-    </p:extLst>
-  </p:cSld>
-  <p:clrMapOvr>
-    <a:masterClrMapping/>
-  </p:clrMapOvr>
-</p:notes>
-</file>
-
-<file path=ppt/notesSlides/notesSlide55.xml><?xml version="1.0" encoding="utf-8"?>
-<p:notes xmlns:a="http://schemas.openxmlformats.org/drawingml/2006/main" xmlns:r="http://schemas.openxmlformats.org/officeDocument/2006/relationships" xmlns:p="http://schemas.openxmlformats.org/presentationml/2006/main">
-  <p:cSld>
-    <p:spTree>
-      <p:nvGrpSpPr>
-        <p:cNvPr id="1" name="">
-          <a:extLst>
-            <a:ext uri="{FF2B5EF4-FFF2-40B4-BE49-F238E27FC236}">
               <a16:creationId xmlns:a16="http://schemas.microsoft.com/office/drawing/2014/main" id="{DCCE50ED-7B36-AE55-8CCA-062EB4D37A92}"/>
             </a:ext>
           </a:extLst>
@@ -8389,7 +7664,7 @@
           <a:p>
             <a:fld id="{009A7612-DBC4-42FD-AF5C-03C5F90E2665}" type="slidenum">
               <a:rPr lang="en-GB" smtClean="0"/>
-              <a:t>55</a:t>
+              <a:t>50</a:t>
             </a:fld>
             <a:endParaRPr lang="en-GB"/>
           </a:p>
@@ -8408,7 +7683,7 @@
 </p:notes>
 </file>
 
-<file path=ppt/notesSlides/notesSlide56.xml><?xml version="1.0" encoding="utf-8"?>
+<file path=ppt/notesSlides/notesSlide51.xml><?xml version="1.0" encoding="utf-8"?>
 <p:notes xmlns:a="http://schemas.openxmlformats.org/drawingml/2006/main" xmlns:r="http://schemas.openxmlformats.org/officeDocument/2006/relationships" xmlns:p="http://schemas.openxmlformats.org/presentationml/2006/main">
   <p:cSld>
     <p:spTree>
@@ -8506,7 +7781,7 @@
           <a:p>
             <a:fld id="{009A7612-DBC4-42FD-AF5C-03C5F90E2665}" type="slidenum">
               <a:rPr lang="en-GB" smtClean="0"/>
-              <a:t>56</a:t>
+              <a:t>51</a:t>
             </a:fld>
             <a:endParaRPr lang="en-GB"/>
           </a:p>
@@ -8525,7 +7800,7 @@
 </p:notes>
 </file>
 
-<file path=ppt/notesSlides/notesSlide57.xml><?xml version="1.0" encoding="utf-8"?>
+<file path=ppt/notesSlides/notesSlide52.xml><?xml version="1.0" encoding="utf-8"?>
 <p:notes xmlns:a="http://schemas.openxmlformats.org/drawingml/2006/main" xmlns:r="http://schemas.openxmlformats.org/officeDocument/2006/relationships" xmlns:p="http://schemas.openxmlformats.org/presentationml/2006/main">
   <p:cSld>
     <p:spTree>
@@ -8623,7 +7898,7 @@
           <a:p>
             <a:fld id="{009A7612-DBC4-42FD-AF5C-03C5F90E2665}" type="slidenum">
               <a:rPr lang="en-GB" smtClean="0"/>
-              <a:t>57</a:t>
+              <a:t>52</a:t>
             </a:fld>
             <a:endParaRPr lang="en-GB"/>
           </a:p>
@@ -8642,7 +7917,7 @@
 </p:notes>
 </file>
 
-<file path=ppt/notesSlides/notesSlide58.xml><?xml version="1.0" encoding="utf-8"?>
+<file path=ppt/notesSlides/notesSlide53.xml><?xml version="1.0" encoding="utf-8"?>
 <p:notes xmlns:a="http://schemas.openxmlformats.org/drawingml/2006/main" xmlns:r="http://schemas.openxmlformats.org/officeDocument/2006/relationships" xmlns:p="http://schemas.openxmlformats.org/presentationml/2006/main">
   <p:cSld>
     <p:spTree>
@@ -8743,7 +8018,7 @@
           <a:p>
             <a:fld id="{009A7612-DBC4-42FD-AF5C-03C5F90E2665}" type="slidenum">
               <a:rPr lang="en-GB" smtClean="0"/>
-              <a:t>58</a:t>
+              <a:t>53</a:t>
             </a:fld>
             <a:endParaRPr lang="en-GB"/>
           </a:p>
@@ -8762,7 +8037,7 @@
 </p:notes>
 </file>
 
-<file path=ppt/notesSlides/notesSlide59.xml><?xml version="1.0" encoding="utf-8"?>
+<file path=ppt/notesSlides/notesSlide54.xml><?xml version="1.0" encoding="utf-8"?>
 <p:notes xmlns:a="http://schemas.openxmlformats.org/drawingml/2006/main" xmlns:r="http://schemas.openxmlformats.org/officeDocument/2006/relationships" xmlns:p="http://schemas.openxmlformats.org/presentationml/2006/main">
   <p:cSld>
     <p:spTree>
@@ -8860,7 +8135,7 @@
           <a:p>
             <a:fld id="{009A7612-DBC4-42FD-AF5C-03C5F90E2665}" type="slidenum">
               <a:rPr lang="en-GB" smtClean="0"/>
-              <a:t>59</a:t>
+              <a:t>54</a:t>
             </a:fld>
             <a:endParaRPr lang="en-GB"/>
           </a:p>
@@ -8870,6 +8145,633 @@
     <p:extLst>
       <p:ext uri="{BB962C8B-B14F-4D97-AF65-F5344CB8AC3E}">
         <p14:creationId xmlns:p14="http://schemas.microsoft.com/office/powerpoint/2010/main" val="2530965314"/>
+      </p:ext>
+    </p:extLst>
+  </p:cSld>
+  <p:clrMapOvr>
+    <a:masterClrMapping/>
+  </p:clrMapOvr>
+</p:notes>
+</file>
+
+<file path=ppt/notesSlides/notesSlide55.xml><?xml version="1.0" encoding="utf-8"?>
+<p:notes xmlns:a="http://schemas.openxmlformats.org/drawingml/2006/main" xmlns:r="http://schemas.openxmlformats.org/officeDocument/2006/relationships" xmlns:p="http://schemas.openxmlformats.org/presentationml/2006/main">
+  <p:cSld>
+    <p:spTree>
+      <p:nvGrpSpPr>
+        <p:cNvPr id="1" name="">
+          <a:extLst>
+            <a:ext uri="{FF2B5EF4-FFF2-40B4-BE49-F238E27FC236}">
+              <a16:creationId xmlns:a16="http://schemas.microsoft.com/office/drawing/2014/main" id="{3DA8F9D7-4882-8F72-3EF7-8356EC4D3ED3}"/>
+            </a:ext>
+          </a:extLst>
+        </p:cNvPr>
+        <p:cNvGrpSpPr/>
+        <p:nvPr/>
+      </p:nvGrpSpPr>
+      <p:grpSpPr>
+        <a:xfrm>
+          <a:off x="0" y="0"/>
+          <a:ext cx="0" cy="0"/>
+          <a:chOff x="0" y="0"/>
+          <a:chExt cx="0" cy="0"/>
+        </a:xfrm>
+      </p:grpSpPr>
+      <p:sp>
+        <p:nvSpPr>
+          <p:cNvPr id="2" name="Slide Image Placeholder 1">
+            <a:extLst>
+              <a:ext uri="{FF2B5EF4-FFF2-40B4-BE49-F238E27FC236}">
+                <a16:creationId xmlns:a16="http://schemas.microsoft.com/office/drawing/2014/main" id="{EF6BCC49-8FA2-C448-BC1C-1F708259C665}"/>
+              </a:ext>
+            </a:extLst>
+          </p:cNvPr>
+          <p:cNvSpPr>
+            <a:spLocks noGrp="1" noRot="1" noChangeAspect="1"/>
+          </p:cNvSpPr>
+          <p:nvPr>
+            <p:ph type="sldImg"/>
+          </p:nvPr>
+        </p:nvSpPr>
+        <p:spPr/>
+        <p:txBody>
+          <a:bodyPr/>
+          <a:lstStyle/>
+          <a:p>
+            <a:endParaRPr lang="en-GB"/>
+          </a:p>
+        </p:txBody>
+      </p:sp>
+      <p:sp>
+        <p:nvSpPr>
+          <p:cNvPr id="3" name="Notes Placeholder 2">
+            <a:extLst>
+              <a:ext uri="{FF2B5EF4-FFF2-40B4-BE49-F238E27FC236}">
+                <a16:creationId xmlns:a16="http://schemas.microsoft.com/office/drawing/2014/main" id="{5AE32A84-C39D-E34C-AE7E-E4005810B977}"/>
+              </a:ext>
+            </a:extLst>
+          </p:cNvPr>
+          <p:cNvSpPr>
+            <a:spLocks noGrp="1"/>
+          </p:cNvSpPr>
+          <p:nvPr>
+            <p:ph type="body" idx="1"/>
+          </p:nvPr>
+        </p:nvSpPr>
+        <p:spPr/>
+        <p:txBody>
+          <a:bodyPr/>
+          <a:lstStyle/>
+          <a:p>
+            <a:r>
+              <a:rPr lang="en-GB" dirty="0">
+                <a:latin typeface="Aptos" panose="020B0004020202020204" pitchFamily="34" charset="0"/>
+              </a:rPr>
+              <a:t>We learned from Tony Vento’s presentation yesterday that we need to be like Alice in Wonderland and call out nonsense if we see it.</a:t>
+            </a:r>
+          </a:p>
+        </p:txBody>
+      </p:sp>
+      <p:sp>
+        <p:nvSpPr>
+          <p:cNvPr id="4" name="Slide Number Placeholder 3">
+            <a:extLst>
+              <a:ext uri="{FF2B5EF4-FFF2-40B4-BE49-F238E27FC236}">
+                <a16:creationId xmlns:a16="http://schemas.microsoft.com/office/drawing/2014/main" id="{0FC3C7AF-D556-A0C9-C38F-490575136F68}"/>
+              </a:ext>
+            </a:extLst>
+          </p:cNvPr>
+          <p:cNvSpPr>
+            <a:spLocks noGrp="1"/>
+          </p:cNvSpPr>
+          <p:nvPr>
+            <p:ph type="sldNum" sz="quarter" idx="5"/>
+          </p:nvPr>
+        </p:nvSpPr>
+        <p:spPr/>
+        <p:txBody>
+          <a:bodyPr/>
+          <a:lstStyle/>
+          <a:p>
+            <a:fld id="{009A7612-DBC4-42FD-AF5C-03C5F90E2665}" type="slidenum">
+              <a:rPr lang="en-GB" smtClean="0"/>
+              <a:t>55</a:t>
+            </a:fld>
+            <a:endParaRPr lang="en-GB"/>
+          </a:p>
+        </p:txBody>
+      </p:sp>
+    </p:spTree>
+    <p:extLst>
+      <p:ext uri="{BB962C8B-B14F-4D97-AF65-F5344CB8AC3E}">
+        <p14:creationId xmlns:p14="http://schemas.microsoft.com/office/powerpoint/2010/main" val="4013064675"/>
+      </p:ext>
+    </p:extLst>
+  </p:cSld>
+  <p:clrMapOvr>
+    <a:masterClrMapping/>
+  </p:clrMapOvr>
+</p:notes>
+</file>
+
+<file path=ppt/notesSlides/notesSlide56.xml><?xml version="1.0" encoding="utf-8"?>
+<p:notes xmlns:a="http://schemas.openxmlformats.org/drawingml/2006/main" xmlns:r="http://schemas.openxmlformats.org/officeDocument/2006/relationships" xmlns:p="http://schemas.openxmlformats.org/presentationml/2006/main">
+  <p:cSld>
+    <p:spTree>
+      <p:nvGrpSpPr>
+        <p:cNvPr id="1" name="">
+          <a:extLst>
+            <a:ext uri="{FF2B5EF4-FFF2-40B4-BE49-F238E27FC236}">
+              <a16:creationId xmlns:a16="http://schemas.microsoft.com/office/drawing/2014/main" id="{B19B9426-FE64-C9A3-29FC-EE5917A7140F}"/>
+            </a:ext>
+          </a:extLst>
+        </p:cNvPr>
+        <p:cNvGrpSpPr/>
+        <p:nvPr/>
+      </p:nvGrpSpPr>
+      <p:grpSpPr>
+        <a:xfrm>
+          <a:off x="0" y="0"/>
+          <a:ext cx="0" cy="0"/>
+          <a:chOff x="0" y="0"/>
+          <a:chExt cx="0" cy="0"/>
+        </a:xfrm>
+      </p:grpSpPr>
+      <p:sp>
+        <p:nvSpPr>
+          <p:cNvPr id="2" name="Slide Image Placeholder 1">
+            <a:extLst>
+              <a:ext uri="{FF2B5EF4-FFF2-40B4-BE49-F238E27FC236}">
+                <a16:creationId xmlns:a16="http://schemas.microsoft.com/office/drawing/2014/main" id="{437FB823-744A-695F-E76E-086FFF72981E}"/>
+              </a:ext>
+            </a:extLst>
+          </p:cNvPr>
+          <p:cNvSpPr>
+            <a:spLocks noGrp="1" noRot="1" noChangeAspect="1"/>
+          </p:cNvSpPr>
+          <p:nvPr>
+            <p:ph type="sldImg"/>
+          </p:nvPr>
+        </p:nvSpPr>
+        <p:spPr/>
+        <p:txBody>
+          <a:bodyPr/>
+          <a:lstStyle/>
+          <a:p>
+            <a:endParaRPr lang="en-GB"/>
+          </a:p>
+        </p:txBody>
+      </p:sp>
+      <p:sp>
+        <p:nvSpPr>
+          <p:cNvPr id="3" name="Notes Placeholder 2">
+            <a:extLst>
+              <a:ext uri="{FF2B5EF4-FFF2-40B4-BE49-F238E27FC236}">
+                <a16:creationId xmlns:a16="http://schemas.microsoft.com/office/drawing/2014/main" id="{C8EB1498-BAA1-1C0F-61AE-EA1CA5D3080C}"/>
+              </a:ext>
+            </a:extLst>
+          </p:cNvPr>
+          <p:cNvSpPr>
+            <a:spLocks noGrp="1"/>
+          </p:cNvSpPr>
+          <p:nvPr>
+            <p:ph type="body" idx="1"/>
+          </p:nvPr>
+        </p:nvSpPr>
+        <p:spPr/>
+        <p:txBody>
+          <a:bodyPr/>
+          <a:lstStyle/>
+          <a:p>
+            <a:r>
+              <a:rPr lang="en-GB" dirty="0">
+                <a:latin typeface="Aptos" panose="020B0004020202020204" pitchFamily="34" charset="0"/>
+              </a:rPr>
+              <a:t>Let’s discuss subroutine and inline, if time allows.</a:t>
+            </a:r>
+          </a:p>
+        </p:txBody>
+      </p:sp>
+      <p:sp>
+        <p:nvSpPr>
+          <p:cNvPr id="4" name="Slide Number Placeholder 3">
+            <a:extLst>
+              <a:ext uri="{FF2B5EF4-FFF2-40B4-BE49-F238E27FC236}">
+                <a16:creationId xmlns:a16="http://schemas.microsoft.com/office/drawing/2014/main" id="{C9EC7E8F-8E8D-B16E-889C-B66CCFA4412F}"/>
+              </a:ext>
+            </a:extLst>
+          </p:cNvPr>
+          <p:cNvSpPr>
+            <a:spLocks noGrp="1"/>
+          </p:cNvSpPr>
+          <p:nvPr>
+            <p:ph type="sldNum" sz="quarter" idx="5"/>
+          </p:nvPr>
+        </p:nvSpPr>
+        <p:spPr/>
+        <p:txBody>
+          <a:bodyPr/>
+          <a:lstStyle/>
+          <a:p>
+            <a:fld id="{009A7612-DBC4-42FD-AF5C-03C5F90E2665}" type="slidenum">
+              <a:rPr lang="en-GB" smtClean="0"/>
+              <a:t>56</a:t>
+            </a:fld>
+            <a:endParaRPr lang="en-GB"/>
+          </a:p>
+        </p:txBody>
+      </p:sp>
+    </p:spTree>
+    <p:extLst>
+      <p:ext uri="{BB962C8B-B14F-4D97-AF65-F5344CB8AC3E}">
+        <p14:creationId xmlns:p14="http://schemas.microsoft.com/office/powerpoint/2010/main" val="2053123670"/>
+      </p:ext>
+    </p:extLst>
+  </p:cSld>
+  <p:clrMapOvr>
+    <a:masterClrMapping/>
+  </p:clrMapOvr>
+</p:notes>
+</file>
+
+<file path=ppt/notesSlides/notesSlide57.xml><?xml version="1.0" encoding="utf-8"?>
+<p:notes xmlns:a="http://schemas.openxmlformats.org/drawingml/2006/main" xmlns:r="http://schemas.openxmlformats.org/officeDocument/2006/relationships" xmlns:p="http://schemas.openxmlformats.org/presentationml/2006/main">
+  <p:cSld>
+    <p:spTree>
+      <p:nvGrpSpPr>
+        <p:cNvPr id="1" name="">
+          <a:extLst>
+            <a:ext uri="{FF2B5EF4-FFF2-40B4-BE49-F238E27FC236}">
+              <a16:creationId xmlns:a16="http://schemas.microsoft.com/office/drawing/2014/main" id="{FFC6B999-C0AF-F318-35B3-448894D44D92}"/>
+            </a:ext>
+          </a:extLst>
+        </p:cNvPr>
+        <p:cNvGrpSpPr/>
+        <p:nvPr/>
+      </p:nvGrpSpPr>
+      <p:grpSpPr>
+        <a:xfrm>
+          <a:off x="0" y="0"/>
+          <a:ext cx="0" cy="0"/>
+          <a:chOff x="0" y="0"/>
+          <a:chExt cx="0" cy="0"/>
+        </a:xfrm>
+      </p:grpSpPr>
+      <p:sp>
+        <p:nvSpPr>
+          <p:cNvPr id="2" name="Slide Image Placeholder 1">
+            <a:extLst>
+              <a:ext uri="{FF2B5EF4-FFF2-40B4-BE49-F238E27FC236}">
+                <a16:creationId xmlns:a16="http://schemas.microsoft.com/office/drawing/2014/main" id="{5E8080C1-FAD7-5F0E-CE3B-7858334AAFBB}"/>
+              </a:ext>
+            </a:extLst>
+          </p:cNvPr>
+          <p:cNvSpPr>
+            <a:spLocks noGrp="1" noRot="1" noChangeAspect="1"/>
+          </p:cNvSpPr>
+          <p:nvPr>
+            <p:ph type="sldImg"/>
+          </p:nvPr>
+        </p:nvSpPr>
+        <p:spPr/>
+        <p:txBody>
+          <a:bodyPr/>
+          <a:lstStyle/>
+          <a:p>
+            <a:endParaRPr lang="en-GB"/>
+          </a:p>
+        </p:txBody>
+      </p:sp>
+      <p:sp>
+        <p:nvSpPr>
+          <p:cNvPr id="3" name="Notes Placeholder 2">
+            <a:extLst>
+              <a:ext uri="{FF2B5EF4-FFF2-40B4-BE49-F238E27FC236}">
+                <a16:creationId xmlns:a16="http://schemas.microsoft.com/office/drawing/2014/main" id="{80886377-A389-2973-66EC-040947A55F7C}"/>
+              </a:ext>
+            </a:extLst>
+          </p:cNvPr>
+          <p:cNvSpPr>
+            <a:spLocks noGrp="1"/>
+          </p:cNvSpPr>
+          <p:nvPr>
+            <p:ph type="body" idx="1"/>
+          </p:nvPr>
+        </p:nvSpPr>
+        <p:spPr/>
+        <p:txBody>
+          <a:bodyPr/>
+          <a:lstStyle/>
+          <a:p>
+            <a:r>
+              <a:rPr lang="en-GB" dirty="0">
+                <a:latin typeface="Aptos" panose="020B0004020202020204" pitchFamily="34" charset="0"/>
+              </a:rPr>
+              <a:t>Enabling subroutine on PCR VIs increases performance further. Enabling inline increases performance even further.</a:t>
+            </a:r>
+          </a:p>
+        </p:txBody>
+      </p:sp>
+      <p:sp>
+        <p:nvSpPr>
+          <p:cNvPr id="4" name="Slide Number Placeholder 3">
+            <a:extLst>
+              <a:ext uri="{FF2B5EF4-FFF2-40B4-BE49-F238E27FC236}">
+                <a16:creationId xmlns:a16="http://schemas.microsoft.com/office/drawing/2014/main" id="{BD8D22A5-17AC-889C-E0BF-595FC92CC5F2}"/>
+              </a:ext>
+            </a:extLst>
+          </p:cNvPr>
+          <p:cNvSpPr>
+            <a:spLocks noGrp="1"/>
+          </p:cNvSpPr>
+          <p:nvPr>
+            <p:ph type="sldNum" sz="quarter" idx="5"/>
+          </p:nvPr>
+        </p:nvSpPr>
+        <p:spPr/>
+        <p:txBody>
+          <a:bodyPr/>
+          <a:lstStyle/>
+          <a:p>
+            <a:fld id="{009A7612-DBC4-42FD-AF5C-03C5F90E2665}" type="slidenum">
+              <a:rPr lang="en-GB" smtClean="0"/>
+              <a:t>57</a:t>
+            </a:fld>
+            <a:endParaRPr lang="en-GB"/>
+          </a:p>
+        </p:txBody>
+      </p:sp>
+    </p:spTree>
+    <p:extLst>
+      <p:ext uri="{BB962C8B-B14F-4D97-AF65-F5344CB8AC3E}">
+        <p14:creationId xmlns:p14="http://schemas.microsoft.com/office/powerpoint/2010/main" val="288780164"/>
+      </p:ext>
+    </p:extLst>
+  </p:cSld>
+  <p:clrMapOvr>
+    <a:masterClrMapping/>
+  </p:clrMapOvr>
+</p:notes>
+</file>
+
+<file path=ppt/notesSlides/notesSlide58.xml><?xml version="1.0" encoding="utf-8"?>
+<p:notes xmlns:a="http://schemas.openxmlformats.org/drawingml/2006/main" xmlns:r="http://schemas.openxmlformats.org/officeDocument/2006/relationships" xmlns:p="http://schemas.openxmlformats.org/presentationml/2006/main">
+  <p:cSld>
+    <p:spTree>
+      <p:nvGrpSpPr>
+        <p:cNvPr id="1" name="">
+          <a:extLst>
+            <a:ext uri="{FF2B5EF4-FFF2-40B4-BE49-F238E27FC236}">
+              <a16:creationId xmlns:a16="http://schemas.microsoft.com/office/drawing/2014/main" id="{52893876-93F0-AC0D-7284-74C913BAEEDD}"/>
+            </a:ext>
+          </a:extLst>
+        </p:cNvPr>
+        <p:cNvGrpSpPr/>
+        <p:nvPr/>
+      </p:nvGrpSpPr>
+      <p:grpSpPr>
+        <a:xfrm>
+          <a:off x="0" y="0"/>
+          <a:ext cx="0" cy="0"/>
+          <a:chOff x="0" y="0"/>
+          <a:chExt cx="0" cy="0"/>
+        </a:xfrm>
+      </p:grpSpPr>
+      <p:sp>
+        <p:nvSpPr>
+          <p:cNvPr id="2" name="Slide Image Placeholder 1">
+            <a:extLst>
+              <a:ext uri="{FF2B5EF4-FFF2-40B4-BE49-F238E27FC236}">
+                <a16:creationId xmlns:a16="http://schemas.microsoft.com/office/drawing/2014/main" id="{4E5C9EB0-3496-B40A-1728-F2AE351F50B9}"/>
+              </a:ext>
+            </a:extLst>
+          </p:cNvPr>
+          <p:cNvSpPr>
+            <a:spLocks noGrp="1" noRot="1" noChangeAspect="1"/>
+          </p:cNvSpPr>
+          <p:nvPr>
+            <p:ph type="sldImg"/>
+          </p:nvPr>
+        </p:nvSpPr>
+        <p:spPr/>
+        <p:txBody>
+          <a:bodyPr/>
+          <a:lstStyle/>
+          <a:p>
+            <a:endParaRPr lang="en-GB"/>
+          </a:p>
+        </p:txBody>
+      </p:sp>
+      <p:sp>
+        <p:nvSpPr>
+          <p:cNvPr id="3" name="Notes Placeholder 2">
+            <a:extLst>
+              <a:ext uri="{FF2B5EF4-FFF2-40B4-BE49-F238E27FC236}">
+                <a16:creationId xmlns:a16="http://schemas.microsoft.com/office/drawing/2014/main" id="{4613A564-4CFA-9D6F-715D-A22A31959297}"/>
+              </a:ext>
+            </a:extLst>
+          </p:cNvPr>
+          <p:cNvSpPr>
+            <a:spLocks noGrp="1"/>
+          </p:cNvSpPr>
+          <p:nvPr>
+            <p:ph type="body" idx="1"/>
+          </p:nvPr>
+        </p:nvSpPr>
+        <p:spPr/>
+        <p:txBody>
+          <a:bodyPr/>
+          <a:lstStyle/>
+          <a:p>
+            <a:r>
+              <a:rPr lang="en-GB" dirty="0">
+                <a:latin typeface="Aptos" panose="020B0004020202020204" pitchFamily="34" charset="0"/>
+              </a:rPr>
+              <a:t>Enabling subroutine on PCR VIs increases performance further. Enabling inline increases performance even further.</a:t>
+            </a:r>
+          </a:p>
+          <a:p>
+            <a:endParaRPr lang="en-GB" dirty="0">
+              <a:latin typeface="Aptos" panose="020B0004020202020204" pitchFamily="34" charset="0"/>
+            </a:endParaRPr>
+          </a:p>
+          <a:p>
+            <a:pPr marL="0" marR="0" lvl="0" indent="0" algn="l" defTabSz="914400" rtl="0" eaLnBrk="1" fontAlgn="auto" latinLnBrk="0" hangingPunct="1">
+              <a:lnSpc>
+                <a:spcPct val="100000"/>
+              </a:lnSpc>
+              <a:spcBef>
+                <a:spcPts val="0"/>
+              </a:spcBef>
+              <a:spcAft>
+                <a:spcPts val="0"/>
+              </a:spcAft>
+              <a:buClrTx/>
+              <a:buSzTx/>
+              <a:buFontTx/>
+              <a:buNone/>
+              <a:tabLst/>
+              <a:defRPr/>
+            </a:pPr>
+            <a:r>
+              <a:rPr lang="en-GB" dirty="0">
+                <a:latin typeface="Aptos" panose="020B0004020202020204" pitchFamily="34" charset="0"/>
+              </a:rPr>
+              <a:t>By “pure” VIs we mean VIs that take one or more inputs, perform computations on those input values, and produce one or more output values. Such VIs do not read/write global variables or FGVs, do not send or receive asynchronous messages (queues, notifiers, events), do not control hardware, do not perform file I/O, do not send network messages.</a:t>
+            </a:r>
+          </a:p>
+        </p:txBody>
+      </p:sp>
+      <p:sp>
+        <p:nvSpPr>
+          <p:cNvPr id="4" name="Slide Number Placeholder 3">
+            <a:extLst>
+              <a:ext uri="{FF2B5EF4-FFF2-40B4-BE49-F238E27FC236}">
+                <a16:creationId xmlns:a16="http://schemas.microsoft.com/office/drawing/2014/main" id="{13319FEF-D032-B396-4A01-9A9910B51EEB}"/>
+              </a:ext>
+            </a:extLst>
+          </p:cNvPr>
+          <p:cNvSpPr>
+            <a:spLocks noGrp="1"/>
+          </p:cNvSpPr>
+          <p:nvPr>
+            <p:ph type="sldNum" sz="quarter" idx="5"/>
+          </p:nvPr>
+        </p:nvSpPr>
+        <p:spPr/>
+        <p:txBody>
+          <a:bodyPr/>
+          <a:lstStyle/>
+          <a:p>
+            <a:fld id="{009A7612-DBC4-42FD-AF5C-03C5F90E2665}" type="slidenum">
+              <a:rPr lang="en-GB" smtClean="0"/>
+              <a:t>58</a:t>
+            </a:fld>
+            <a:endParaRPr lang="en-GB"/>
+          </a:p>
+        </p:txBody>
+      </p:sp>
+    </p:spTree>
+    <p:extLst>
+      <p:ext uri="{BB962C8B-B14F-4D97-AF65-F5344CB8AC3E}">
+        <p14:creationId xmlns:p14="http://schemas.microsoft.com/office/powerpoint/2010/main" val="3341258854"/>
+      </p:ext>
+    </p:extLst>
+  </p:cSld>
+  <p:clrMapOvr>
+    <a:masterClrMapping/>
+  </p:clrMapOvr>
+</p:notes>
+</file>
+
+<file path=ppt/notesSlides/notesSlide59.xml><?xml version="1.0" encoding="utf-8"?>
+<p:notes xmlns:a="http://schemas.openxmlformats.org/drawingml/2006/main" xmlns:r="http://schemas.openxmlformats.org/officeDocument/2006/relationships" xmlns:p="http://schemas.openxmlformats.org/presentationml/2006/main">
+  <p:cSld>
+    <p:spTree>
+      <p:nvGrpSpPr>
+        <p:cNvPr id="1" name="">
+          <a:extLst>
+            <a:ext uri="{FF2B5EF4-FFF2-40B4-BE49-F238E27FC236}">
+              <a16:creationId xmlns:a16="http://schemas.microsoft.com/office/drawing/2014/main" id="{CE645964-1150-3D60-656F-606265D60966}"/>
+            </a:ext>
+          </a:extLst>
+        </p:cNvPr>
+        <p:cNvGrpSpPr/>
+        <p:nvPr/>
+      </p:nvGrpSpPr>
+      <p:grpSpPr>
+        <a:xfrm>
+          <a:off x="0" y="0"/>
+          <a:ext cx="0" cy="0"/>
+          <a:chOff x="0" y="0"/>
+          <a:chExt cx="0" cy="0"/>
+        </a:xfrm>
+      </p:grpSpPr>
+      <p:sp>
+        <p:nvSpPr>
+          <p:cNvPr id="2" name="Slide Image Placeholder 1">
+            <a:extLst>
+              <a:ext uri="{FF2B5EF4-FFF2-40B4-BE49-F238E27FC236}">
+                <a16:creationId xmlns:a16="http://schemas.microsoft.com/office/drawing/2014/main" id="{CDAC982A-BC44-6F2A-EF71-A69324427FFE}"/>
+              </a:ext>
+            </a:extLst>
+          </p:cNvPr>
+          <p:cNvSpPr>
+            <a:spLocks noGrp="1" noRot="1" noChangeAspect="1"/>
+          </p:cNvSpPr>
+          <p:nvPr>
+            <p:ph type="sldImg"/>
+          </p:nvPr>
+        </p:nvSpPr>
+        <p:spPr/>
+        <p:txBody>
+          <a:bodyPr/>
+          <a:lstStyle/>
+          <a:p>
+            <a:endParaRPr lang="en-GB"/>
+          </a:p>
+        </p:txBody>
+      </p:sp>
+      <p:sp>
+        <p:nvSpPr>
+          <p:cNvPr id="3" name="Notes Placeholder 2">
+            <a:extLst>
+              <a:ext uri="{FF2B5EF4-FFF2-40B4-BE49-F238E27FC236}">
+                <a16:creationId xmlns:a16="http://schemas.microsoft.com/office/drawing/2014/main" id="{34865DA5-C1E0-51BA-214A-2F88F8330533}"/>
+              </a:ext>
+            </a:extLst>
+          </p:cNvPr>
+          <p:cNvSpPr>
+            <a:spLocks noGrp="1"/>
+          </p:cNvSpPr>
+          <p:nvPr>
+            <p:ph type="body" idx="1"/>
+          </p:nvPr>
+        </p:nvSpPr>
+        <p:spPr/>
+        <p:txBody>
+          <a:bodyPr/>
+          <a:lstStyle/>
+          <a:p>
+            <a:endParaRPr lang="en-GB" dirty="0">
+              <a:latin typeface="Aptos" panose="020B0004020202020204" pitchFamily="34" charset="0"/>
+            </a:endParaRPr>
+          </a:p>
+        </p:txBody>
+      </p:sp>
+      <p:sp>
+        <p:nvSpPr>
+          <p:cNvPr id="4" name="Slide Number Placeholder 3">
+            <a:extLst>
+              <a:ext uri="{FF2B5EF4-FFF2-40B4-BE49-F238E27FC236}">
+                <a16:creationId xmlns:a16="http://schemas.microsoft.com/office/drawing/2014/main" id="{4C506286-C498-749B-3AB0-46C7A9742A72}"/>
+              </a:ext>
+            </a:extLst>
+          </p:cNvPr>
+          <p:cNvSpPr>
+            <a:spLocks noGrp="1"/>
+          </p:cNvSpPr>
+          <p:nvPr>
+            <p:ph type="sldNum" sz="quarter" idx="5"/>
+          </p:nvPr>
+        </p:nvSpPr>
+        <p:spPr/>
+        <p:txBody>
+          <a:bodyPr/>
+          <a:lstStyle/>
+          <a:p>
+            <a:fld id="{009A7612-DBC4-42FD-AF5C-03C5F90E2665}" type="slidenum">
+              <a:rPr lang="en-GB" smtClean="0"/>
+              <a:t>59</a:t>
+            </a:fld>
+            <a:endParaRPr lang="en-GB"/>
+          </a:p>
+        </p:txBody>
+      </p:sp>
+    </p:spTree>
+    <p:extLst>
+      <p:ext uri="{BB962C8B-B14F-4D97-AF65-F5344CB8AC3E}">
+        <p14:creationId xmlns:p14="http://schemas.microsoft.com/office/powerpoint/2010/main" val="3859473270"/>
       </p:ext>
     </p:extLst>
   </p:cSld>
@@ -9007,633 +8909,6 @@
         <p:cNvPr id="1" name="">
           <a:extLst>
             <a:ext uri="{FF2B5EF4-FFF2-40B4-BE49-F238E27FC236}">
-              <a16:creationId xmlns:a16="http://schemas.microsoft.com/office/drawing/2014/main" id="{3DA8F9D7-4882-8F72-3EF7-8356EC4D3ED3}"/>
-            </a:ext>
-          </a:extLst>
-        </p:cNvPr>
-        <p:cNvGrpSpPr/>
-        <p:nvPr/>
-      </p:nvGrpSpPr>
-      <p:grpSpPr>
-        <a:xfrm>
-          <a:off x="0" y="0"/>
-          <a:ext cx="0" cy="0"/>
-          <a:chOff x="0" y="0"/>
-          <a:chExt cx="0" cy="0"/>
-        </a:xfrm>
-      </p:grpSpPr>
-      <p:sp>
-        <p:nvSpPr>
-          <p:cNvPr id="2" name="Slide Image Placeholder 1">
-            <a:extLst>
-              <a:ext uri="{FF2B5EF4-FFF2-40B4-BE49-F238E27FC236}">
-                <a16:creationId xmlns:a16="http://schemas.microsoft.com/office/drawing/2014/main" id="{EF6BCC49-8FA2-C448-BC1C-1F708259C665}"/>
-              </a:ext>
-            </a:extLst>
-          </p:cNvPr>
-          <p:cNvSpPr>
-            <a:spLocks noGrp="1" noRot="1" noChangeAspect="1"/>
-          </p:cNvSpPr>
-          <p:nvPr>
-            <p:ph type="sldImg"/>
-          </p:nvPr>
-        </p:nvSpPr>
-        <p:spPr/>
-        <p:txBody>
-          <a:bodyPr/>
-          <a:lstStyle/>
-          <a:p>
-            <a:endParaRPr lang="en-GB"/>
-          </a:p>
-        </p:txBody>
-      </p:sp>
-      <p:sp>
-        <p:nvSpPr>
-          <p:cNvPr id="3" name="Notes Placeholder 2">
-            <a:extLst>
-              <a:ext uri="{FF2B5EF4-FFF2-40B4-BE49-F238E27FC236}">
-                <a16:creationId xmlns:a16="http://schemas.microsoft.com/office/drawing/2014/main" id="{5AE32A84-C39D-E34C-AE7E-E4005810B977}"/>
-              </a:ext>
-            </a:extLst>
-          </p:cNvPr>
-          <p:cNvSpPr>
-            <a:spLocks noGrp="1"/>
-          </p:cNvSpPr>
-          <p:nvPr>
-            <p:ph type="body" idx="1"/>
-          </p:nvPr>
-        </p:nvSpPr>
-        <p:spPr/>
-        <p:txBody>
-          <a:bodyPr/>
-          <a:lstStyle/>
-          <a:p>
-            <a:r>
-              <a:rPr lang="en-GB" dirty="0">
-                <a:latin typeface="Aptos" panose="020B0004020202020204" pitchFamily="34" charset="0"/>
-              </a:rPr>
-              <a:t>We learned from Tony Vento’s presentation yesterday that we need to be like Alice in Wonderland and call out nonsense if we see it.</a:t>
-            </a:r>
-          </a:p>
-        </p:txBody>
-      </p:sp>
-      <p:sp>
-        <p:nvSpPr>
-          <p:cNvPr id="4" name="Slide Number Placeholder 3">
-            <a:extLst>
-              <a:ext uri="{FF2B5EF4-FFF2-40B4-BE49-F238E27FC236}">
-                <a16:creationId xmlns:a16="http://schemas.microsoft.com/office/drawing/2014/main" id="{0FC3C7AF-D556-A0C9-C38F-490575136F68}"/>
-              </a:ext>
-            </a:extLst>
-          </p:cNvPr>
-          <p:cNvSpPr>
-            <a:spLocks noGrp="1"/>
-          </p:cNvSpPr>
-          <p:nvPr>
-            <p:ph type="sldNum" sz="quarter" idx="5"/>
-          </p:nvPr>
-        </p:nvSpPr>
-        <p:spPr/>
-        <p:txBody>
-          <a:bodyPr/>
-          <a:lstStyle/>
-          <a:p>
-            <a:fld id="{009A7612-DBC4-42FD-AF5C-03C5F90E2665}" type="slidenum">
-              <a:rPr lang="en-GB" smtClean="0"/>
-              <a:t>60</a:t>
-            </a:fld>
-            <a:endParaRPr lang="en-GB"/>
-          </a:p>
-        </p:txBody>
-      </p:sp>
-    </p:spTree>
-    <p:extLst>
-      <p:ext uri="{BB962C8B-B14F-4D97-AF65-F5344CB8AC3E}">
-        <p14:creationId xmlns:p14="http://schemas.microsoft.com/office/powerpoint/2010/main" val="4013064675"/>
-      </p:ext>
-    </p:extLst>
-  </p:cSld>
-  <p:clrMapOvr>
-    <a:masterClrMapping/>
-  </p:clrMapOvr>
-</p:notes>
-</file>
-
-<file path=ppt/notesSlides/notesSlide61.xml><?xml version="1.0" encoding="utf-8"?>
-<p:notes xmlns:a="http://schemas.openxmlformats.org/drawingml/2006/main" xmlns:r="http://schemas.openxmlformats.org/officeDocument/2006/relationships" xmlns:p="http://schemas.openxmlformats.org/presentationml/2006/main">
-  <p:cSld>
-    <p:spTree>
-      <p:nvGrpSpPr>
-        <p:cNvPr id="1" name="">
-          <a:extLst>
-            <a:ext uri="{FF2B5EF4-FFF2-40B4-BE49-F238E27FC236}">
-              <a16:creationId xmlns:a16="http://schemas.microsoft.com/office/drawing/2014/main" id="{B19B9426-FE64-C9A3-29FC-EE5917A7140F}"/>
-            </a:ext>
-          </a:extLst>
-        </p:cNvPr>
-        <p:cNvGrpSpPr/>
-        <p:nvPr/>
-      </p:nvGrpSpPr>
-      <p:grpSpPr>
-        <a:xfrm>
-          <a:off x="0" y="0"/>
-          <a:ext cx="0" cy="0"/>
-          <a:chOff x="0" y="0"/>
-          <a:chExt cx="0" cy="0"/>
-        </a:xfrm>
-      </p:grpSpPr>
-      <p:sp>
-        <p:nvSpPr>
-          <p:cNvPr id="2" name="Slide Image Placeholder 1">
-            <a:extLst>
-              <a:ext uri="{FF2B5EF4-FFF2-40B4-BE49-F238E27FC236}">
-                <a16:creationId xmlns:a16="http://schemas.microsoft.com/office/drawing/2014/main" id="{437FB823-744A-695F-E76E-086FFF72981E}"/>
-              </a:ext>
-            </a:extLst>
-          </p:cNvPr>
-          <p:cNvSpPr>
-            <a:spLocks noGrp="1" noRot="1" noChangeAspect="1"/>
-          </p:cNvSpPr>
-          <p:nvPr>
-            <p:ph type="sldImg"/>
-          </p:nvPr>
-        </p:nvSpPr>
-        <p:spPr/>
-        <p:txBody>
-          <a:bodyPr/>
-          <a:lstStyle/>
-          <a:p>
-            <a:endParaRPr lang="en-GB"/>
-          </a:p>
-        </p:txBody>
-      </p:sp>
-      <p:sp>
-        <p:nvSpPr>
-          <p:cNvPr id="3" name="Notes Placeholder 2">
-            <a:extLst>
-              <a:ext uri="{FF2B5EF4-FFF2-40B4-BE49-F238E27FC236}">
-                <a16:creationId xmlns:a16="http://schemas.microsoft.com/office/drawing/2014/main" id="{C8EB1498-BAA1-1C0F-61AE-EA1CA5D3080C}"/>
-              </a:ext>
-            </a:extLst>
-          </p:cNvPr>
-          <p:cNvSpPr>
-            <a:spLocks noGrp="1"/>
-          </p:cNvSpPr>
-          <p:nvPr>
-            <p:ph type="body" idx="1"/>
-          </p:nvPr>
-        </p:nvSpPr>
-        <p:spPr/>
-        <p:txBody>
-          <a:bodyPr/>
-          <a:lstStyle/>
-          <a:p>
-            <a:r>
-              <a:rPr lang="en-GB" dirty="0">
-                <a:latin typeface="Aptos" panose="020B0004020202020204" pitchFamily="34" charset="0"/>
-              </a:rPr>
-              <a:t>Let’s discuss subroutine and inline, if time allows.</a:t>
-            </a:r>
-          </a:p>
-        </p:txBody>
-      </p:sp>
-      <p:sp>
-        <p:nvSpPr>
-          <p:cNvPr id="4" name="Slide Number Placeholder 3">
-            <a:extLst>
-              <a:ext uri="{FF2B5EF4-FFF2-40B4-BE49-F238E27FC236}">
-                <a16:creationId xmlns:a16="http://schemas.microsoft.com/office/drawing/2014/main" id="{C9EC7E8F-8E8D-B16E-889C-B66CCFA4412F}"/>
-              </a:ext>
-            </a:extLst>
-          </p:cNvPr>
-          <p:cNvSpPr>
-            <a:spLocks noGrp="1"/>
-          </p:cNvSpPr>
-          <p:nvPr>
-            <p:ph type="sldNum" sz="quarter" idx="5"/>
-          </p:nvPr>
-        </p:nvSpPr>
-        <p:spPr/>
-        <p:txBody>
-          <a:bodyPr/>
-          <a:lstStyle/>
-          <a:p>
-            <a:fld id="{009A7612-DBC4-42FD-AF5C-03C5F90E2665}" type="slidenum">
-              <a:rPr lang="en-GB" smtClean="0"/>
-              <a:t>61</a:t>
-            </a:fld>
-            <a:endParaRPr lang="en-GB"/>
-          </a:p>
-        </p:txBody>
-      </p:sp>
-    </p:spTree>
-    <p:extLst>
-      <p:ext uri="{BB962C8B-B14F-4D97-AF65-F5344CB8AC3E}">
-        <p14:creationId xmlns:p14="http://schemas.microsoft.com/office/powerpoint/2010/main" val="2053123670"/>
-      </p:ext>
-    </p:extLst>
-  </p:cSld>
-  <p:clrMapOvr>
-    <a:masterClrMapping/>
-  </p:clrMapOvr>
-</p:notes>
-</file>
-
-<file path=ppt/notesSlides/notesSlide62.xml><?xml version="1.0" encoding="utf-8"?>
-<p:notes xmlns:a="http://schemas.openxmlformats.org/drawingml/2006/main" xmlns:r="http://schemas.openxmlformats.org/officeDocument/2006/relationships" xmlns:p="http://schemas.openxmlformats.org/presentationml/2006/main">
-  <p:cSld>
-    <p:spTree>
-      <p:nvGrpSpPr>
-        <p:cNvPr id="1" name="">
-          <a:extLst>
-            <a:ext uri="{FF2B5EF4-FFF2-40B4-BE49-F238E27FC236}">
-              <a16:creationId xmlns:a16="http://schemas.microsoft.com/office/drawing/2014/main" id="{FFC6B999-C0AF-F318-35B3-448894D44D92}"/>
-            </a:ext>
-          </a:extLst>
-        </p:cNvPr>
-        <p:cNvGrpSpPr/>
-        <p:nvPr/>
-      </p:nvGrpSpPr>
-      <p:grpSpPr>
-        <a:xfrm>
-          <a:off x="0" y="0"/>
-          <a:ext cx="0" cy="0"/>
-          <a:chOff x="0" y="0"/>
-          <a:chExt cx="0" cy="0"/>
-        </a:xfrm>
-      </p:grpSpPr>
-      <p:sp>
-        <p:nvSpPr>
-          <p:cNvPr id="2" name="Slide Image Placeholder 1">
-            <a:extLst>
-              <a:ext uri="{FF2B5EF4-FFF2-40B4-BE49-F238E27FC236}">
-                <a16:creationId xmlns:a16="http://schemas.microsoft.com/office/drawing/2014/main" id="{5E8080C1-FAD7-5F0E-CE3B-7858334AAFBB}"/>
-              </a:ext>
-            </a:extLst>
-          </p:cNvPr>
-          <p:cNvSpPr>
-            <a:spLocks noGrp="1" noRot="1" noChangeAspect="1"/>
-          </p:cNvSpPr>
-          <p:nvPr>
-            <p:ph type="sldImg"/>
-          </p:nvPr>
-        </p:nvSpPr>
-        <p:spPr/>
-        <p:txBody>
-          <a:bodyPr/>
-          <a:lstStyle/>
-          <a:p>
-            <a:endParaRPr lang="en-GB"/>
-          </a:p>
-        </p:txBody>
-      </p:sp>
-      <p:sp>
-        <p:nvSpPr>
-          <p:cNvPr id="3" name="Notes Placeholder 2">
-            <a:extLst>
-              <a:ext uri="{FF2B5EF4-FFF2-40B4-BE49-F238E27FC236}">
-                <a16:creationId xmlns:a16="http://schemas.microsoft.com/office/drawing/2014/main" id="{80886377-A389-2973-66EC-040947A55F7C}"/>
-              </a:ext>
-            </a:extLst>
-          </p:cNvPr>
-          <p:cNvSpPr>
-            <a:spLocks noGrp="1"/>
-          </p:cNvSpPr>
-          <p:nvPr>
-            <p:ph type="body" idx="1"/>
-          </p:nvPr>
-        </p:nvSpPr>
-        <p:spPr/>
-        <p:txBody>
-          <a:bodyPr/>
-          <a:lstStyle/>
-          <a:p>
-            <a:r>
-              <a:rPr lang="en-GB" dirty="0">
-                <a:latin typeface="Aptos" panose="020B0004020202020204" pitchFamily="34" charset="0"/>
-              </a:rPr>
-              <a:t>Enabling subroutine on PCR VIs increases performance further. Enabling inline increases performance even further.</a:t>
-            </a:r>
-          </a:p>
-        </p:txBody>
-      </p:sp>
-      <p:sp>
-        <p:nvSpPr>
-          <p:cNvPr id="4" name="Slide Number Placeholder 3">
-            <a:extLst>
-              <a:ext uri="{FF2B5EF4-FFF2-40B4-BE49-F238E27FC236}">
-                <a16:creationId xmlns:a16="http://schemas.microsoft.com/office/drawing/2014/main" id="{BD8D22A5-17AC-889C-E0BF-595FC92CC5F2}"/>
-              </a:ext>
-            </a:extLst>
-          </p:cNvPr>
-          <p:cNvSpPr>
-            <a:spLocks noGrp="1"/>
-          </p:cNvSpPr>
-          <p:nvPr>
-            <p:ph type="sldNum" sz="quarter" idx="5"/>
-          </p:nvPr>
-        </p:nvSpPr>
-        <p:spPr/>
-        <p:txBody>
-          <a:bodyPr/>
-          <a:lstStyle/>
-          <a:p>
-            <a:fld id="{009A7612-DBC4-42FD-AF5C-03C5F90E2665}" type="slidenum">
-              <a:rPr lang="en-GB" smtClean="0"/>
-              <a:t>62</a:t>
-            </a:fld>
-            <a:endParaRPr lang="en-GB"/>
-          </a:p>
-        </p:txBody>
-      </p:sp>
-    </p:spTree>
-    <p:extLst>
-      <p:ext uri="{BB962C8B-B14F-4D97-AF65-F5344CB8AC3E}">
-        <p14:creationId xmlns:p14="http://schemas.microsoft.com/office/powerpoint/2010/main" val="288780164"/>
-      </p:ext>
-    </p:extLst>
-  </p:cSld>
-  <p:clrMapOvr>
-    <a:masterClrMapping/>
-  </p:clrMapOvr>
-</p:notes>
-</file>
-
-<file path=ppt/notesSlides/notesSlide63.xml><?xml version="1.0" encoding="utf-8"?>
-<p:notes xmlns:a="http://schemas.openxmlformats.org/drawingml/2006/main" xmlns:r="http://schemas.openxmlformats.org/officeDocument/2006/relationships" xmlns:p="http://schemas.openxmlformats.org/presentationml/2006/main">
-  <p:cSld>
-    <p:spTree>
-      <p:nvGrpSpPr>
-        <p:cNvPr id="1" name="">
-          <a:extLst>
-            <a:ext uri="{FF2B5EF4-FFF2-40B4-BE49-F238E27FC236}">
-              <a16:creationId xmlns:a16="http://schemas.microsoft.com/office/drawing/2014/main" id="{52893876-93F0-AC0D-7284-74C913BAEEDD}"/>
-            </a:ext>
-          </a:extLst>
-        </p:cNvPr>
-        <p:cNvGrpSpPr/>
-        <p:nvPr/>
-      </p:nvGrpSpPr>
-      <p:grpSpPr>
-        <a:xfrm>
-          <a:off x="0" y="0"/>
-          <a:ext cx="0" cy="0"/>
-          <a:chOff x="0" y="0"/>
-          <a:chExt cx="0" cy="0"/>
-        </a:xfrm>
-      </p:grpSpPr>
-      <p:sp>
-        <p:nvSpPr>
-          <p:cNvPr id="2" name="Slide Image Placeholder 1">
-            <a:extLst>
-              <a:ext uri="{FF2B5EF4-FFF2-40B4-BE49-F238E27FC236}">
-                <a16:creationId xmlns:a16="http://schemas.microsoft.com/office/drawing/2014/main" id="{4E5C9EB0-3496-B40A-1728-F2AE351F50B9}"/>
-              </a:ext>
-            </a:extLst>
-          </p:cNvPr>
-          <p:cNvSpPr>
-            <a:spLocks noGrp="1" noRot="1" noChangeAspect="1"/>
-          </p:cNvSpPr>
-          <p:nvPr>
-            <p:ph type="sldImg"/>
-          </p:nvPr>
-        </p:nvSpPr>
-        <p:spPr/>
-        <p:txBody>
-          <a:bodyPr/>
-          <a:lstStyle/>
-          <a:p>
-            <a:endParaRPr lang="en-GB"/>
-          </a:p>
-        </p:txBody>
-      </p:sp>
-      <p:sp>
-        <p:nvSpPr>
-          <p:cNvPr id="3" name="Notes Placeholder 2">
-            <a:extLst>
-              <a:ext uri="{FF2B5EF4-FFF2-40B4-BE49-F238E27FC236}">
-                <a16:creationId xmlns:a16="http://schemas.microsoft.com/office/drawing/2014/main" id="{4613A564-4CFA-9D6F-715D-A22A31959297}"/>
-              </a:ext>
-            </a:extLst>
-          </p:cNvPr>
-          <p:cNvSpPr>
-            <a:spLocks noGrp="1"/>
-          </p:cNvSpPr>
-          <p:nvPr>
-            <p:ph type="body" idx="1"/>
-          </p:nvPr>
-        </p:nvSpPr>
-        <p:spPr/>
-        <p:txBody>
-          <a:bodyPr/>
-          <a:lstStyle/>
-          <a:p>
-            <a:r>
-              <a:rPr lang="en-GB" dirty="0">
-                <a:latin typeface="Aptos" panose="020B0004020202020204" pitchFamily="34" charset="0"/>
-              </a:rPr>
-              <a:t>Enabling subroutine on PCR VIs increases performance further. Enabling inline increases performance even further.</a:t>
-            </a:r>
-          </a:p>
-          <a:p>
-            <a:endParaRPr lang="en-GB" dirty="0">
-              <a:latin typeface="Aptos" panose="020B0004020202020204" pitchFamily="34" charset="0"/>
-            </a:endParaRPr>
-          </a:p>
-          <a:p>
-            <a:pPr marL="0" marR="0" lvl="0" indent="0" algn="l" defTabSz="914400" rtl="0" eaLnBrk="1" fontAlgn="auto" latinLnBrk="0" hangingPunct="1">
-              <a:lnSpc>
-                <a:spcPct val="100000"/>
-              </a:lnSpc>
-              <a:spcBef>
-                <a:spcPts val="0"/>
-              </a:spcBef>
-              <a:spcAft>
-                <a:spcPts val="0"/>
-              </a:spcAft>
-              <a:buClrTx/>
-              <a:buSzTx/>
-              <a:buFontTx/>
-              <a:buNone/>
-              <a:tabLst/>
-              <a:defRPr/>
-            </a:pPr>
-            <a:r>
-              <a:rPr lang="en-GB" dirty="0">
-                <a:latin typeface="Aptos" panose="020B0004020202020204" pitchFamily="34" charset="0"/>
-              </a:rPr>
-              <a:t>By “pure” VIs we mean VIs that take one or more inputs, perform computations on those input values, and produce one or more output values. Such VIs do not read/write global variables or FGVs, do not send or receive asynchronous messages (queues, notifiers, events), do not control hardware, do not perform file I/O, do not send network messages.</a:t>
-            </a:r>
-          </a:p>
-        </p:txBody>
-      </p:sp>
-      <p:sp>
-        <p:nvSpPr>
-          <p:cNvPr id="4" name="Slide Number Placeholder 3">
-            <a:extLst>
-              <a:ext uri="{FF2B5EF4-FFF2-40B4-BE49-F238E27FC236}">
-                <a16:creationId xmlns:a16="http://schemas.microsoft.com/office/drawing/2014/main" id="{13319FEF-D032-B396-4A01-9A9910B51EEB}"/>
-              </a:ext>
-            </a:extLst>
-          </p:cNvPr>
-          <p:cNvSpPr>
-            <a:spLocks noGrp="1"/>
-          </p:cNvSpPr>
-          <p:nvPr>
-            <p:ph type="sldNum" sz="quarter" idx="5"/>
-          </p:nvPr>
-        </p:nvSpPr>
-        <p:spPr/>
-        <p:txBody>
-          <a:bodyPr/>
-          <a:lstStyle/>
-          <a:p>
-            <a:fld id="{009A7612-DBC4-42FD-AF5C-03C5F90E2665}" type="slidenum">
-              <a:rPr lang="en-GB" smtClean="0"/>
-              <a:t>63</a:t>
-            </a:fld>
-            <a:endParaRPr lang="en-GB"/>
-          </a:p>
-        </p:txBody>
-      </p:sp>
-    </p:spTree>
-    <p:extLst>
-      <p:ext uri="{BB962C8B-B14F-4D97-AF65-F5344CB8AC3E}">
-        <p14:creationId xmlns:p14="http://schemas.microsoft.com/office/powerpoint/2010/main" val="3341258854"/>
-      </p:ext>
-    </p:extLst>
-  </p:cSld>
-  <p:clrMapOvr>
-    <a:masterClrMapping/>
-  </p:clrMapOvr>
-</p:notes>
-</file>
-
-<file path=ppt/notesSlides/notesSlide64.xml><?xml version="1.0" encoding="utf-8"?>
-<p:notes xmlns:a="http://schemas.openxmlformats.org/drawingml/2006/main" xmlns:r="http://schemas.openxmlformats.org/officeDocument/2006/relationships" xmlns:p="http://schemas.openxmlformats.org/presentationml/2006/main">
-  <p:cSld>
-    <p:spTree>
-      <p:nvGrpSpPr>
-        <p:cNvPr id="1" name="">
-          <a:extLst>
-            <a:ext uri="{FF2B5EF4-FFF2-40B4-BE49-F238E27FC236}">
-              <a16:creationId xmlns:a16="http://schemas.microsoft.com/office/drawing/2014/main" id="{CE645964-1150-3D60-656F-606265D60966}"/>
-            </a:ext>
-          </a:extLst>
-        </p:cNvPr>
-        <p:cNvGrpSpPr/>
-        <p:nvPr/>
-      </p:nvGrpSpPr>
-      <p:grpSpPr>
-        <a:xfrm>
-          <a:off x="0" y="0"/>
-          <a:ext cx="0" cy="0"/>
-          <a:chOff x="0" y="0"/>
-          <a:chExt cx="0" cy="0"/>
-        </a:xfrm>
-      </p:grpSpPr>
-      <p:sp>
-        <p:nvSpPr>
-          <p:cNvPr id="2" name="Slide Image Placeholder 1">
-            <a:extLst>
-              <a:ext uri="{FF2B5EF4-FFF2-40B4-BE49-F238E27FC236}">
-                <a16:creationId xmlns:a16="http://schemas.microsoft.com/office/drawing/2014/main" id="{CDAC982A-BC44-6F2A-EF71-A69324427FFE}"/>
-              </a:ext>
-            </a:extLst>
-          </p:cNvPr>
-          <p:cNvSpPr>
-            <a:spLocks noGrp="1" noRot="1" noChangeAspect="1"/>
-          </p:cNvSpPr>
-          <p:nvPr>
-            <p:ph type="sldImg"/>
-          </p:nvPr>
-        </p:nvSpPr>
-        <p:spPr/>
-        <p:txBody>
-          <a:bodyPr/>
-          <a:lstStyle/>
-          <a:p>
-            <a:endParaRPr lang="en-GB"/>
-          </a:p>
-        </p:txBody>
-      </p:sp>
-      <p:sp>
-        <p:nvSpPr>
-          <p:cNvPr id="3" name="Notes Placeholder 2">
-            <a:extLst>
-              <a:ext uri="{FF2B5EF4-FFF2-40B4-BE49-F238E27FC236}">
-                <a16:creationId xmlns:a16="http://schemas.microsoft.com/office/drawing/2014/main" id="{34865DA5-C1E0-51BA-214A-2F88F8330533}"/>
-              </a:ext>
-            </a:extLst>
-          </p:cNvPr>
-          <p:cNvSpPr>
-            <a:spLocks noGrp="1"/>
-          </p:cNvSpPr>
-          <p:nvPr>
-            <p:ph type="body" idx="1"/>
-          </p:nvPr>
-        </p:nvSpPr>
-        <p:spPr/>
-        <p:txBody>
-          <a:bodyPr/>
-          <a:lstStyle/>
-          <a:p>
-            <a:endParaRPr lang="en-GB" dirty="0">
-              <a:latin typeface="Aptos" panose="020B0004020202020204" pitchFamily="34" charset="0"/>
-            </a:endParaRPr>
-          </a:p>
-        </p:txBody>
-      </p:sp>
-      <p:sp>
-        <p:nvSpPr>
-          <p:cNvPr id="4" name="Slide Number Placeholder 3">
-            <a:extLst>
-              <a:ext uri="{FF2B5EF4-FFF2-40B4-BE49-F238E27FC236}">
-                <a16:creationId xmlns:a16="http://schemas.microsoft.com/office/drawing/2014/main" id="{4C506286-C498-749B-3AB0-46C7A9742A72}"/>
-              </a:ext>
-            </a:extLst>
-          </p:cNvPr>
-          <p:cNvSpPr>
-            <a:spLocks noGrp="1"/>
-          </p:cNvSpPr>
-          <p:nvPr>
-            <p:ph type="sldNum" sz="quarter" idx="5"/>
-          </p:nvPr>
-        </p:nvSpPr>
-        <p:spPr/>
-        <p:txBody>
-          <a:bodyPr/>
-          <a:lstStyle/>
-          <a:p>
-            <a:fld id="{009A7612-DBC4-42FD-AF5C-03C5F90E2665}" type="slidenum">
-              <a:rPr lang="en-GB" smtClean="0"/>
-              <a:t>64</a:t>
-            </a:fld>
-            <a:endParaRPr lang="en-GB"/>
-          </a:p>
-        </p:txBody>
-      </p:sp>
-    </p:spTree>
-    <p:extLst>
-      <p:ext uri="{BB962C8B-B14F-4D97-AF65-F5344CB8AC3E}">
-        <p14:creationId xmlns:p14="http://schemas.microsoft.com/office/powerpoint/2010/main" val="3859473270"/>
-      </p:ext>
-    </p:extLst>
-  </p:cSld>
-  <p:clrMapOvr>
-    <a:masterClrMapping/>
-  </p:clrMapOvr>
-</p:notes>
-</file>
-
-<file path=ppt/notesSlides/notesSlide65.xml><?xml version="1.0" encoding="utf-8"?>
-<p:notes xmlns:a="http://schemas.openxmlformats.org/drawingml/2006/main" xmlns:r="http://schemas.openxmlformats.org/officeDocument/2006/relationships" xmlns:p="http://schemas.openxmlformats.org/presentationml/2006/main">
-  <p:cSld>
-    <p:spTree>
-      <p:nvGrpSpPr>
-        <p:cNvPr id="1" name="">
-          <a:extLst>
-            <a:ext uri="{FF2B5EF4-FFF2-40B4-BE49-F238E27FC236}">
               <a16:creationId xmlns:a16="http://schemas.microsoft.com/office/drawing/2014/main" id="{4CEA12A6-F553-EDDD-8156-715C76427556}"/>
             </a:ext>
           </a:extLst>
@@ -9727,7 +9002,7 @@
           <a:p>
             <a:fld id="{009A7612-DBC4-42FD-AF5C-03C5F90E2665}" type="slidenum">
               <a:rPr lang="en-GB" smtClean="0"/>
-              <a:t>65</a:t>
+              <a:t>60</a:t>
             </a:fld>
             <a:endParaRPr lang="en-GB"/>
           </a:p>
@@ -9746,7 +9021,7 @@
 </p:notes>
 </file>
 
-<file path=ppt/notesSlides/notesSlide66.xml><?xml version="1.0" encoding="utf-8"?>
+<file path=ppt/notesSlides/notesSlide61.xml><?xml version="1.0" encoding="utf-8"?>
 <p:notes xmlns:a="http://schemas.openxmlformats.org/drawingml/2006/main" xmlns:r="http://schemas.openxmlformats.org/officeDocument/2006/relationships" xmlns:p="http://schemas.openxmlformats.org/presentationml/2006/main">
   <p:cSld>
     <p:spTree>
@@ -9847,7 +9122,7 @@
           <a:p>
             <a:fld id="{009A7612-DBC4-42FD-AF5C-03C5F90E2665}" type="slidenum">
               <a:rPr lang="en-GB" smtClean="0"/>
-              <a:t>66</a:t>
+              <a:t>61</a:t>
             </a:fld>
             <a:endParaRPr lang="en-GB"/>
           </a:p>
@@ -9866,7 +9141,7 @@
 </p:notes>
 </file>
 
-<file path=ppt/notesSlides/notesSlide67.xml><?xml version="1.0" encoding="utf-8"?>
+<file path=ppt/notesSlides/notesSlide62.xml><?xml version="1.0" encoding="utf-8"?>
 <p:notes xmlns:a="http://schemas.openxmlformats.org/drawingml/2006/main" xmlns:r="http://schemas.openxmlformats.org/officeDocument/2006/relationships" xmlns:p="http://schemas.openxmlformats.org/presentationml/2006/main">
   <p:cSld>
     <p:spTree>
@@ -9964,7 +9239,7 @@
           <a:p>
             <a:fld id="{009A7612-DBC4-42FD-AF5C-03C5F90E2665}" type="slidenum">
               <a:rPr lang="en-GB" smtClean="0"/>
-              <a:t>67</a:t>
+              <a:t>62</a:t>
             </a:fld>
             <a:endParaRPr lang="en-GB"/>
           </a:p>
@@ -9983,7 +9258,7 @@
 </p:notes>
 </file>
 
-<file path=ppt/notesSlides/notesSlide68.xml><?xml version="1.0" encoding="utf-8"?>
+<file path=ppt/notesSlides/notesSlide63.xml><?xml version="1.0" encoding="utf-8"?>
 <p:notes xmlns:a="http://schemas.openxmlformats.org/drawingml/2006/main" xmlns:r="http://schemas.openxmlformats.org/officeDocument/2006/relationships" xmlns:p="http://schemas.openxmlformats.org/presentationml/2006/main">
   <p:cSld>
     <p:spTree>
@@ -10081,7 +9356,7 @@
           <a:p>
             <a:fld id="{009A7612-DBC4-42FD-AF5C-03C5F90E2665}" type="slidenum">
               <a:rPr lang="en-GB" smtClean="0"/>
-              <a:t>68</a:t>
+              <a:t>63</a:t>
             </a:fld>
             <a:endParaRPr lang="en-GB"/>
           </a:p>
@@ -10100,7 +9375,7 @@
 </p:notes>
 </file>
 
-<file path=ppt/notesSlides/notesSlide69.xml><?xml version="1.0" encoding="utf-8"?>
+<file path=ppt/notesSlides/notesSlide64.xml><?xml version="1.0" encoding="utf-8"?>
 <p:notes xmlns:a="http://schemas.openxmlformats.org/drawingml/2006/main" xmlns:r="http://schemas.openxmlformats.org/officeDocument/2006/relationships" xmlns:p="http://schemas.openxmlformats.org/presentationml/2006/main">
   <p:cSld>
     <p:spTree>
@@ -10177,7 +9452,7 @@
           <a:p>
             <a:fld id="{009A7612-DBC4-42FD-AF5C-03C5F90E2665}" type="slidenum">
               <a:rPr lang="en-GB" smtClean="0"/>
-              <a:t>69</a:t>
+              <a:t>64</a:t>
             </a:fld>
             <a:endParaRPr lang="en-GB"/>
           </a:p>
@@ -25347,7 +24622,7 @@
                 </a:solidFill>
                 <a:latin typeface="Aptos" panose="020B0004020202020204" pitchFamily="34" charset="0"/>
               </a:rPr>
-              <a:t>Let a codebase contain 100 call sites of a VI. Let the codebase function in such a way that a maximum of 3 call sites execute at the same time. All 100 call sites are used, but a maximum of 3 are used at the same time. If the VI is set to PCR, 100 instances will exist in memory. If the VI is set to SCR, a maximum of 3 instances will exist in memory. The 3 instances are sufficient to service all call sites while avoiding collisions. Thus, a reduction of 97 memory instances.</a:t>
+              <a:t>Let a codebase contain 20 call sites of a VI. Let the codebase function in such a way that a maximum of 3 call sites execute at the same time. All 20 call sites are used, but a maximum of 3 are used at the same time. If the VI is set to PCR, 100 instances will exist in memory. If the VI is set to SCR, a maximum of 3 instances will exist in memory. The 3 instances are sufficient to service all call sites while avoiding collisions. Thus, a reduction of 17 memory instances.</a:t>
             </a:r>
           </a:p>
           <a:p>
@@ -35195,10 +34470,8 @@
                 </a:solidFill>
                 <a:latin typeface="Aptos" panose="020B0004020202020204" pitchFamily="34" charset="0"/>
               </a:rPr>
-              <a:t>Press Ctrl + M to bring it back to edit mode (to edit the master blueprint for all call sites)</a:t>
-            </a:r>
-          </a:p>
-          <a:p>
+              <a:t>Press </a:t>
+            </a:r>
             <a:r>
               <a:rPr lang="en-GB" sz="2000" b="1" dirty="0">
                 <a:solidFill>
@@ -35206,6 +34479,26 @@
                 </a:solidFill>
                 <a:latin typeface="Aptos" panose="020B0004020202020204" pitchFamily="34" charset="0"/>
               </a:rPr>
+              <a:t>Ctrl + M</a:t>
+            </a:r>
+            <a:r>
+              <a:rPr lang="en-GB" sz="2000" dirty="0">
+                <a:solidFill>
+                  <a:srgbClr val="003B66"/>
+                </a:solidFill>
+                <a:latin typeface="Aptos" panose="020B0004020202020204" pitchFamily="34" charset="0"/>
+              </a:rPr>
+              <a:t> to bring it back to edit mode (to edit the master blueprint for all call sites)</a:t>
+            </a:r>
+          </a:p>
+          <a:p>
+            <a:r>
+              <a:rPr lang="en-GB" sz="2000" b="1" dirty="0">
+                <a:solidFill>
+                  <a:srgbClr val="003B66"/>
+                </a:solidFill>
+                <a:latin typeface="Aptos" panose="020B0004020202020204" pitchFamily="34" charset="0"/>
+              </a:rPr>
               <a:t>Objection 4: </a:t>
             </a:r>
             <a:r>
@@ -35227,7 +34520,7 @@
                 </a:solidFill>
                 <a:latin typeface="Aptos" panose="020B0004020202020204" pitchFamily="34" charset="0"/>
               </a:rPr>
-              <a:t>I agree that many LabVIEW applications are not limited by the computational overhead that NR and SCR VIs add. Proof of this are the very many LabVIEW applications in which NR VIs dominate. These apps do not suffer bugs and do not experience human-noticeable delays due to NR VIs.</a:t>
+              <a:t>I agree that many LabVIEW applications are not actively limited by the computational overhead that NR and SCR VIs add. Proof of this are the many LabVIEW applications in which NR VIs dominate. These apps do not suffer bugs and do not experience human-noticeable delays due to NR VIs.</a:t>
             </a:r>
           </a:p>
           <a:p>
@@ -35239,7 +34532,7 @@
                 </a:solidFill>
                 <a:latin typeface="Aptos" panose="020B0004020202020204" pitchFamily="34" charset="0"/>
               </a:rPr>
-              <a:t>Use PCR because it’s better from a Software Engineering (clean code) point of view, even if not from a performance point of view.</a:t>
+              <a:t>Use PCR because it’s better from a Software Engineering (clean code) point of view, even if performance is not your priority.</a:t>
             </a:r>
           </a:p>
           <a:p>
@@ -36095,16 +35388,7 @@
                 </a:solidFill>
                 <a:latin typeface="Aptos" panose="020B0004020202020204" pitchFamily="34" charset="0"/>
               </a:rPr>
-              <a:t> when they should 100% be set to Preallocated Clone </a:t>
-            </a:r>
-            <a:r>
-              <a:rPr lang="en-GB" sz="2000" dirty="0" err="1">
-                <a:solidFill>
-                  <a:srgbClr val="003B66"/>
-                </a:solidFill>
-                <a:latin typeface="Aptos" panose="020B0004020202020204" pitchFamily="34" charset="0"/>
-              </a:rPr>
-              <a:t>Reentrant</a:t>
+              <a:t>. These should be set to PCR (or SCR where PCR is not available).</a:t>
             </a:r>
             <a:endParaRPr lang="en-GB" sz="1600" dirty="0">
               <a:solidFill>
@@ -36291,43 +35575,25 @@
                 </a:solidFill>
                 <a:latin typeface="Aptos" panose="020B0004020202020204" pitchFamily="34" charset="0"/>
               </a:rPr>
-              <a:t>Unfortunately, there are lots of native VIs that are set to </a:t>
+              <a:t>Unfortunately, there are lots of native VIs that are set to Non-</a:t>
+            </a:r>
+            <a:r>
+              <a:rPr lang="en-GB" sz="2000" dirty="0" err="1">
+                <a:solidFill>
+                  <a:srgbClr val="003B66"/>
+                </a:solidFill>
+                <a:latin typeface="Aptos" panose="020B0004020202020204" pitchFamily="34" charset="0"/>
+              </a:rPr>
+              <a:t>Reentrant</a:t>
             </a:r>
             <a:r>
               <a:rPr lang="en-GB" sz="2000" dirty="0">
                 <a:solidFill>
-                  <a:srgbClr val="C00000"/>
+                  <a:srgbClr val="003B66"/>
                 </a:solidFill>
                 <a:latin typeface="Aptos" panose="020B0004020202020204" pitchFamily="34" charset="0"/>
               </a:rPr>
-              <a:t>Non-</a:t>
-            </a:r>
-            <a:r>
-              <a:rPr lang="en-GB" sz="2000" dirty="0" err="1">
-                <a:solidFill>
-                  <a:srgbClr val="C00000"/>
-                </a:solidFill>
-                <a:latin typeface="Aptos" panose="020B0004020202020204" pitchFamily="34" charset="0"/>
-              </a:rPr>
-              <a:t>Reentrant</a:t>
-            </a:r>
-            <a:r>
-              <a:rPr lang="en-GB" sz="2000" dirty="0">
-                <a:solidFill>
-                  <a:srgbClr val="003B66"/>
-                </a:solidFill>
-                <a:latin typeface="Aptos" panose="020B0004020202020204" pitchFamily="34" charset="0"/>
-              </a:rPr>
-              <a:t> when they should 100% be set to Preallocated Clone </a:t>
-            </a:r>
-            <a:r>
-              <a:rPr lang="en-GB" sz="2000" dirty="0" err="1">
-                <a:solidFill>
-                  <a:srgbClr val="003B66"/>
-                </a:solidFill>
-                <a:latin typeface="Aptos" panose="020B0004020202020204" pitchFamily="34" charset="0"/>
-              </a:rPr>
-              <a:t>Reentrant</a:t>
+              <a:t>. These should be set to PCR (or SCR where PCR is not available).</a:t>
             </a:r>
             <a:endParaRPr lang="en-GB" sz="1600" dirty="0">
               <a:solidFill>
@@ -36680,7 +35946,7 @@
         <p:cNvPr id="1" name="">
           <a:extLst>
             <a:ext uri="{FF2B5EF4-FFF2-40B4-BE49-F238E27FC236}">
-              <a16:creationId xmlns:a16="http://schemas.microsoft.com/office/drawing/2014/main" id="{58355484-B5D7-B3F4-5E60-0F37DDD7AA7F}"/>
+              <a16:creationId xmlns:a16="http://schemas.microsoft.com/office/drawing/2014/main" id="{69233344-B8B0-DE4C-677F-8387C4C64C2B}"/>
             </a:ext>
           </a:extLst>
         </p:cNvPr>
@@ -36700,7 +35966,7 @@
           <p:cNvPr id="2" name="Title 1">
             <a:extLst>
               <a:ext uri="{FF2B5EF4-FFF2-40B4-BE49-F238E27FC236}">
-                <a16:creationId xmlns:a16="http://schemas.microsoft.com/office/drawing/2014/main" id="{81F9C1B1-AFE8-FA5F-D76D-AE9DB314BA0D}"/>
+                <a16:creationId xmlns:a16="http://schemas.microsoft.com/office/drawing/2014/main" id="{28714FE5-1461-5963-A5A5-7E97AD888BE0}"/>
               </a:ext>
             </a:extLst>
           </p:cNvPr>
@@ -36730,1217 +35996,6 @@
                 </a:solidFill>
                 <a:latin typeface="Aptos Display" panose="020B0004020202020204" pitchFamily="34" charset="0"/>
               </a:rPr>
-              <a:t>LabVIEW Ideas – Native </a:t>
-            </a:r>
-            <a:r>
-              <a:rPr lang="en-GB" dirty="0" err="1">
-                <a:solidFill>
-                  <a:srgbClr val="003B66"/>
-                </a:solidFill>
-                <a:latin typeface="Aptos Display" panose="020B0004020202020204" pitchFamily="34" charset="0"/>
-              </a:rPr>
-              <a:t>AppBuilder</a:t>
-            </a:r>
-            <a:r>
-              <a:rPr lang="en-GB" dirty="0">
-                <a:solidFill>
-                  <a:srgbClr val="003B66"/>
-                </a:solidFill>
-                <a:latin typeface="Aptos Display" panose="020B0004020202020204" pitchFamily="34" charset="0"/>
-              </a:rPr>
-              <a:t> VIs</a:t>
-            </a:r>
-          </a:p>
-        </p:txBody>
-      </p:sp>
-      <p:sp>
-        <p:nvSpPr>
-          <p:cNvPr id="3" name="Content Placeholder 2">
-            <a:extLst>
-              <a:ext uri="{FF2B5EF4-FFF2-40B4-BE49-F238E27FC236}">
-                <a16:creationId xmlns:a16="http://schemas.microsoft.com/office/drawing/2014/main" id="{D6E7091B-9743-8C9D-C2E1-A51361AE3EA6}"/>
-              </a:ext>
-            </a:extLst>
-          </p:cNvPr>
-          <p:cNvSpPr>
-            <a:spLocks noGrp="1"/>
-          </p:cNvSpPr>
-          <p:nvPr>
-            <p:ph idx="1"/>
-          </p:nvPr>
-        </p:nvSpPr>
-        <p:spPr>
-          <a:xfrm>
-            <a:off x="838200" y="1027291"/>
-            <a:ext cx="10838512" cy="4228104"/>
-          </a:xfrm>
-        </p:spPr>
-        <p:txBody>
-          <a:bodyPr>
-            <a:normAutofit/>
-          </a:bodyPr>
-          <a:lstStyle/>
-          <a:p>
-            <a:r>
-              <a:rPr lang="en-GB" sz="1600" dirty="0">
-                <a:solidFill>
-                  <a:srgbClr val="003B66"/>
-                </a:solidFill>
-                <a:latin typeface="Aptos" panose="020B0004020202020204" pitchFamily="34" charset="0"/>
-              </a:rPr>
-              <a:t>Let’s look at the block diagram of some of the </a:t>
-            </a:r>
-            <a:r>
-              <a:rPr lang="en-GB" sz="1600" dirty="0" err="1">
-                <a:solidFill>
-                  <a:srgbClr val="003B66"/>
-                </a:solidFill>
-                <a:latin typeface="Aptos" panose="020B0004020202020204" pitchFamily="34" charset="0"/>
-              </a:rPr>
-              <a:t>AppBuilder</a:t>
-            </a:r>
-            <a:r>
-              <a:rPr lang="en-GB" sz="1600" dirty="0">
-                <a:solidFill>
-                  <a:srgbClr val="003B66"/>
-                </a:solidFill>
-                <a:latin typeface="Aptos" panose="020B0004020202020204" pitchFamily="34" charset="0"/>
-              </a:rPr>
-              <a:t> VIs, to get a sense of how small they are and how being set to Non-</a:t>
-            </a:r>
-            <a:r>
-              <a:rPr lang="en-GB" sz="1600" dirty="0" err="1">
-                <a:solidFill>
-                  <a:srgbClr val="003B66"/>
-                </a:solidFill>
-                <a:latin typeface="Aptos" panose="020B0004020202020204" pitchFamily="34" charset="0"/>
-              </a:rPr>
-              <a:t>Reentrant</a:t>
-            </a:r>
-            <a:r>
-              <a:rPr lang="en-GB" sz="1600" dirty="0">
-                <a:solidFill>
-                  <a:srgbClr val="003B66"/>
-                </a:solidFill>
-                <a:latin typeface="Aptos" panose="020B0004020202020204" pitchFamily="34" charset="0"/>
-              </a:rPr>
-              <a:t> is simply the incorrect choice.</a:t>
-            </a:r>
-          </a:p>
-          <a:p>
-            <a:endParaRPr lang="en-GB" sz="1600" dirty="0">
-              <a:solidFill>
-                <a:srgbClr val="003B66"/>
-              </a:solidFill>
-              <a:latin typeface="Aptos" panose="020B0004020202020204" pitchFamily="34" charset="0"/>
-            </a:endParaRPr>
-          </a:p>
-        </p:txBody>
-      </p:sp>
-      <p:sp>
-        <p:nvSpPr>
-          <p:cNvPr id="4" name="Slide Number Placeholder 3">
-            <a:extLst>
-              <a:ext uri="{FF2B5EF4-FFF2-40B4-BE49-F238E27FC236}">
-                <a16:creationId xmlns:a16="http://schemas.microsoft.com/office/drawing/2014/main" id="{6B682BB9-52F7-8995-1FAD-E170BBEE756E}"/>
-              </a:ext>
-            </a:extLst>
-          </p:cNvPr>
-          <p:cNvSpPr>
-            <a:spLocks noGrp="1"/>
-          </p:cNvSpPr>
-          <p:nvPr>
-            <p:ph type="sldNum" sz="quarter" idx="12"/>
-          </p:nvPr>
-        </p:nvSpPr>
-        <p:spPr/>
-        <p:txBody>
-          <a:bodyPr/>
-          <a:lstStyle/>
-          <a:p>
-            <a:fld id="{A5BC3523-C363-4BFA-8941-CE9ECEEECBA2}" type="slidenum">
-              <a:rPr lang="en-GB" smtClean="0"/>
-              <a:t>50</a:t>
-            </a:fld>
-            <a:endParaRPr lang="en-GB" dirty="0"/>
-          </a:p>
-        </p:txBody>
-      </p:sp>
-      <p:pic>
-        <p:nvPicPr>
-          <p:cNvPr id="17" name="Picture 16">
-            <a:extLst>
-              <a:ext uri="{FF2B5EF4-FFF2-40B4-BE49-F238E27FC236}">
-                <a16:creationId xmlns:a16="http://schemas.microsoft.com/office/drawing/2014/main" id="{B980F552-39E0-AA93-47E8-5AD6252A1C39}"/>
-              </a:ext>
-            </a:extLst>
-          </p:cNvPr>
-          <p:cNvPicPr>
-            <a:picLocks noChangeAspect="1"/>
-          </p:cNvPicPr>
-          <p:nvPr/>
-        </p:nvPicPr>
-        <p:blipFill>
-          <a:blip r:embed="rId3">
-            <a:extLst>
-              <a:ext uri="{28A0092B-C50C-407E-A947-70E740481C1C}">
-                <a14:useLocalDpi xmlns:a14="http://schemas.microsoft.com/office/drawing/2010/main" val="0"/>
-              </a:ext>
-            </a:extLst>
-          </a:blip>
-          <a:stretch>
-            <a:fillRect/>
-          </a:stretch>
-        </p:blipFill>
-        <p:spPr>
-          <a:xfrm>
-            <a:off x="2496000" y="1602605"/>
-            <a:ext cx="7200000" cy="4497941"/>
-          </a:xfrm>
-          <a:prstGeom prst="rect">
-            <a:avLst/>
-          </a:prstGeom>
-        </p:spPr>
-      </p:pic>
-    </p:spTree>
-    <p:extLst>
-      <p:ext uri="{BB962C8B-B14F-4D97-AF65-F5344CB8AC3E}">
-        <p14:creationId xmlns:p14="http://schemas.microsoft.com/office/powerpoint/2010/main" val="2696061409"/>
-      </p:ext>
-    </p:extLst>
-  </p:cSld>
-  <p:clrMapOvr>
-    <a:masterClrMapping/>
-  </p:clrMapOvr>
-</p:sld>
-</file>
-
-<file path=ppt/slides/slide51.xml><?xml version="1.0" encoding="utf-8"?>
-<p:sld xmlns:a="http://schemas.openxmlformats.org/drawingml/2006/main" xmlns:r="http://schemas.openxmlformats.org/officeDocument/2006/relationships" xmlns:p="http://schemas.openxmlformats.org/presentationml/2006/main">
-  <p:cSld>
-    <p:spTree>
-      <p:nvGrpSpPr>
-        <p:cNvPr id="1" name="">
-          <a:extLst>
-            <a:ext uri="{FF2B5EF4-FFF2-40B4-BE49-F238E27FC236}">
-              <a16:creationId xmlns:a16="http://schemas.microsoft.com/office/drawing/2014/main" id="{143753EA-33A6-39AA-72C2-A87BB94049DC}"/>
-            </a:ext>
-          </a:extLst>
-        </p:cNvPr>
-        <p:cNvGrpSpPr/>
-        <p:nvPr/>
-      </p:nvGrpSpPr>
-      <p:grpSpPr>
-        <a:xfrm>
-          <a:off x="0" y="0"/>
-          <a:ext cx="0" cy="0"/>
-          <a:chOff x="0" y="0"/>
-          <a:chExt cx="0" cy="0"/>
-        </a:xfrm>
-      </p:grpSpPr>
-      <p:sp>
-        <p:nvSpPr>
-          <p:cNvPr id="2" name="Title 1">
-            <a:extLst>
-              <a:ext uri="{FF2B5EF4-FFF2-40B4-BE49-F238E27FC236}">
-                <a16:creationId xmlns:a16="http://schemas.microsoft.com/office/drawing/2014/main" id="{E0534ADD-8CE9-73DB-D50E-AF60F6D491A5}"/>
-              </a:ext>
-            </a:extLst>
-          </p:cNvPr>
-          <p:cNvSpPr>
-            <a:spLocks noGrp="1"/>
-          </p:cNvSpPr>
-          <p:nvPr>
-            <p:ph type="title"/>
-          </p:nvPr>
-        </p:nvSpPr>
-        <p:spPr>
-          <a:xfrm>
-            <a:off x="838200" y="365126"/>
-            <a:ext cx="10515600" cy="662164"/>
-          </a:xfrm>
-        </p:spPr>
-        <p:txBody>
-          <a:bodyPr>
-            <a:normAutofit fontScale="90000"/>
-          </a:bodyPr>
-          <a:lstStyle/>
-          <a:p>
-            <a:r>
-              <a:rPr lang="en-GB" dirty="0">
-                <a:solidFill>
-                  <a:srgbClr val="003B66"/>
-                </a:solidFill>
-                <a:latin typeface="Aptos Display" panose="020B0004020202020204" pitchFamily="34" charset="0"/>
-              </a:rPr>
-              <a:t>LabVIEW Ideas – Native </a:t>
-            </a:r>
-            <a:r>
-              <a:rPr lang="en-GB" dirty="0" err="1">
-                <a:solidFill>
-                  <a:srgbClr val="003B66"/>
-                </a:solidFill>
-                <a:latin typeface="Aptos Display" panose="020B0004020202020204" pitchFamily="34" charset="0"/>
-              </a:rPr>
-              <a:t>AppBuilder</a:t>
-            </a:r>
-            <a:r>
-              <a:rPr lang="en-GB" dirty="0">
-                <a:solidFill>
-                  <a:srgbClr val="003B66"/>
-                </a:solidFill>
-                <a:latin typeface="Aptos Display" panose="020B0004020202020204" pitchFamily="34" charset="0"/>
-              </a:rPr>
-              <a:t> VIs</a:t>
-            </a:r>
-          </a:p>
-        </p:txBody>
-      </p:sp>
-      <p:sp>
-        <p:nvSpPr>
-          <p:cNvPr id="3" name="Content Placeholder 2">
-            <a:extLst>
-              <a:ext uri="{FF2B5EF4-FFF2-40B4-BE49-F238E27FC236}">
-                <a16:creationId xmlns:a16="http://schemas.microsoft.com/office/drawing/2014/main" id="{8F2EF80D-8BA5-43F7-8C68-0A495BAF434F}"/>
-              </a:ext>
-            </a:extLst>
-          </p:cNvPr>
-          <p:cNvSpPr>
-            <a:spLocks noGrp="1"/>
-          </p:cNvSpPr>
-          <p:nvPr>
-            <p:ph idx="1"/>
-          </p:nvPr>
-        </p:nvSpPr>
-        <p:spPr>
-          <a:xfrm>
-            <a:off x="838200" y="1027291"/>
-            <a:ext cx="10838512" cy="4228104"/>
-          </a:xfrm>
-        </p:spPr>
-        <p:txBody>
-          <a:bodyPr>
-            <a:normAutofit/>
-          </a:bodyPr>
-          <a:lstStyle/>
-          <a:p>
-            <a:r>
-              <a:rPr lang="en-GB" sz="1600" dirty="0">
-                <a:solidFill>
-                  <a:srgbClr val="003B66"/>
-                </a:solidFill>
-                <a:latin typeface="Aptos" panose="020B0004020202020204" pitchFamily="34" charset="0"/>
-              </a:rPr>
-              <a:t>Let’s look at the block diagram of some of the </a:t>
-            </a:r>
-            <a:r>
-              <a:rPr lang="en-GB" sz="1600" dirty="0" err="1">
-                <a:solidFill>
-                  <a:srgbClr val="003B66"/>
-                </a:solidFill>
-                <a:latin typeface="Aptos" panose="020B0004020202020204" pitchFamily="34" charset="0"/>
-              </a:rPr>
-              <a:t>AppBuilder</a:t>
-            </a:r>
-            <a:r>
-              <a:rPr lang="en-GB" sz="1600" dirty="0">
-                <a:solidFill>
-                  <a:srgbClr val="003B66"/>
-                </a:solidFill>
-                <a:latin typeface="Aptos" panose="020B0004020202020204" pitchFamily="34" charset="0"/>
-              </a:rPr>
-              <a:t> VIs, to get a sense of how small they are and how being set to Non-</a:t>
-            </a:r>
-            <a:r>
-              <a:rPr lang="en-GB" sz="1600" dirty="0" err="1">
-                <a:solidFill>
-                  <a:srgbClr val="003B66"/>
-                </a:solidFill>
-                <a:latin typeface="Aptos" panose="020B0004020202020204" pitchFamily="34" charset="0"/>
-              </a:rPr>
-              <a:t>Reentrant</a:t>
-            </a:r>
-            <a:r>
-              <a:rPr lang="en-GB" sz="1600" dirty="0">
-                <a:solidFill>
-                  <a:srgbClr val="003B66"/>
-                </a:solidFill>
-                <a:latin typeface="Aptos" panose="020B0004020202020204" pitchFamily="34" charset="0"/>
-              </a:rPr>
-              <a:t> is simply the incorrect choice.</a:t>
-            </a:r>
-          </a:p>
-          <a:p>
-            <a:endParaRPr lang="en-GB" sz="1600" dirty="0">
-              <a:solidFill>
-                <a:srgbClr val="003B66"/>
-              </a:solidFill>
-              <a:latin typeface="Aptos" panose="020B0004020202020204" pitchFamily="34" charset="0"/>
-            </a:endParaRPr>
-          </a:p>
-        </p:txBody>
-      </p:sp>
-      <p:sp>
-        <p:nvSpPr>
-          <p:cNvPr id="4" name="Slide Number Placeholder 3">
-            <a:extLst>
-              <a:ext uri="{FF2B5EF4-FFF2-40B4-BE49-F238E27FC236}">
-                <a16:creationId xmlns:a16="http://schemas.microsoft.com/office/drawing/2014/main" id="{1DCFB63A-FB69-36B5-08E8-B9ED61AE163D}"/>
-              </a:ext>
-            </a:extLst>
-          </p:cNvPr>
-          <p:cNvSpPr>
-            <a:spLocks noGrp="1"/>
-          </p:cNvSpPr>
-          <p:nvPr>
-            <p:ph type="sldNum" sz="quarter" idx="12"/>
-          </p:nvPr>
-        </p:nvSpPr>
-        <p:spPr/>
-        <p:txBody>
-          <a:bodyPr/>
-          <a:lstStyle/>
-          <a:p>
-            <a:fld id="{A5BC3523-C363-4BFA-8941-CE9ECEEECBA2}" type="slidenum">
-              <a:rPr lang="en-GB" smtClean="0"/>
-              <a:t>51</a:t>
-            </a:fld>
-            <a:endParaRPr lang="en-GB" dirty="0"/>
-          </a:p>
-        </p:txBody>
-      </p:sp>
-      <p:pic>
-        <p:nvPicPr>
-          <p:cNvPr id="17" name="Picture 16">
-            <a:extLst>
-              <a:ext uri="{FF2B5EF4-FFF2-40B4-BE49-F238E27FC236}">
-                <a16:creationId xmlns:a16="http://schemas.microsoft.com/office/drawing/2014/main" id="{805813EE-8376-C33F-1947-55A4DCE330C3}"/>
-              </a:ext>
-            </a:extLst>
-          </p:cNvPr>
-          <p:cNvPicPr>
-            <a:picLocks noChangeAspect="1"/>
-          </p:cNvPicPr>
-          <p:nvPr/>
-        </p:nvPicPr>
-        <p:blipFill>
-          <a:blip r:embed="rId3">
-            <a:extLst>
-              <a:ext uri="{28A0092B-C50C-407E-A947-70E740481C1C}">
-                <a14:useLocalDpi xmlns:a14="http://schemas.microsoft.com/office/drawing/2010/main" val="0"/>
-              </a:ext>
-            </a:extLst>
-          </a:blip>
-          <a:srcRect/>
-          <a:stretch/>
-        </p:blipFill>
-        <p:spPr>
-          <a:xfrm>
-            <a:off x="2647890" y="1602605"/>
-            <a:ext cx="6896219" cy="4497941"/>
-          </a:xfrm>
-          <a:prstGeom prst="rect">
-            <a:avLst/>
-          </a:prstGeom>
-        </p:spPr>
-      </p:pic>
-    </p:spTree>
-    <p:extLst>
-      <p:ext uri="{BB962C8B-B14F-4D97-AF65-F5344CB8AC3E}">
-        <p14:creationId xmlns:p14="http://schemas.microsoft.com/office/powerpoint/2010/main" val="222248792"/>
-      </p:ext>
-    </p:extLst>
-  </p:cSld>
-  <p:clrMapOvr>
-    <a:masterClrMapping/>
-  </p:clrMapOvr>
-</p:sld>
-</file>
-
-<file path=ppt/slides/slide52.xml><?xml version="1.0" encoding="utf-8"?>
-<p:sld xmlns:a="http://schemas.openxmlformats.org/drawingml/2006/main" xmlns:r="http://schemas.openxmlformats.org/officeDocument/2006/relationships" xmlns:p="http://schemas.openxmlformats.org/presentationml/2006/main">
-  <p:cSld>
-    <p:spTree>
-      <p:nvGrpSpPr>
-        <p:cNvPr id="1" name="">
-          <a:extLst>
-            <a:ext uri="{FF2B5EF4-FFF2-40B4-BE49-F238E27FC236}">
-              <a16:creationId xmlns:a16="http://schemas.microsoft.com/office/drawing/2014/main" id="{50B25948-B58F-1616-3F5A-740F462ADF07}"/>
-            </a:ext>
-          </a:extLst>
-        </p:cNvPr>
-        <p:cNvGrpSpPr/>
-        <p:nvPr/>
-      </p:nvGrpSpPr>
-      <p:grpSpPr>
-        <a:xfrm>
-          <a:off x="0" y="0"/>
-          <a:ext cx="0" cy="0"/>
-          <a:chOff x="0" y="0"/>
-          <a:chExt cx="0" cy="0"/>
-        </a:xfrm>
-      </p:grpSpPr>
-      <p:sp>
-        <p:nvSpPr>
-          <p:cNvPr id="2" name="Title 1">
-            <a:extLst>
-              <a:ext uri="{FF2B5EF4-FFF2-40B4-BE49-F238E27FC236}">
-                <a16:creationId xmlns:a16="http://schemas.microsoft.com/office/drawing/2014/main" id="{F226AC6D-0BB0-FF7D-43D4-734680A0B93B}"/>
-              </a:ext>
-            </a:extLst>
-          </p:cNvPr>
-          <p:cNvSpPr>
-            <a:spLocks noGrp="1"/>
-          </p:cNvSpPr>
-          <p:nvPr>
-            <p:ph type="title"/>
-          </p:nvPr>
-        </p:nvSpPr>
-        <p:spPr>
-          <a:xfrm>
-            <a:off x="838200" y="365126"/>
-            <a:ext cx="10515600" cy="662164"/>
-          </a:xfrm>
-        </p:spPr>
-        <p:txBody>
-          <a:bodyPr>
-            <a:normAutofit fontScale="90000"/>
-          </a:bodyPr>
-          <a:lstStyle/>
-          <a:p>
-            <a:r>
-              <a:rPr lang="en-GB" dirty="0">
-                <a:solidFill>
-                  <a:srgbClr val="003B66"/>
-                </a:solidFill>
-                <a:latin typeface="Aptos Display" panose="020B0004020202020204" pitchFamily="34" charset="0"/>
-              </a:rPr>
-              <a:t>LabVIEW Ideas – Native </a:t>
-            </a:r>
-            <a:r>
-              <a:rPr lang="en-GB" dirty="0" err="1">
-                <a:solidFill>
-                  <a:srgbClr val="003B66"/>
-                </a:solidFill>
-                <a:latin typeface="Aptos Display" panose="020B0004020202020204" pitchFamily="34" charset="0"/>
-              </a:rPr>
-              <a:t>AppBuilder</a:t>
-            </a:r>
-            <a:r>
-              <a:rPr lang="en-GB" dirty="0">
-                <a:solidFill>
-                  <a:srgbClr val="003B66"/>
-                </a:solidFill>
-                <a:latin typeface="Aptos Display" panose="020B0004020202020204" pitchFamily="34" charset="0"/>
-              </a:rPr>
-              <a:t> VIs</a:t>
-            </a:r>
-          </a:p>
-        </p:txBody>
-      </p:sp>
-      <p:sp>
-        <p:nvSpPr>
-          <p:cNvPr id="3" name="Content Placeholder 2">
-            <a:extLst>
-              <a:ext uri="{FF2B5EF4-FFF2-40B4-BE49-F238E27FC236}">
-                <a16:creationId xmlns:a16="http://schemas.microsoft.com/office/drawing/2014/main" id="{066D4F67-C0BA-2E5C-AE2A-1015657E4903}"/>
-              </a:ext>
-            </a:extLst>
-          </p:cNvPr>
-          <p:cNvSpPr>
-            <a:spLocks noGrp="1"/>
-          </p:cNvSpPr>
-          <p:nvPr>
-            <p:ph idx="1"/>
-          </p:nvPr>
-        </p:nvSpPr>
-        <p:spPr>
-          <a:xfrm>
-            <a:off x="838200" y="1027291"/>
-            <a:ext cx="10838512" cy="4228104"/>
-          </a:xfrm>
-        </p:spPr>
-        <p:txBody>
-          <a:bodyPr>
-            <a:normAutofit/>
-          </a:bodyPr>
-          <a:lstStyle/>
-          <a:p>
-            <a:r>
-              <a:rPr lang="en-GB" sz="1600" dirty="0">
-                <a:solidFill>
-                  <a:srgbClr val="003B66"/>
-                </a:solidFill>
-                <a:latin typeface="Aptos" panose="020B0004020202020204" pitchFamily="34" charset="0"/>
-              </a:rPr>
-              <a:t>Let’s look at the block diagram of some of the </a:t>
-            </a:r>
-            <a:r>
-              <a:rPr lang="en-GB" sz="1600" dirty="0" err="1">
-                <a:solidFill>
-                  <a:srgbClr val="003B66"/>
-                </a:solidFill>
-                <a:latin typeface="Aptos" panose="020B0004020202020204" pitchFamily="34" charset="0"/>
-              </a:rPr>
-              <a:t>AppBuilder</a:t>
-            </a:r>
-            <a:r>
-              <a:rPr lang="en-GB" sz="1600" dirty="0">
-                <a:solidFill>
-                  <a:srgbClr val="003B66"/>
-                </a:solidFill>
-                <a:latin typeface="Aptos" panose="020B0004020202020204" pitchFamily="34" charset="0"/>
-              </a:rPr>
-              <a:t> VIs, to get a sense of how small they are and how being set to Non-</a:t>
-            </a:r>
-            <a:r>
-              <a:rPr lang="en-GB" sz="1600" dirty="0" err="1">
-                <a:solidFill>
-                  <a:srgbClr val="003B66"/>
-                </a:solidFill>
-                <a:latin typeface="Aptos" panose="020B0004020202020204" pitchFamily="34" charset="0"/>
-              </a:rPr>
-              <a:t>Reentrant</a:t>
-            </a:r>
-            <a:r>
-              <a:rPr lang="en-GB" sz="1600" dirty="0">
-                <a:solidFill>
-                  <a:srgbClr val="003B66"/>
-                </a:solidFill>
-                <a:latin typeface="Aptos" panose="020B0004020202020204" pitchFamily="34" charset="0"/>
-              </a:rPr>
-              <a:t> is simply the incorrect choice.</a:t>
-            </a:r>
-          </a:p>
-          <a:p>
-            <a:endParaRPr lang="en-GB" sz="1600" dirty="0">
-              <a:solidFill>
-                <a:srgbClr val="003B66"/>
-              </a:solidFill>
-              <a:latin typeface="Aptos" panose="020B0004020202020204" pitchFamily="34" charset="0"/>
-            </a:endParaRPr>
-          </a:p>
-        </p:txBody>
-      </p:sp>
-      <p:sp>
-        <p:nvSpPr>
-          <p:cNvPr id="4" name="Slide Number Placeholder 3">
-            <a:extLst>
-              <a:ext uri="{FF2B5EF4-FFF2-40B4-BE49-F238E27FC236}">
-                <a16:creationId xmlns:a16="http://schemas.microsoft.com/office/drawing/2014/main" id="{93753F0D-F89D-3395-B008-E48B02F7767C}"/>
-              </a:ext>
-            </a:extLst>
-          </p:cNvPr>
-          <p:cNvSpPr>
-            <a:spLocks noGrp="1"/>
-          </p:cNvSpPr>
-          <p:nvPr>
-            <p:ph type="sldNum" sz="quarter" idx="12"/>
-          </p:nvPr>
-        </p:nvSpPr>
-        <p:spPr/>
-        <p:txBody>
-          <a:bodyPr/>
-          <a:lstStyle/>
-          <a:p>
-            <a:fld id="{A5BC3523-C363-4BFA-8941-CE9ECEEECBA2}" type="slidenum">
-              <a:rPr lang="en-GB" smtClean="0"/>
-              <a:t>52</a:t>
-            </a:fld>
-            <a:endParaRPr lang="en-GB" dirty="0"/>
-          </a:p>
-        </p:txBody>
-      </p:sp>
-      <p:pic>
-        <p:nvPicPr>
-          <p:cNvPr id="17" name="Picture 16">
-            <a:extLst>
-              <a:ext uri="{FF2B5EF4-FFF2-40B4-BE49-F238E27FC236}">
-                <a16:creationId xmlns:a16="http://schemas.microsoft.com/office/drawing/2014/main" id="{575E9450-91FE-169C-175A-204696357DA6}"/>
-              </a:ext>
-            </a:extLst>
-          </p:cNvPr>
-          <p:cNvPicPr>
-            <a:picLocks noChangeAspect="1"/>
-          </p:cNvPicPr>
-          <p:nvPr/>
-        </p:nvPicPr>
-        <p:blipFill>
-          <a:blip r:embed="rId3">
-            <a:extLst>
-              <a:ext uri="{28A0092B-C50C-407E-A947-70E740481C1C}">
-                <a14:useLocalDpi xmlns:a14="http://schemas.microsoft.com/office/drawing/2010/main" val="0"/>
-              </a:ext>
-            </a:extLst>
-          </a:blip>
-          <a:srcRect/>
-          <a:stretch/>
-        </p:blipFill>
-        <p:spPr>
-          <a:xfrm>
-            <a:off x="2895201" y="1602605"/>
-            <a:ext cx="6401597" cy="4497941"/>
-          </a:xfrm>
-          <a:prstGeom prst="rect">
-            <a:avLst/>
-          </a:prstGeom>
-        </p:spPr>
-      </p:pic>
-    </p:spTree>
-    <p:extLst>
-      <p:ext uri="{BB962C8B-B14F-4D97-AF65-F5344CB8AC3E}">
-        <p14:creationId xmlns:p14="http://schemas.microsoft.com/office/powerpoint/2010/main" val="222900826"/>
-      </p:ext>
-    </p:extLst>
-  </p:cSld>
-  <p:clrMapOvr>
-    <a:masterClrMapping/>
-  </p:clrMapOvr>
-</p:sld>
-</file>
-
-<file path=ppt/slides/slide53.xml><?xml version="1.0" encoding="utf-8"?>
-<p:sld xmlns:a="http://schemas.openxmlformats.org/drawingml/2006/main" xmlns:r="http://schemas.openxmlformats.org/officeDocument/2006/relationships" xmlns:p="http://schemas.openxmlformats.org/presentationml/2006/main">
-  <p:cSld>
-    <p:spTree>
-      <p:nvGrpSpPr>
-        <p:cNvPr id="1" name="">
-          <a:extLst>
-            <a:ext uri="{FF2B5EF4-FFF2-40B4-BE49-F238E27FC236}">
-              <a16:creationId xmlns:a16="http://schemas.microsoft.com/office/drawing/2014/main" id="{9B91EB24-A729-89B1-8EA7-5C2B01F42029}"/>
-            </a:ext>
-          </a:extLst>
-        </p:cNvPr>
-        <p:cNvGrpSpPr/>
-        <p:nvPr/>
-      </p:nvGrpSpPr>
-      <p:grpSpPr>
-        <a:xfrm>
-          <a:off x="0" y="0"/>
-          <a:ext cx="0" cy="0"/>
-          <a:chOff x="0" y="0"/>
-          <a:chExt cx="0" cy="0"/>
-        </a:xfrm>
-      </p:grpSpPr>
-      <p:sp>
-        <p:nvSpPr>
-          <p:cNvPr id="2" name="Title 1">
-            <a:extLst>
-              <a:ext uri="{FF2B5EF4-FFF2-40B4-BE49-F238E27FC236}">
-                <a16:creationId xmlns:a16="http://schemas.microsoft.com/office/drawing/2014/main" id="{4D10AF4B-CBC6-4A1E-8292-4975B2A7394E}"/>
-              </a:ext>
-            </a:extLst>
-          </p:cNvPr>
-          <p:cNvSpPr>
-            <a:spLocks noGrp="1"/>
-          </p:cNvSpPr>
-          <p:nvPr>
-            <p:ph type="title"/>
-          </p:nvPr>
-        </p:nvSpPr>
-        <p:spPr>
-          <a:xfrm>
-            <a:off x="838200" y="365126"/>
-            <a:ext cx="10515600" cy="662164"/>
-          </a:xfrm>
-        </p:spPr>
-        <p:txBody>
-          <a:bodyPr>
-            <a:normAutofit fontScale="90000"/>
-          </a:bodyPr>
-          <a:lstStyle/>
-          <a:p>
-            <a:r>
-              <a:rPr lang="en-GB" dirty="0">
-                <a:solidFill>
-                  <a:srgbClr val="003B66"/>
-                </a:solidFill>
-                <a:latin typeface="Aptos Display" panose="020B0004020202020204" pitchFamily="34" charset="0"/>
-              </a:rPr>
-              <a:t>LabVIEW Ideas – Native </a:t>
-            </a:r>
-            <a:r>
-              <a:rPr lang="en-GB" dirty="0" err="1">
-                <a:solidFill>
-                  <a:srgbClr val="003B66"/>
-                </a:solidFill>
-                <a:latin typeface="Aptos Display" panose="020B0004020202020204" pitchFamily="34" charset="0"/>
-              </a:rPr>
-              <a:t>AppBuilder</a:t>
-            </a:r>
-            <a:r>
-              <a:rPr lang="en-GB" dirty="0">
-                <a:solidFill>
-                  <a:srgbClr val="003B66"/>
-                </a:solidFill>
-                <a:latin typeface="Aptos Display" panose="020B0004020202020204" pitchFamily="34" charset="0"/>
-              </a:rPr>
-              <a:t> VIs</a:t>
-            </a:r>
-          </a:p>
-        </p:txBody>
-      </p:sp>
-      <p:sp>
-        <p:nvSpPr>
-          <p:cNvPr id="3" name="Content Placeholder 2">
-            <a:extLst>
-              <a:ext uri="{FF2B5EF4-FFF2-40B4-BE49-F238E27FC236}">
-                <a16:creationId xmlns:a16="http://schemas.microsoft.com/office/drawing/2014/main" id="{18023FDE-4C93-D75A-A03A-355C6891F9EB}"/>
-              </a:ext>
-            </a:extLst>
-          </p:cNvPr>
-          <p:cNvSpPr>
-            <a:spLocks noGrp="1"/>
-          </p:cNvSpPr>
-          <p:nvPr>
-            <p:ph idx="1"/>
-          </p:nvPr>
-        </p:nvSpPr>
-        <p:spPr>
-          <a:xfrm>
-            <a:off x="838200" y="1027291"/>
-            <a:ext cx="10838512" cy="4228104"/>
-          </a:xfrm>
-        </p:spPr>
-        <p:txBody>
-          <a:bodyPr>
-            <a:normAutofit/>
-          </a:bodyPr>
-          <a:lstStyle/>
-          <a:p>
-            <a:r>
-              <a:rPr lang="en-GB" sz="1600" dirty="0">
-                <a:solidFill>
-                  <a:srgbClr val="003B66"/>
-                </a:solidFill>
-                <a:latin typeface="Aptos" panose="020B0004020202020204" pitchFamily="34" charset="0"/>
-              </a:rPr>
-              <a:t>Let’s look at the block diagram of some of the </a:t>
-            </a:r>
-            <a:r>
-              <a:rPr lang="en-GB" sz="1600" dirty="0" err="1">
-                <a:solidFill>
-                  <a:srgbClr val="003B66"/>
-                </a:solidFill>
-                <a:latin typeface="Aptos" panose="020B0004020202020204" pitchFamily="34" charset="0"/>
-              </a:rPr>
-              <a:t>AppBuilder</a:t>
-            </a:r>
-            <a:r>
-              <a:rPr lang="en-GB" sz="1600" dirty="0">
-                <a:solidFill>
-                  <a:srgbClr val="003B66"/>
-                </a:solidFill>
-                <a:latin typeface="Aptos" panose="020B0004020202020204" pitchFamily="34" charset="0"/>
-              </a:rPr>
-              <a:t> VIs, to get a sense of how small they are and how being set to Non-</a:t>
-            </a:r>
-            <a:r>
-              <a:rPr lang="en-GB" sz="1600" dirty="0" err="1">
-                <a:solidFill>
-                  <a:srgbClr val="003B66"/>
-                </a:solidFill>
-                <a:latin typeface="Aptos" panose="020B0004020202020204" pitchFamily="34" charset="0"/>
-              </a:rPr>
-              <a:t>Reentrant</a:t>
-            </a:r>
-            <a:r>
-              <a:rPr lang="en-GB" sz="1600" dirty="0">
-                <a:solidFill>
-                  <a:srgbClr val="003B66"/>
-                </a:solidFill>
-                <a:latin typeface="Aptos" panose="020B0004020202020204" pitchFamily="34" charset="0"/>
-              </a:rPr>
-              <a:t> is simply the incorrect choice.</a:t>
-            </a:r>
-          </a:p>
-          <a:p>
-            <a:endParaRPr lang="en-GB" sz="1600" dirty="0">
-              <a:solidFill>
-                <a:srgbClr val="003B66"/>
-              </a:solidFill>
-              <a:latin typeface="Aptos" panose="020B0004020202020204" pitchFamily="34" charset="0"/>
-            </a:endParaRPr>
-          </a:p>
-        </p:txBody>
-      </p:sp>
-      <p:sp>
-        <p:nvSpPr>
-          <p:cNvPr id="4" name="Slide Number Placeholder 3">
-            <a:extLst>
-              <a:ext uri="{FF2B5EF4-FFF2-40B4-BE49-F238E27FC236}">
-                <a16:creationId xmlns:a16="http://schemas.microsoft.com/office/drawing/2014/main" id="{73CBB079-7C16-220A-2B5B-BDA16059BAB9}"/>
-              </a:ext>
-            </a:extLst>
-          </p:cNvPr>
-          <p:cNvSpPr>
-            <a:spLocks noGrp="1"/>
-          </p:cNvSpPr>
-          <p:nvPr>
-            <p:ph type="sldNum" sz="quarter" idx="12"/>
-          </p:nvPr>
-        </p:nvSpPr>
-        <p:spPr/>
-        <p:txBody>
-          <a:bodyPr/>
-          <a:lstStyle/>
-          <a:p>
-            <a:fld id="{A5BC3523-C363-4BFA-8941-CE9ECEEECBA2}" type="slidenum">
-              <a:rPr lang="en-GB" smtClean="0"/>
-              <a:t>53</a:t>
-            </a:fld>
-            <a:endParaRPr lang="en-GB" dirty="0"/>
-          </a:p>
-        </p:txBody>
-      </p:sp>
-      <p:pic>
-        <p:nvPicPr>
-          <p:cNvPr id="17" name="Picture 16">
-            <a:extLst>
-              <a:ext uri="{FF2B5EF4-FFF2-40B4-BE49-F238E27FC236}">
-                <a16:creationId xmlns:a16="http://schemas.microsoft.com/office/drawing/2014/main" id="{FDA1E00E-9BB3-7D82-7A73-A19F8AFAF54E}"/>
-              </a:ext>
-            </a:extLst>
-          </p:cNvPr>
-          <p:cNvPicPr>
-            <a:picLocks noChangeAspect="1"/>
-          </p:cNvPicPr>
-          <p:nvPr/>
-        </p:nvPicPr>
-        <p:blipFill>
-          <a:blip r:embed="rId3">
-            <a:extLst>
-              <a:ext uri="{28A0092B-C50C-407E-A947-70E740481C1C}">
-                <a14:useLocalDpi xmlns:a14="http://schemas.microsoft.com/office/drawing/2010/main" val="0"/>
-              </a:ext>
-            </a:extLst>
-          </a:blip>
-          <a:srcRect/>
-          <a:stretch/>
-        </p:blipFill>
-        <p:spPr>
-          <a:xfrm>
-            <a:off x="2496000" y="1602605"/>
-            <a:ext cx="7200000" cy="4155340"/>
-          </a:xfrm>
-          <a:prstGeom prst="rect">
-            <a:avLst/>
-          </a:prstGeom>
-        </p:spPr>
-      </p:pic>
-    </p:spTree>
-    <p:extLst>
-      <p:ext uri="{BB962C8B-B14F-4D97-AF65-F5344CB8AC3E}">
-        <p14:creationId xmlns:p14="http://schemas.microsoft.com/office/powerpoint/2010/main" val="68997076"/>
-      </p:ext>
-    </p:extLst>
-  </p:cSld>
-  <p:clrMapOvr>
-    <a:masterClrMapping/>
-  </p:clrMapOvr>
-</p:sld>
-</file>
-
-<file path=ppt/slides/slide54.xml><?xml version="1.0" encoding="utf-8"?>
-<p:sld xmlns:a="http://schemas.openxmlformats.org/drawingml/2006/main" xmlns:r="http://schemas.openxmlformats.org/officeDocument/2006/relationships" xmlns:p="http://schemas.openxmlformats.org/presentationml/2006/main">
-  <p:cSld>
-    <p:spTree>
-      <p:nvGrpSpPr>
-        <p:cNvPr id="1" name="">
-          <a:extLst>
-            <a:ext uri="{FF2B5EF4-FFF2-40B4-BE49-F238E27FC236}">
-              <a16:creationId xmlns:a16="http://schemas.microsoft.com/office/drawing/2014/main" id="{4D13E2E9-047E-7CB7-0B32-79A36EA8F242}"/>
-            </a:ext>
-          </a:extLst>
-        </p:cNvPr>
-        <p:cNvGrpSpPr/>
-        <p:nvPr/>
-      </p:nvGrpSpPr>
-      <p:grpSpPr>
-        <a:xfrm>
-          <a:off x="0" y="0"/>
-          <a:ext cx="0" cy="0"/>
-          <a:chOff x="0" y="0"/>
-          <a:chExt cx="0" cy="0"/>
-        </a:xfrm>
-      </p:grpSpPr>
-      <p:sp>
-        <p:nvSpPr>
-          <p:cNvPr id="2" name="Title 1">
-            <a:extLst>
-              <a:ext uri="{FF2B5EF4-FFF2-40B4-BE49-F238E27FC236}">
-                <a16:creationId xmlns:a16="http://schemas.microsoft.com/office/drawing/2014/main" id="{99417CA9-7385-5470-CA94-3C04E99D1283}"/>
-              </a:ext>
-            </a:extLst>
-          </p:cNvPr>
-          <p:cNvSpPr>
-            <a:spLocks noGrp="1"/>
-          </p:cNvSpPr>
-          <p:nvPr>
-            <p:ph type="title"/>
-          </p:nvPr>
-        </p:nvSpPr>
-        <p:spPr>
-          <a:xfrm>
-            <a:off x="838200" y="365126"/>
-            <a:ext cx="10515600" cy="662164"/>
-          </a:xfrm>
-        </p:spPr>
-        <p:txBody>
-          <a:bodyPr>
-            <a:normAutofit fontScale="90000"/>
-          </a:bodyPr>
-          <a:lstStyle/>
-          <a:p>
-            <a:r>
-              <a:rPr lang="en-GB" dirty="0">
-                <a:solidFill>
-                  <a:srgbClr val="003B66"/>
-                </a:solidFill>
-                <a:latin typeface="Aptos Display" panose="020B0004020202020204" pitchFamily="34" charset="0"/>
-              </a:rPr>
-              <a:t>LabVIEW Ideas – Native </a:t>
-            </a:r>
-            <a:r>
-              <a:rPr lang="en-GB" dirty="0" err="1">
-                <a:solidFill>
-                  <a:srgbClr val="003B66"/>
-                </a:solidFill>
-                <a:latin typeface="Aptos Display" panose="020B0004020202020204" pitchFamily="34" charset="0"/>
-              </a:rPr>
-              <a:t>AppBuilder</a:t>
-            </a:r>
-            <a:r>
-              <a:rPr lang="en-GB" dirty="0">
-                <a:solidFill>
-                  <a:srgbClr val="003B66"/>
-                </a:solidFill>
-                <a:latin typeface="Aptos Display" panose="020B0004020202020204" pitchFamily="34" charset="0"/>
-              </a:rPr>
-              <a:t> VIs</a:t>
-            </a:r>
-          </a:p>
-        </p:txBody>
-      </p:sp>
-      <p:sp>
-        <p:nvSpPr>
-          <p:cNvPr id="3" name="Content Placeholder 2">
-            <a:extLst>
-              <a:ext uri="{FF2B5EF4-FFF2-40B4-BE49-F238E27FC236}">
-                <a16:creationId xmlns:a16="http://schemas.microsoft.com/office/drawing/2014/main" id="{43D2CF18-FCBF-A9ED-DD98-B23D80D5377E}"/>
-              </a:ext>
-            </a:extLst>
-          </p:cNvPr>
-          <p:cNvSpPr>
-            <a:spLocks noGrp="1"/>
-          </p:cNvSpPr>
-          <p:nvPr>
-            <p:ph idx="1"/>
-          </p:nvPr>
-        </p:nvSpPr>
-        <p:spPr>
-          <a:xfrm>
-            <a:off x="838200" y="1027291"/>
-            <a:ext cx="10838512" cy="4228104"/>
-          </a:xfrm>
-        </p:spPr>
-        <p:txBody>
-          <a:bodyPr>
-            <a:normAutofit/>
-          </a:bodyPr>
-          <a:lstStyle/>
-          <a:p>
-            <a:r>
-              <a:rPr lang="en-GB" sz="1600" dirty="0">
-                <a:solidFill>
-                  <a:srgbClr val="003B66"/>
-                </a:solidFill>
-                <a:latin typeface="Aptos" panose="020B0004020202020204" pitchFamily="34" charset="0"/>
-              </a:rPr>
-              <a:t>Let’s look at the block diagram of some of the </a:t>
-            </a:r>
-            <a:r>
-              <a:rPr lang="en-GB" sz="1600" dirty="0" err="1">
-                <a:solidFill>
-                  <a:srgbClr val="003B66"/>
-                </a:solidFill>
-                <a:latin typeface="Aptos" panose="020B0004020202020204" pitchFamily="34" charset="0"/>
-              </a:rPr>
-              <a:t>AppBuilder</a:t>
-            </a:r>
-            <a:r>
-              <a:rPr lang="en-GB" sz="1600" dirty="0">
-                <a:solidFill>
-                  <a:srgbClr val="003B66"/>
-                </a:solidFill>
-                <a:latin typeface="Aptos" panose="020B0004020202020204" pitchFamily="34" charset="0"/>
-              </a:rPr>
-              <a:t> VIs, to get a sense of how small they are and how being set to Non-</a:t>
-            </a:r>
-            <a:r>
-              <a:rPr lang="en-GB" sz="1600" dirty="0" err="1">
-                <a:solidFill>
-                  <a:srgbClr val="003B66"/>
-                </a:solidFill>
-                <a:latin typeface="Aptos" panose="020B0004020202020204" pitchFamily="34" charset="0"/>
-              </a:rPr>
-              <a:t>Reentrant</a:t>
-            </a:r>
-            <a:r>
-              <a:rPr lang="en-GB" sz="1600" dirty="0">
-                <a:solidFill>
-                  <a:srgbClr val="003B66"/>
-                </a:solidFill>
-                <a:latin typeface="Aptos" panose="020B0004020202020204" pitchFamily="34" charset="0"/>
-              </a:rPr>
-              <a:t> is simply the incorrect choice.</a:t>
-            </a:r>
-          </a:p>
-          <a:p>
-            <a:endParaRPr lang="en-GB" sz="1600" dirty="0">
-              <a:solidFill>
-                <a:srgbClr val="003B66"/>
-              </a:solidFill>
-              <a:latin typeface="Aptos" panose="020B0004020202020204" pitchFamily="34" charset="0"/>
-            </a:endParaRPr>
-          </a:p>
-        </p:txBody>
-      </p:sp>
-      <p:sp>
-        <p:nvSpPr>
-          <p:cNvPr id="4" name="Slide Number Placeholder 3">
-            <a:extLst>
-              <a:ext uri="{FF2B5EF4-FFF2-40B4-BE49-F238E27FC236}">
-                <a16:creationId xmlns:a16="http://schemas.microsoft.com/office/drawing/2014/main" id="{187F35DB-E322-E5F5-B8C9-77D7966948BF}"/>
-              </a:ext>
-            </a:extLst>
-          </p:cNvPr>
-          <p:cNvSpPr>
-            <a:spLocks noGrp="1"/>
-          </p:cNvSpPr>
-          <p:nvPr>
-            <p:ph type="sldNum" sz="quarter" idx="12"/>
-          </p:nvPr>
-        </p:nvSpPr>
-        <p:spPr/>
-        <p:txBody>
-          <a:bodyPr/>
-          <a:lstStyle/>
-          <a:p>
-            <a:fld id="{A5BC3523-C363-4BFA-8941-CE9ECEEECBA2}" type="slidenum">
-              <a:rPr lang="en-GB" smtClean="0"/>
-              <a:t>54</a:t>
-            </a:fld>
-            <a:endParaRPr lang="en-GB" dirty="0"/>
-          </a:p>
-        </p:txBody>
-      </p:sp>
-      <p:pic>
-        <p:nvPicPr>
-          <p:cNvPr id="17" name="Picture 16">
-            <a:extLst>
-              <a:ext uri="{FF2B5EF4-FFF2-40B4-BE49-F238E27FC236}">
-                <a16:creationId xmlns:a16="http://schemas.microsoft.com/office/drawing/2014/main" id="{D903C832-B4C0-18CF-0095-B21F67976887}"/>
-              </a:ext>
-            </a:extLst>
-          </p:cNvPr>
-          <p:cNvPicPr>
-            <a:picLocks noChangeAspect="1"/>
-          </p:cNvPicPr>
-          <p:nvPr/>
-        </p:nvPicPr>
-        <p:blipFill>
-          <a:blip r:embed="rId3">
-            <a:extLst>
-              <a:ext uri="{28A0092B-C50C-407E-A947-70E740481C1C}">
-                <a14:useLocalDpi xmlns:a14="http://schemas.microsoft.com/office/drawing/2010/main" val="0"/>
-              </a:ext>
-            </a:extLst>
-          </a:blip>
-          <a:srcRect/>
-          <a:stretch/>
-        </p:blipFill>
-        <p:spPr>
-          <a:xfrm>
-            <a:off x="2846841" y="1602605"/>
-            <a:ext cx="6498317" cy="4155340"/>
-          </a:xfrm>
-          <a:prstGeom prst="rect">
-            <a:avLst/>
-          </a:prstGeom>
-        </p:spPr>
-      </p:pic>
-    </p:spTree>
-    <p:extLst>
-      <p:ext uri="{BB962C8B-B14F-4D97-AF65-F5344CB8AC3E}">
-        <p14:creationId xmlns:p14="http://schemas.microsoft.com/office/powerpoint/2010/main" val="4050078487"/>
-      </p:ext>
-    </p:extLst>
-  </p:cSld>
-  <p:clrMapOvr>
-    <a:masterClrMapping/>
-  </p:clrMapOvr>
-</p:sld>
-</file>
-
-<file path=ppt/slides/slide55.xml><?xml version="1.0" encoding="utf-8"?>
-<p:sld xmlns:a="http://schemas.openxmlformats.org/drawingml/2006/main" xmlns:r="http://schemas.openxmlformats.org/officeDocument/2006/relationships" xmlns:p="http://schemas.openxmlformats.org/presentationml/2006/main">
-  <p:cSld>
-    <p:spTree>
-      <p:nvGrpSpPr>
-        <p:cNvPr id="1" name="">
-          <a:extLst>
-            <a:ext uri="{FF2B5EF4-FFF2-40B4-BE49-F238E27FC236}">
-              <a16:creationId xmlns:a16="http://schemas.microsoft.com/office/drawing/2014/main" id="{69233344-B8B0-DE4C-677F-8387C4C64C2B}"/>
-            </a:ext>
-          </a:extLst>
-        </p:cNvPr>
-        <p:cNvGrpSpPr/>
-        <p:nvPr/>
-      </p:nvGrpSpPr>
-      <p:grpSpPr>
-        <a:xfrm>
-          <a:off x="0" y="0"/>
-          <a:ext cx="0" cy="0"/>
-          <a:chOff x="0" y="0"/>
-          <a:chExt cx="0" cy="0"/>
-        </a:xfrm>
-      </p:grpSpPr>
-      <p:sp>
-        <p:nvSpPr>
-          <p:cNvPr id="2" name="Title 1">
-            <a:extLst>
-              <a:ext uri="{FF2B5EF4-FFF2-40B4-BE49-F238E27FC236}">
-                <a16:creationId xmlns:a16="http://schemas.microsoft.com/office/drawing/2014/main" id="{28714FE5-1461-5963-A5A5-7E97AD888BE0}"/>
-              </a:ext>
-            </a:extLst>
-          </p:cNvPr>
-          <p:cNvSpPr>
-            <a:spLocks noGrp="1"/>
-          </p:cNvSpPr>
-          <p:nvPr>
-            <p:ph type="title"/>
-          </p:nvPr>
-        </p:nvSpPr>
-        <p:spPr>
-          <a:xfrm>
-            <a:off x="838200" y="365126"/>
-            <a:ext cx="10515600" cy="662164"/>
-          </a:xfrm>
-        </p:spPr>
-        <p:txBody>
-          <a:bodyPr>
-            <a:normAutofit fontScale="90000"/>
-          </a:bodyPr>
-          <a:lstStyle/>
-          <a:p>
-            <a:r>
-              <a:rPr lang="en-GB" dirty="0">
-                <a:solidFill>
-                  <a:srgbClr val="003B66"/>
-                </a:solidFill>
-                <a:latin typeface="Aptos Display" panose="020B0004020202020204" pitchFamily="34" charset="0"/>
-              </a:rPr>
               <a:t>LabVIEW Ideas</a:t>
             </a:r>
           </a:p>
@@ -38140,7 +36195,7 @@
           <a:p>
             <a:fld id="{A5BC3523-C363-4BFA-8941-CE9ECEEECBA2}" type="slidenum">
               <a:rPr lang="en-GB" smtClean="0"/>
-              <a:t>55</a:t>
+              <a:t>50</a:t>
             </a:fld>
             <a:endParaRPr lang="en-GB" dirty="0"/>
           </a:p>
@@ -38305,7 +36360,7 @@
 </p:sld>
 </file>
 
-<file path=ppt/slides/slide56.xml><?xml version="1.0" encoding="utf-8"?>
+<file path=ppt/slides/slide51.xml><?xml version="1.0" encoding="utf-8"?>
 <p:sld xmlns:a="http://schemas.openxmlformats.org/drawingml/2006/main" xmlns:r="http://schemas.openxmlformats.org/officeDocument/2006/relationships" xmlns:p="http://schemas.openxmlformats.org/presentationml/2006/main">
   <p:cSld>
     <p:spTree>
@@ -38451,7 +36506,7 @@
           <a:p>
             <a:fld id="{A5BC3523-C363-4BFA-8941-CE9ECEEECBA2}" type="slidenum">
               <a:rPr lang="en-GB" smtClean="0"/>
-              <a:t>56</a:t>
+              <a:t>51</a:t>
             </a:fld>
             <a:endParaRPr lang="en-GB" dirty="0"/>
           </a:p>
@@ -38505,7 +36560,7 @@
 </p:sld>
 </file>
 
-<file path=ppt/slides/slide57.xml><?xml version="1.0" encoding="utf-8"?>
+<file path=ppt/slides/slide52.xml><?xml version="1.0" encoding="utf-8"?>
 <p:sld xmlns:a="http://schemas.openxmlformats.org/drawingml/2006/main" xmlns:r="http://schemas.openxmlformats.org/officeDocument/2006/relationships" xmlns:p="http://schemas.openxmlformats.org/presentationml/2006/main">
   <p:cSld>
     <p:spTree>
@@ -38734,7 +36789,7 @@
           <a:p>
             <a:fld id="{A5BC3523-C363-4BFA-8941-CE9ECEEECBA2}" type="slidenum">
               <a:rPr lang="en-GB" smtClean="0"/>
-              <a:t>57</a:t>
+              <a:t>52</a:t>
             </a:fld>
             <a:endParaRPr lang="en-GB" dirty="0"/>
           </a:p>
@@ -38789,7 +36844,7 @@
 </p:sld>
 </file>
 
-<file path=ppt/slides/slide58.xml><?xml version="1.0" encoding="utf-8"?>
+<file path=ppt/slides/slide53.xml><?xml version="1.0" encoding="utf-8"?>
 <p:sld xmlns:a="http://schemas.openxmlformats.org/drawingml/2006/main" xmlns:r="http://schemas.openxmlformats.org/officeDocument/2006/relationships" xmlns:p="http://schemas.openxmlformats.org/presentationml/2006/main">
   <p:cSld>
     <p:spTree>
@@ -38986,7 +37041,7 @@
           <a:p>
             <a:fld id="{A5BC3523-C363-4BFA-8941-CE9ECEEECBA2}" type="slidenum">
               <a:rPr lang="en-GB" smtClean="0"/>
-              <a:t>58</a:t>
+              <a:t>53</a:t>
             </a:fld>
             <a:endParaRPr lang="en-GB" dirty="0"/>
           </a:p>
@@ -39040,7 +37095,7 @@
 </p:sld>
 </file>
 
-<file path=ppt/slides/slide59.xml><?xml version="1.0" encoding="utf-8"?>
+<file path=ppt/slides/slide54.xml><?xml version="1.0" encoding="utf-8"?>
 <p:sld xmlns:a="http://schemas.openxmlformats.org/drawingml/2006/main" xmlns:r="http://schemas.openxmlformats.org/officeDocument/2006/relationships" xmlns:p="http://schemas.openxmlformats.org/presentationml/2006/main">
   <p:cSld>
     <p:spTree>
@@ -39138,7 +37193,7 @@
                 </a:solidFill>
                 <a:latin typeface="Aptos" panose="020B0004020202020204" pitchFamily="34" charset="0"/>
               </a:rPr>
-              <a:t>I published these 3 free, open-source packages around 3 years ago, which is before I became aware of everything I discussed so far. These packages do use lots of NR VIs. I aim to release new versions soon that will use more PCR VIs and will be more performant.</a:t>
+              <a:t>I published these free, open-source packages around 3 years ago, which is before I became fully aware of everything that was discussed so far. These packages use lots of NR VIs. I aim to release new versions soon that will use the PCR setting more and will be more performant.</a:t>
             </a:r>
             <a:endParaRPr lang="en-GB" sz="1600" dirty="0">
               <a:solidFill>
@@ -39172,7 +37227,7 @@
           <a:p>
             <a:fld id="{A5BC3523-C363-4BFA-8941-CE9ECEEECBA2}" type="slidenum">
               <a:rPr lang="en-GB" smtClean="0"/>
-              <a:t>59</a:t>
+              <a:t>54</a:t>
             </a:fld>
             <a:endParaRPr lang="en-GB" dirty="0"/>
           </a:p>
@@ -39227,224 +37282,7 @@
 </p:sld>
 </file>
 
-<file path=ppt/slides/slide6.xml><?xml version="1.0" encoding="utf-8"?>
-<p:sld xmlns:a="http://schemas.openxmlformats.org/drawingml/2006/main" xmlns:r="http://schemas.openxmlformats.org/officeDocument/2006/relationships" xmlns:p="http://schemas.openxmlformats.org/presentationml/2006/main">
-  <p:cSld>
-    <p:spTree>
-      <p:nvGrpSpPr>
-        <p:cNvPr id="1" name="">
-          <a:extLst>
-            <a:ext uri="{FF2B5EF4-FFF2-40B4-BE49-F238E27FC236}">
-              <a16:creationId xmlns:a16="http://schemas.microsoft.com/office/drawing/2014/main" id="{C98B7E18-119B-64E0-45E5-EF3C612EDF92}"/>
-            </a:ext>
-          </a:extLst>
-        </p:cNvPr>
-        <p:cNvGrpSpPr/>
-        <p:nvPr/>
-      </p:nvGrpSpPr>
-      <p:grpSpPr>
-        <a:xfrm>
-          <a:off x="0" y="0"/>
-          <a:ext cx="0" cy="0"/>
-          <a:chOff x="0" y="0"/>
-          <a:chExt cx="0" cy="0"/>
-        </a:xfrm>
-      </p:grpSpPr>
-      <p:sp>
-        <p:nvSpPr>
-          <p:cNvPr id="2" name="Title 1">
-            <a:extLst>
-              <a:ext uri="{FF2B5EF4-FFF2-40B4-BE49-F238E27FC236}">
-                <a16:creationId xmlns:a16="http://schemas.microsoft.com/office/drawing/2014/main" id="{50414F07-AD9B-E579-7944-B16DA312357A}"/>
-              </a:ext>
-            </a:extLst>
-          </p:cNvPr>
-          <p:cNvSpPr>
-            <a:spLocks noGrp="1"/>
-          </p:cNvSpPr>
-          <p:nvPr>
-            <p:ph type="title"/>
-          </p:nvPr>
-        </p:nvSpPr>
-        <p:spPr>
-          <a:xfrm>
-            <a:off x="838200" y="365126"/>
-            <a:ext cx="10515600" cy="662164"/>
-          </a:xfrm>
-        </p:spPr>
-        <p:txBody>
-          <a:bodyPr>
-            <a:normAutofit fontScale="90000"/>
-          </a:bodyPr>
-          <a:lstStyle/>
-          <a:p>
-            <a:r>
-              <a:rPr lang="en-GB" dirty="0">
-                <a:solidFill>
-                  <a:srgbClr val="003B66"/>
-                </a:solidFill>
-                <a:latin typeface="Aptos Display" panose="020B0004020202020204" pitchFamily="34" charset="0"/>
-              </a:rPr>
-              <a:t>Questions</a:t>
-            </a:r>
-          </a:p>
-        </p:txBody>
-      </p:sp>
-      <p:sp>
-        <p:nvSpPr>
-          <p:cNvPr id="3" name="Content Placeholder 2">
-            <a:extLst>
-              <a:ext uri="{FF2B5EF4-FFF2-40B4-BE49-F238E27FC236}">
-                <a16:creationId xmlns:a16="http://schemas.microsoft.com/office/drawing/2014/main" id="{990BA7BB-348A-E88C-0391-EB2B490A98BA}"/>
-              </a:ext>
-            </a:extLst>
-          </p:cNvPr>
-          <p:cNvSpPr>
-            <a:spLocks noGrp="1"/>
-          </p:cNvSpPr>
-          <p:nvPr>
-            <p:ph idx="1"/>
-          </p:nvPr>
-        </p:nvSpPr>
-        <p:spPr>
-          <a:xfrm>
-            <a:off x="838200" y="1027290"/>
-            <a:ext cx="10515600" cy="1253897"/>
-          </a:xfrm>
-        </p:spPr>
-        <p:txBody>
-          <a:bodyPr>
-            <a:normAutofit/>
-          </a:bodyPr>
-          <a:lstStyle/>
-          <a:p>
-            <a:r>
-              <a:rPr lang="en-GB" sz="2000" dirty="0">
-                <a:solidFill>
-                  <a:srgbClr val="003B66"/>
-                </a:solidFill>
-                <a:latin typeface="Aptos" panose="020B0004020202020204" pitchFamily="34" charset="0"/>
-              </a:rPr>
-              <a:t>Please ask questions at the end of the presentation and in the dedicated Discord channel. I will reply to every question or comment made on Discord.</a:t>
-            </a:r>
-          </a:p>
-        </p:txBody>
-      </p:sp>
-      <p:sp>
-        <p:nvSpPr>
-          <p:cNvPr id="4" name="Slide Number Placeholder 3">
-            <a:extLst>
-              <a:ext uri="{FF2B5EF4-FFF2-40B4-BE49-F238E27FC236}">
-                <a16:creationId xmlns:a16="http://schemas.microsoft.com/office/drawing/2014/main" id="{EFD20438-6BAF-3983-658F-C35B24AEA6BE}"/>
-              </a:ext>
-            </a:extLst>
-          </p:cNvPr>
-          <p:cNvSpPr>
-            <a:spLocks noGrp="1"/>
-          </p:cNvSpPr>
-          <p:nvPr>
-            <p:ph type="sldNum" sz="quarter" idx="12"/>
-          </p:nvPr>
-        </p:nvSpPr>
-        <p:spPr/>
-        <p:txBody>
-          <a:bodyPr/>
-          <a:lstStyle/>
-          <a:p>
-            <a:fld id="{A5BC3523-C363-4BFA-8941-CE9ECEEECBA2}" type="slidenum">
-              <a:rPr lang="en-GB" smtClean="0"/>
-              <a:t>6</a:t>
-            </a:fld>
-            <a:endParaRPr lang="en-GB" dirty="0"/>
-          </a:p>
-        </p:txBody>
-      </p:sp>
-      <p:pic>
-        <p:nvPicPr>
-          <p:cNvPr id="6" name="Picture 5">
-            <a:extLst>
-              <a:ext uri="{FF2B5EF4-FFF2-40B4-BE49-F238E27FC236}">
-                <a16:creationId xmlns:a16="http://schemas.microsoft.com/office/drawing/2014/main" id="{15CCD54F-8246-5929-83E9-F20DDA566642}"/>
-              </a:ext>
-            </a:extLst>
-          </p:cNvPr>
-          <p:cNvPicPr>
-            <a:picLocks noChangeAspect="1"/>
-          </p:cNvPicPr>
-          <p:nvPr/>
-        </p:nvPicPr>
-        <p:blipFill>
-          <a:blip r:embed="rId3">
-            <a:extLst>
-              <a:ext uri="{28A0092B-C50C-407E-A947-70E740481C1C}">
-                <a14:useLocalDpi xmlns:a14="http://schemas.microsoft.com/office/drawing/2010/main" val="0"/>
-              </a:ext>
-            </a:extLst>
-          </a:blip>
-          <a:stretch>
-            <a:fillRect/>
-          </a:stretch>
-        </p:blipFill>
-        <p:spPr>
-          <a:xfrm>
-            <a:off x="838200" y="1689454"/>
-            <a:ext cx="3391373" cy="5039428"/>
-          </a:xfrm>
-          <a:prstGeom prst="rect">
-            <a:avLst/>
-          </a:prstGeom>
-        </p:spPr>
-      </p:pic>
-      <p:pic>
-        <p:nvPicPr>
-          <p:cNvPr id="8" name="Picture 7">
-            <a:extLst>
-              <a:ext uri="{FF2B5EF4-FFF2-40B4-BE49-F238E27FC236}">
-                <a16:creationId xmlns:a16="http://schemas.microsoft.com/office/drawing/2014/main" id="{FFB0C26B-6650-8B9A-27B7-8C573CE1AFB4}"/>
-              </a:ext>
-            </a:extLst>
-          </p:cNvPr>
-          <p:cNvPicPr>
-            <a:picLocks noChangeAspect="1"/>
-          </p:cNvPicPr>
-          <p:nvPr/>
-        </p:nvPicPr>
-        <p:blipFill>
-          <a:blip r:embed="rId4">
-            <a:extLst>
-              <a:ext uri="{28A0092B-C50C-407E-A947-70E740481C1C}">
-                <a14:useLocalDpi xmlns:a14="http://schemas.microsoft.com/office/drawing/2010/main" val="0"/>
-              </a:ext>
-            </a:extLst>
-          </a:blip>
-          <a:stretch>
-            <a:fillRect/>
-          </a:stretch>
-        </p:blipFill>
-        <p:spPr>
-          <a:xfrm>
-            <a:off x="4451614" y="1689454"/>
-            <a:ext cx="2700000" cy="4735513"/>
-          </a:xfrm>
-          <a:prstGeom prst="rect">
-            <a:avLst/>
-          </a:prstGeom>
-        </p:spPr>
-      </p:pic>
-    </p:spTree>
-    <p:extLst>
-      <p:ext uri="{BB962C8B-B14F-4D97-AF65-F5344CB8AC3E}">
-        <p14:creationId xmlns:p14="http://schemas.microsoft.com/office/powerpoint/2010/main" val="3252061306"/>
-      </p:ext>
-    </p:extLst>
-  </p:cSld>
-  <p:clrMapOvr>
-    <a:masterClrMapping/>
-  </p:clrMapOvr>
-</p:sld>
-</file>
-
-<file path=ppt/slides/slide60.xml><?xml version="1.0" encoding="utf-8"?>
+<file path=ppt/slides/slide55.xml><?xml version="1.0" encoding="utf-8"?>
 <p:sld xmlns:a="http://schemas.openxmlformats.org/drawingml/2006/main" xmlns:r="http://schemas.openxmlformats.org/officeDocument/2006/relationships" xmlns:p="http://schemas.openxmlformats.org/presentationml/2006/main">
   <p:cSld>
     <p:spTree>
@@ -39592,7 +37430,7 @@
           <a:p>
             <a:fld id="{A5BC3523-C363-4BFA-8941-CE9ECEEECBA2}" type="slidenum">
               <a:rPr lang="en-GB" smtClean="0"/>
-              <a:t>60</a:t>
+              <a:t>55</a:t>
             </a:fld>
             <a:endParaRPr lang="en-GB" dirty="0"/>
           </a:p>
@@ -39739,7 +37577,7 @@
 </p:sld>
 </file>
 
-<file path=ppt/slides/slide61.xml><?xml version="1.0" encoding="utf-8"?>
+<file path=ppt/slides/slide56.xml><?xml version="1.0" encoding="utf-8"?>
 <p:sld xmlns:a="http://schemas.openxmlformats.org/drawingml/2006/main" xmlns:r="http://schemas.openxmlformats.org/officeDocument/2006/relationships" xmlns:p="http://schemas.openxmlformats.org/presentationml/2006/main">
   <p:cSld>
     <p:spTree>
@@ -39863,7 +37701,7 @@
           <a:p>
             <a:fld id="{A5BC3523-C363-4BFA-8941-CE9ECEEECBA2}" type="slidenum">
               <a:rPr lang="en-GB" smtClean="0"/>
-              <a:t>61</a:t>
+              <a:t>56</a:t>
             </a:fld>
             <a:endParaRPr lang="en-GB" dirty="0"/>
           </a:p>
@@ -39882,7 +37720,7 @@
 </p:sld>
 </file>
 
-<file path=ppt/slides/slide62.xml><?xml version="1.0" encoding="utf-8"?>
+<file path=ppt/slides/slide57.xml><?xml version="1.0" encoding="utf-8"?>
 <p:sld xmlns:a="http://schemas.openxmlformats.org/drawingml/2006/main" xmlns:r="http://schemas.openxmlformats.org/officeDocument/2006/relationships" xmlns:p="http://schemas.openxmlformats.org/presentationml/2006/main">
   <p:cSld>
     <p:spTree>
@@ -39968,7 +37806,7 @@
           <a:p>
             <a:fld id="{A5BC3523-C363-4BFA-8941-CE9ECEEECBA2}" type="slidenum">
               <a:rPr lang="en-GB" smtClean="0"/>
-              <a:t>62</a:t>
+              <a:t>57</a:t>
             </a:fld>
             <a:endParaRPr lang="en-GB" dirty="0"/>
           </a:p>
@@ -40025,7 +37863,7 @@
 </p:sld>
 </file>
 
-<file path=ppt/slides/slide63.xml><?xml version="1.0" encoding="utf-8"?>
+<file path=ppt/slides/slide58.xml><?xml version="1.0" encoding="utf-8"?>
 <p:sld xmlns:a="http://schemas.openxmlformats.org/drawingml/2006/main" xmlns:r="http://schemas.openxmlformats.org/officeDocument/2006/relationships" xmlns:p="http://schemas.openxmlformats.org/presentationml/2006/main">
   <p:cSld>
     <p:spTree>
@@ -40111,7 +37949,7 @@
           <a:p>
             <a:fld id="{A5BC3523-C363-4BFA-8941-CE9ECEEECBA2}" type="slidenum">
               <a:rPr lang="en-GB" smtClean="0"/>
-              <a:t>63</a:t>
+              <a:t>58</a:t>
             </a:fld>
             <a:endParaRPr lang="en-GB" dirty="0"/>
           </a:p>
@@ -40497,7 +38335,7 @@
 </p:sld>
 </file>
 
-<file path=ppt/slides/slide64.xml><?xml version="1.0" encoding="utf-8"?>
+<file path=ppt/slides/slide59.xml><?xml version="1.0" encoding="utf-8"?>
 <p:sld xmlns:a="http://schemas.openxmlformats.org/drawingml/2006/main" xmlns:r="http://schemas.openxmlformats.org/officeDocument/2006/relationships" xmlns:p="http://schemas.openxmlformats.org/presentationml/2006/main">
   <p:cSld>
     <p:spTree>
@@ -40583,7 +38421,7 @@
           <a:p>
             <a:fld id="{A5BC3523-C363-4BFA-8941-CE9ECEEECBA2}" type="slidenum">
               <a:rPr lang="en-GB" smtClean="0"/>
-              <a:t>64</a:t>
+              <a:t>59</a:t>
             </a:fld>
             <a:endParaRPr lang="en-GB" dirty="0"/>
           </a:p>
@@ -41171,7 +39009,224 @@
 </p:sld>
 </file>
 
-<file path=ppt/slides/slide65.xml><?xml version="1.0" encoding="utf-8"?>
+<file path=ppt/slides/slide6.xml><?xml version="1.0" encoding="utf-8"?>
+<p:sld xmlns:a="http://schemas.openxmlformats.org/drawingml/2006/main" xmlns:r="http://schemas.openxmlformats.org/officeDocument/2006/relationships" xmlns:p="http://schemas.openxmlformats.org/presentationml/2006/main">
+  <p:cSld>
+    <p:spTree>
+      <p:nvGrpSpPr>
+        <p:cNvPr id="1" name="">
+          <a:extLst>
+            <a:ext uri="{FF2B5EF4-FFF2-40B4-BE49-F238E27FC236}">
+              <a16:creationId xmlns:a16="http://schemas.microsoft.com/office/drawing/2014/main" id="{C98B7E18-119B-64E0-45E5-EF3C612EDF92}"/>
+            </a:ext>
+          </a:extLst>
+        </p:cNvPr>
+        <p:cNvGrpSpPr/>
+        <p:nvPr/>
+      </p:nvGrpSpPr>
+      <p:grpSpPr>
+        <a:xfrm>
+          <a:off x="0" y="0"/>
+          <a:ext cx="0" cy="0"/>
+          <a:chOff x="0" y="0"/>
+          <a:chExt cx="0" cy="0"/>
+        </a:xfrm>
+      </p:grpSpPr>
+      <p:sp>
+        <p:nvSpPr>
+          <p:cNvPr id="2" name="Title 1">
+            <a:extLst>
+              <a:ext uri="{FF2B5EF4-FFF2-40B4-BE49-F238E27FC236}">
+                <a16:creationId xmlns:a16="http://schemas.microsoft.com/office/drawing/2014/main" id="{50414F07-AD9B-E579-7944-B16DA312357A}"/>
+              </a:ext>
+            </a:extLst>
+          </p:cNvPr>
+          <p:cNvSpPr>
+            <a:spLocks noGrp="1"/>
+          </p:cNvSpPr>
+          <p:nvPr>
+            <p:ph type="title"/>
+          </p:nvPr>
+        </p:nvSpPr>
+        <p:spPr>
+          <a:xfrm>
+            <a:off x="838200" y="365126"/>
+            <a:ext cx="10515600" cy="662164"/>
+          </a:xfrm>
+        </p:spPr>
+        <p:txBody>
+          <a:bodyPr>
+            <a:normAutofit fontScale="90000"/>
+          </a:bodyPr>
+          <a:lstStyle/>
+          <a:p>
+            <a:r>
+              <a:rPr lang="en-GB" dirty="0">
+                <a:solidFill>
+                  <a:srgbClr val="003B66"/>
+                </a:solidFill>
+                <a:latin typeface="Aptos Display" panose="020B0004020202020204" pitchFamily="34" charset="0"/>
+              </a:rPr>
+              <a:t>Questions</a:t>
+            </a:r>
+          </a:p>
+        </p:txBody>
+      </p:sp>
+      <p:sp>
+        <p:nvSpPr>
+          <p:cNvPr id="3" name="Content Placeholder 2">
+            <a:extLst>
+              <a:ext uri="{FF2B5EF4-FFF2-40B4-BE49-F238E27FC236}">
+                <a16:creationId xmlns:a16="http://schemas.microsoft.com/office/drawing/2014/main" id="{990BA7BB-348A-E88C-0391-EB2B490A98BA}"/>
+              </a:ext>
+            </a:extLst>
+          </p:cNvPr>
+          <p:cNvSpPr>
+            <a:spLocks noGrp="1"/>
+          </p:cNvSpPr>
+          <p:nvPr>
+            <p:ph idx="1"/>
+          </p:nvPr>
+        </p:nvSpPr>
+        <p:spPr>
+          <a:xfrm>
+            <a:off x="838200" y="1027290"/>
+            <a:ext cx="10515600" cy="1253897"/>
+          </a:xfrm>
+        </p:spPr>
+        <p:txBody>
+          <a:bodyPr>
+            <a:normAutofit/>
+          </a:bodyPr>
+          <a:lstStyle/>
+          <a:p>
+            <a:r>
+              <a:rPr lang="en-GB" sz="2000" dirty="0">
+                <a:solidFill>
+                  <a:srgbClr val="003B66"/>
+                </a:solidFill>
+                <a:latin typeface="Aptos" panose="020B0004020202020204" pitchFamily="34" charset="0"/>
+              </a:rPr>
+              <a:t>Please ask questions at the end of the presentation and in the dedicated Discord channel. I will reply to every question or comment made on Discord.</a:t>
+            </a:r>
+          </a:p>
+        </p:txBody>
+      </p:sp>
+      <p:sp>
+        <p:nvSpPr>
+          <p:cNvPr id="4" name="Slide Number Placeholder 3">
+            <a:extLst>
+              <a:ext uri="{FF2B5EF4-FFF2-40B4-BE49-F238E27FC236}">
+                <a16:creationId xmlns:a16="http://schemas.microsoft.com/office/drawing/2014/main" id="{EFD20438-6BAF-3983-658F-C35B24AEA6BE}"/>
+              </a:ext>
+            </a:extLst>
+          </p:cNvPr>
+          <p:cNvSpPr>
+            <a:spLocks noGrp="1"/>
+          </p:cNvSpPr>
+          <p:nvPr>
+            <p:ph type="sldNum" sz="quarter" idx="12"/>
+          </p:nvPr>
+        </p:nvSpPr>
+        <p:spPr/>
+        <p:txBody>
+          <a:bodyPr/>
+          <a:lstStyle/>
+          <a:p>
+            <a:fld id="{A5BC3523-C363-4BFA-8941-CE9ECEEECBA2}" type="slidenum">
+              <a:rPr lang="en-GB" smtClean="0"/>
+              <a:t>6</a:t>
+            </a:fld>
+            <a:endParaRPr lang="en-GB" dirty="0"/>
+          </a:p>
+        </p:txBody>
+      </p:sp>
+      <p:pic>
+        <p:nvPicPr>
+          <p:cNvPr id="6" name="Picture 5">
+            <a:extLst>
+              <a:ext uri="{FF2B5EF4-FFF2-40B4-BE49-F238E27FC236}">
+                <a16:creationId xmlns:a16="http://schemas.microsoft.com/office/drawing/2014/main" id="{15CCD54F-8246-5929-83E9-F20DDA566642}"/>
+              </a:ext>
+            </a:extLst>
+          </p:cNvPr>
+          <p:cNvPicPr>
+            <a:picLocks noChangeAspect="1"/>
+          </p:cNvPicPr>
+          <p:nvPr/>
+        </p:nvPicPr>
+        <p:blipFill>
+          <a:blip r:embed="rId3">
+            <a:extLst>
+              <a:ext uri="{28A0092B-C50C-407E-A947-70E740481C1C}">
+                <a14:useLocalDpi xmlns:a14="http://schemas.microsoft.com/office/drawing/2010/main" val="0"/>
+              </a:ext>
+            </a:extLst>
+          </a:blip>
+          <a:stretch>
+            <a:fillRect/>
+          </a:stretch>
+        </p:blipFill>
+        <p:spPr>
+          <a:xfrm>
+            <a:off x="838200" y="1689454"/>
+            <a:ext cx="3391373" cy="5039428"/>
+          </a:xfrm>
+          <a:prstGeom prst="rect">
+            <a:avLst/>
+          </a:prstGeom>
+        </p:spPr>
+      </p:pic>
+      <p:pic>
+        <p:nvPicPr>
+          <p:cNvPr id="8" name="Picture 7">
+            <a:extLst>
+              <a:ext uri="{FF2B5EF4-FFF2-40B4-BE49-F238E27FC236}">
+                <a16:creationId xmlns:a16="http://schemas.microsoft.com/office/drawing/2014/main" id="{FFB0C26B-6650-8B9A-27B7-8C573CE1AFB4}"/>
+              </a:ext>
+            </a:extLst>
+          </p:cNvPr>
+          <p:cNvPicPr>
+            <a:picLocks noChangeAspect="1"/>
+          </p:cNvPicPr>
+          <p:nvPr/>
+        </p:nvPicPr>
+        <p:blipFill>
+          <a:blip r:embed="rId4">
+            <a:extLst>
+              <a:ext uri="{28A0092B-C50C-407E-A947-70E740481C1C}">
+                <a14:useLocalDpi xmlns:a14="http://schemas.microsoft.com/office/drawing/2010/main" val="0"/>
+              </a:ext>
+            </a:extLst>
+          </a:blip>
+          <a:stretch>
+            <a:fillRect/>
+          </a:stretch>
+        </p:blipFill>
+        <p:spPr>
+          <a:xfrm>
+            <a:off x="4451614" y="1689454"/>
+            <a:ext cx="2700000" cy="4735513"/>
+          </a:xfrm>
+          <a:prstGeom prst="rect">
+            <a:avLst/>
+          </a:prstGeom>
+        </p:spPr>
+      </p:pic>
+    </p:spTree>
+    <p:extLst>
+      <p:ext uri="{BB962C8B-B14F-4D97-AF65-F5344CB8AC3E}">
+        <p14:creationId xmlns:p14="http://schemas.microsoft.com/office/powerpoint/2010/main" val="3252061306"/>
+      </p:ext>
+    </p:extLst>
+  </p:cSld>
+  <p:clrMapOvr>
+    <a:masterClrMapping/>
+  </p:clrMapOvr>
+</p:sld>
+</file>
+
+<file path=ppt/slides/slide60.xml><?xml version="1.0" encoding="utf-8"?>
 <p:sld xmlns:a="http://schemas.openxmlformats.org/drawingml/2006/main" xmlns:r="http://schemas.openxmlformats.org/officeDocument/2006/relationships" xmlns:p="http://schemas.openxmlformats.org/presentationml/2006/main">
   <p:cSld>
     <p:spTree>
@@ -41257,7 +39312,7 @@
           <a:p>
             <a:fld id="{A5BC3523-C363-4BFA-8941-CE9ECEEECBA2}" type="slidenum">
               <a:rPr lang="en-GB" smtClean="0"/>
-              <a:t>65</a:t>
+              <a:t>60</a:t>
             </a:fld>
             <a:endParaRPr lang="en-GB" dirty="0"/>
           </a:p>
@@ -41595,7 +39650,7 @@
 </p:sld>
 </file>
 
-<file path=ppt/slides/slide66.xml><?xml version="1.0" encoding="utf-8"?>
+<file path=ppt/slides/slide61.xml><?xml version="1.0" encoding="utf-8"?>
 <p:sld xmlns:a="http://schemas.openxmlformats.org/drawingml/2006/main" xmlns:r="http://schemas.openxmlformats.org/officeDocument/2006/relationships" xmlns:p="http://schemas.openxmlformats.org/presentationml/2006/main">
   <p:cSld>
     <p:spTree>
@@ -41681,7 +39736,7 @@
           <a:p>
             <a:fld id="{A5BC3523-C363-4BFA-8941-CE9ECEEECBA2}" type="slidenum">
               <a:rPr lang="en-GB" smtClean="0"/>
-              <a:t>66</a:t>
+              <a:t>61</a:t>
             </a:fld>
             <a:endParaRPr lang="en-GB" dirty="0"/>
           </a:p>
@@ -42040,7 +40095,7 @@
 </p:sld>
 </file>
 
-<file path=ppt/slides/slide67.xml><?xml version="1.0" encoding="utf-8"?>
+<file path=ppt/slides/slide62.xml><?xml version="1.0" encoding="utf-8"?>
 <p:sld xmlns:a="http://schemas.openxmlformats.org/drawingml/2006/main" xmlns:r="http://schemas.openxmlformats.org/officeDocument/2006/relationships" xmlns:p="http://schemas.openxmlformats.org/presentationml/2006/main">
   <p:cSld>
     <p:spTree>
@@ -42126,7 +40181,7 @@
           <a:p>
             <a:fld id="{A5BC3523-C363-4BFA-8941-CE9ECEEECBA2}" type="slidenum">
               <a:rPr lang="en-GB" smtClean="0"/>
-              <a:t>67</a:t>
+              <a:t>62</a:t>
             </a:fld>
             <a:endParaRPr lang="en-GB" dirty="0"/>
           </a:p>
@@ -42905,7 +40960,7 @@
 </p:sld>
 </file>
 
-<file path=ppt/slides/slide68.xml><?xml version="1.0" encoding="utf-8"?>
+<file path=ppt/slides/slide63.xml><?xml version="1.0" encoding="utf-8"?>
 <p:sld xmlns:a="http://schemas.openxmlformats.org/drawingml/2006/main" xmlns:r="http://schemas.openxmlformats.org/officeDocument/2006/relationships" xmlns:p="http://schemas.openxmlformats.org/presentationml/2006/main">
   <p:cSld>
     <p:spTree>
@@ -42991,7 +41046,7 @@
           <a:p>
             <a:fld id="{A5BC3523-C363-4BFA-8941-CE9ECEEECBA2}" type="slidenum">
               <a:rPr lang="en-GB" smtClean="0"/>
-              <a:t>68</a:t>
+              <a:t>63</a:t>
             </a:fld>
             <a:endParaRPr lang="en-GB" dirty="0"/>
           </a:p>
@@ -43500,7 +41555,7 @@
 </p:sld>
 </file>
 
-<file path=ppt/slides/slide69.xml><?xml version="1.0" encoding="utf-8"?>
+<file path=ppt/slides/slide64.xml><?xml version="1.0" encoding="utf-8"?>
 <p:sld xmlns:a="http://schemas.openxmlformats.org/drawingml/2006/main" xmlns:r="http://schemas.openxmlformats.org/officeDocument/2006/relationships" xmlns:p="http://schemas.openxmlformats.org/presentationml/2006/main">
   <p:cSld>
     <p:spTree>
@@ -43540,7 +41595,7 @@
           <a:p>
             <a:fld id="{A5BC3523-C363-4BFA-8941-CE9ECEEECBA2}" type="slidenum">
               <a:rPr lang="en-GB" smtClean="0"/>
-              <a:t>69</a:t>
+              <a:t>64</a:t>
             </a:fld>
             <a:endParaRPr lang="en-GB" dirty="0"/>
           </a:p>

</xml_diff>

<commit_message>
Correction to slide 22
</commit_message>
<xml_diff>
--- a/2026-09-23 LabVIEW Multithreading and VI Execution Settings (GDevCon7).pptx
+++ b/2026-09-23 LabVIEW Multithreading and VI Execution Settings (GDevCon7).pptx
@@ -1425,7 +1425,7 @@
           <a:p>
             <a:fld id="{61BF1AFD-5C90-46ED-91E2-3D560695B6F7}" type="datetimeFigureOut">
               <a:rPr lang="en-GB" smtClean="0"/>
-              <a:t>23/09/2026</a:t>
+              <a:t>24/09/2026</a:t>
             </a:fld>
             <a:endParaRPr lang="en-GB"/>
           </a:p>
@@ -9974,7 +9974,7 @@
           <a:p>
             <a:fld id="{0C5C33A4-172A-4A95-9286-07BC7486F6DA}" type="datetime1">
               <a:rPr lang="en-GB" smtClean="0"/>
-              <a:t>23/09/2026</a:t>
+              <a:t>24/09/2026</a:t>
             </a:fld>
             <a:endParaRPr lang="en-GB"/>
           </a:p>
@@ -10174,7 +10174,7 @@
           <a:p>
             <a:fld id="{67D7B363-7FE0-4B5C-AA52-4AB00EFF9418}" type="datetime1">
               <a:rPr lang="en-GB" smtClean="0"/>
-              <a:t>23/09/2026</a:t>
+              <a:t>24/09/2026</a:t>
             </a:fld>
             <a:endParaRPr lang="en-GB"/>
           </a:p>
@@ -10384,7 +10384,7 @@
           <a:p>
             <a:fld id="{F698CEA5-3A39-49A5-9435-4C2F63733D59}" type="datetime1">
               <a:rPr lang="en-GB" smtClean="0"/>
-              <a:t>23/09/2026</a:t>
+              <a:t>24/09/2026</a:t>
             </a:fld>
             <a:endParaRPr lang="en-GB"/>
           </a:p>
@@ -10595,7 +10595,7 @@
           <a:p>
             <a:fld id="{BEDB2B52-634B-4FE3-9CB1-4F17872ECC19}" type="datetime1">
               <a:rPr lang="en-GB" smtClean="0"/>
-              <a:t>23/09/2026</a:t>
+              <a:t>24/09/2026</a:t>
             </a:fld>
             <a:endParaRPr lang="en-GB"/>
           </a:p>
@@ -10925,7 +10925,7 @@
           <a:p>
             <a:fld id="{3BEE3078-4A4A-48DB-9B9A-38CD660D0699}" type="datetime1">
               <a:rPr lang="en-GB" smtClean="0"/>
-              <a:t>23/09/2026</a:t>
+              <a:t>24/09/2026</a:t>
             </a:fld>
             <a:endParaRPr lang="en-GB"/>
           </a:p>
@@ -11193,7 +11193,7 @@
           <a:p>
             <a:fld id="{061736D3-8CB9-4B1F-9FA0-8A791D30583C}" type="datetime1">
               <a:rPr lang="en-GB" smtClean="0"/>
-              <a:t>23/09/2026</a:t>
+              <a:t>24/09/2026</a:t>
             </a:fld>
             <a:endParaRPr lang="en-GB"/>
           </a:p>
@@ -11608,7 +11608,7 @@
           <a:p>
             <a:fld id="{12B9BA19-C9B8-4135-BA9F-D058BE5FC515}" type="datetime1">
               <a:rPr lang="en-GB" smtClean="0"/>
-              <a:t>23/09/2026</a:t>
+              <a:t>24/09/2026</a:t>
             </a:fld>
             <a:endParaRPr lang="en-GB"/>
           </a:p>
@@ -11750,7 +11750,7 @@
           <a:p>
             <a:fld id="{70D2F5E2-01C2-44C9-AD10-BDEB53FACCEB}" type="datetime1">
               <a:rPr lang="en-GB" smtClean="0"/>
-              <a:t>23/09/2026</a:t>
+              <a:t>24/09/2026</a:t>
             </a:fld>
             <a:endParaRPr lang="en-GB"/>
           </a:p>
@@ -11863,7 +11863,7 @@
           <a:p>
             <a:fld id="{3981DE2F-7974-482C-8DDA-7054DC5FECDD}" type="datetime1">
               <a:rPr lang="en-GB" smtClean="0"/>
-              <a:t>23/09/2026</a:t>
+              <a:t>24/09/2026</a:t>
             </a:fld>
             <a:endParaRPr lang="en-GB"/>
           </a:p>
@@ -12176,7 +12176,7 @@
           <a:p>
             <a:fld id="{75D3A193-B0C6-4186-B10B-252811725895}" type="datetime1">
               <a:rPr lang="en-GB" smtClean="0"/>
-              <a:t>23/09/2026</a:t>
+              <a:t>24/09/2026</a:t>
             </a:fld>
             <a:endParaRPr lang="en-GB"/>
           </a:p>
@@ -12465,7 +12465,7 @@
           <a:p>
             <a:fld id="{1D98AAE4-9F8F-4873-A5CF-52F66B567CFA}" type="datetime1">
               <a:rPr lang="en-GB" smtClean="0"/>
-              <a:t>23/09/2026</a:t>
+              <a:t>24/09/2026</a:t>
             </a:fld>
             <a:endParaRPr lang="en-GB"/>
           </a:p>
@@ -12708,7 +12708,7 @@
           <a:p>
             <a:fld id="{F6017F57-0928-4AB4-9227-68A9D0F44877}" type="datetime1">
               <a:rPr lang="en-GB" smtClean="0"/>
-              <a:t>23/09/2026</a:t>
+              <a:t>24/09/2026</a:t>
             </a:fld>
             <a:endParaRPr lang="en-GB"/>
           </a:p>
@@ -24622,7 +24622,7 @@
                 </a:solidFill>
                 <a:latin typeface="Aptos" panose="020B0004020202020204" pitchFamily="34" charset="0"/>
               </a:rPr>
-              <a:t>Let a codebase contain 20 call sites of a VI. Let the codebase function in such a way that a maximum of 3 call sites execute at the same time. All 20 call sites are used, but a maximum of 3 are used at the same time. If the VI is set to PCR, 100 instances will exist in memory. If the VI is set to SCR, a maximum of 3 instances will exist in memory. The 3 instances are sufficient to service all call sites while avoiding collisions. Thus, a reduction of 17 memory instances.</a:t>
+              <a:t>Let a codebase contain 20 call sites of a VI. Let the codebase function in such a way that a maximum of 3 call sites execute at the same time. All 20 call sites are used, but a maximum of 3 are used at the same time. If the VI is set to PCR, 20 instances will exist in memory. If the VI is set to SCR, a maximum of 3 instances will exist in memory. The 3 instances are sufficient to service all call sites while avoiding collisions. Thus, a reduction of 17 memory instances.</a:t>
             </a:r>
           </a:p>
           <a:p>

</xml_diff>

<commit_message>
Small improvement to slide 21
</commit_message>
<xml_diff>
--- a/2026-09-23 LabVIEW Multithreading and VI Execution Settings (GDevCon7).pptx
+++ b/2026-09-23 LabVIEW Multithreading and VI Execution Settings (GDevCon7).pptx
@@ -1425,7 +1425,7 @@
           <a:p>
             <a:fld id="{61BF1AFD-5C90-46ED-91E2-3D560695B6F7}" type="datetimeFigureOut">
               <a:rPr lang="en-GB" smtClean="0"/>
-              <a:t>24/09/2026</a:t>
+              <a:t>25/09/2026</a:t>
             </a:fld>
             <a:endParaRPr lang="en-GB"/>
           </a:p>
@@ -9974,7 +9974,7 @@
           <a:p>
             <a:fld id="{0C5C33A4-172A-4A95-9286-07BC7486F6DA}" type="datetime1">
               <a:rPr lang="en-GB" smtClean="0"/>
-              <a:t>24/09/2026</a:t>
+              <a:t>25/09/2026</a:t>
             </a:fld>
             <a:endParaRPr lang="en-GB"/>
           </a:p>
@@ -10174,7 +10174,7 @@
           <a:p>
             <a:fld id="{67D7B363-7FE0-4B5C-AA52-4AB00EFF9418}" type="datetime1">
               <a:rPr lang="en-GB" smtClean="0"/>
-              <a:t>24/09/2026</a:t>
+              <a:t>25/09/2026</a:t>
             </a:fld>
             <a:endParaRPr lang="en-GB"/>
           </a:p>
@@ -10384,7 +10384,7 @@
           <a:p>
             <a:fld id="{F698CEA5-3A39-49A5-9435-4C2F63733D59}" type="datetime1">
               <a:rPr lang="en-GB" smtClean="0"/>
-              <a:t>24/09/2026</a:t>
+              <a:t>25/09/2026</a:t>
             </a:fld>
             <a:endParaRPr lang="en-GB"/>
           </a:p>
@@ -10595,7 +10595,7 @@
           <a:p>
             <a:fld id="{BEDB2B52-634B-4FE3-9CB1-4F17872ECC19}" type="datetime1">
               <a:rPr lang="en-GB" smtClean="0"/>
-              <a:t>24/09/2026</a:t>
+              <a:t>25/09/2026</a:t>
             </a:fld>
             <a:endParaRPr lang="en-GB"/>
           </a:p>
@@ -10925,7 +10925,7 @@
           <a:p>
             <a:fld id="{3BEE3078-4A4A-48DB-9B9A-38CD660D0699}" type="datetime1">
               <a:rPr lang="en-GB" smtClean="0"/>
-              <a:t>24/09/2026</a:t>
+              <a:t>25/09/2026</a:t>
             </a:fld>
             <a:endParaRPr lang="en-GB"/>
           </a:p>
@@ -11193,7 +11193,7 @@
           <a:p>
             <a:fld id="{061736D3-8CB9-4B1F-9FA0-8A791D30583C}" type="datetime1">
               <a:rPr lang="en-GB" smtClean="0"/>
-              <a:t>24/09/2026</a:t>
+              <a:t>25/09/2026</a:t>
             </a:fld>
             <a:endParaRPr lang="en-GB"/>
           </a:p>
@@ -11608,7 +11608,7 @@
           <a:p>
             <a:fld id="{12B9BA19-C9B8-4135-BA9F-D058BE5FC515}" type="datetime1">
               <a:rPr lang="en-GB" smtClean="0"/>
-              <a:t>24/09/2026</a:t>
+              <a:t>25/09/2026</a:t>
             </a:fld>
             <a:endParaRPr lang="en-GB"/>
           </a:p>
@@ -11750,7 +11750,7 @@
           <a:p>
             <a:fld id="{70D2F5E2-01C2-44C9-AD10-BDEB53FACCEB}" type="datetime1">
               <a:rPr lang="en-GB" smtClean="0"/>
-              <a:t>24/09/2026</a:t>
+              <a:t>25/09/2026</a:t>
             </a:fld>
             <a:endParaRPr lang="en-GB"/>
           </a:p>
@@ -11863,7 +11863,7 @@
           <a:p>
             <a:fld id="{3981DE2F-7974-482C-8DDA-7054DC5FECDD}" type="datetime1">
               <a:rPr lang="en-GB" smtClean="0"/>
-              <a:t>24/09/2026</a:t>
+              <a:t>25/09/2026</a:t>
             </a:fld>
             <a:endParaRPr lang="en-GB"/>
           </a:p>
@@ -12176,7 +12176,7 @@
           <a:p>
             <a:fld id="{75D3A193-B0C6-4186-B10B-252811725895}" type="datetime1">
               <a:rPr lang="en-GB" smtClean="0"/>
-              <a:t>24/09/2026</a:t>
+              <a:t>25/09/2026</a:t>
             </a:fld>
             <a:endParaRPr lang="en-GB"/>
           </a:p>
@@ -12465,7 +12465,7 @@
           <a:p>
             <a:fld id="{1D98AAE4-9F8F-4873-A5CF-52F66B567CFA}" type="datetime1">
               <a:rPr lang="en-GB" smtClean="0"/>
-              <a:t>24/09/2026</a:t>
+              <a:t>25/09/2026</a:t>
             </a:fld>
             <a:endParaRPr lang="en-GB"/>
           </a:p>
@@ -12708,7 +12708,7 @@
           <a:p>
             <a:fld id="{F6017F57-0928-4AB4-9227-68A9D0F44877}" type="datetime1">
               <a:rPr lang="en-GB" smtClean="0"/>
-              <a:t>24/09/2026</a:t>
+              <a:t>25/09/2026</a:t>
             </a:fld>
             <a:endParaRPr lang="en-GB"/>
           </a:p>
@@ -24124,7 +24124,43 @@
                 </a:solidFill>
                 <a:latin typeface="Aptos" panose="020B0004020202020204" pitchFamily="34" charset="0"/>
               </a:rPr>
-              <a:t>The same memory instance may be used (shared) by two or more call sites, if those call sites don’t execute at the same time (execution doesn’t overlap). This is what “Shared” refers to.</a:t>
+              <a:t>The same memory instance may be used (shared) by two or more call sites, if those call sites don’t execute at the same time (execution doesn’t overlap). This is </a:t>
+            </a:r>
+            <a:r>
+              <a:rPr lang="en-GB" sz="2000">
+                <a:solidFill>
+                  <a:srgbClr val="003B66"/>
+                </a:solidFill>
+                <a:latin typeface="Aptos" panose="020B0004020202020204" pitchFamily="34" charset="0"/>
+              </a:rPr>
+              <a:t>what </a:t>
+            </a:r>
+            <a:r>
+              <a:rPr lang="en-GB" sz="2000" b="1">
+                <a:solidFill>
+                  <a:srgbClr val="003B66"/>
+                </a:solidFill>
+                <a:latin typeface="Aptos" panose="020B0004020202020204" pitchFamily="34" charset="0"/>
+              </a:rPr>
+              <a:t>Shared</a:t>
+            </a:r>
+            <a:r>
+              <a:rPr lang="en-GB" sz="2000">
+                <a:solidFill>
+                  <a:srgbClr val="003B66"/>
+                </a:solidFill>
+                <a:latin typeface="Aptos" panose="020B0004020202020204" pitchFamily="34" charset="0"/>
+              </a:rPr>
+              <a:t> </a:t>
+            </a:r>
+            <a:r>
+              <a:rPr lang="en-GB" sz="2000" dirty="0">
+                <a:solidFill>
+                  <a:srgbClr val="003B66"/>
+                </a:solidFill>
+                <a:latin typeface="Aptos" panose="020B0004020202020204" pitchFamily="34" charset="0"/>
+              </a:rPr>
+              <a:t>refers to.</a:t>
             </a:r>
           </a:p>
           <a:p>

</xml_diff>